<commit_message>
Add Label Studio comparison slides to the presentation
Two new slides after the three problem/solution slides: what Label
Studio offers for audio annotation (built-in ASR/transcription
template, flexible import/export, built-in annotator agreement — the
NVIDIA/NeMo parallel to our own STT workflow), and an honest side-by-side
of stack and cost against Prodigy. The real point: the role/review
features we already use are the paid tier on both sides, so this isn't
a simple "free vs $490" comparison. Closing slide now lists this as a
fourth, non-blocking discussion item. Figures (Prodigy $490/seat,
Label Studio Community free / Enterprise quote-based) are sourced from
public docs/pricing pages, not invented.

Co-Authored-By: Claude Sonnet 5 <noreply@anthropic.com>
Claude-Session: https://claude.ai/code/session_01UidobC2wtxq4gpGxwXtsNU
</commit_message>
<xml_diff>
--- a/presentation/Kaspi-Markup-presentation.pptx
+++ b/presentation/Kaspi-Markup-presentation.pptx
@@ -11,9 +11,11 @@
     <p:sldId id="259" r:id="rId5"/>
     <p:sldId id="260" r:id="rId6"/>
     <p:sldId id="261" r:id="rId7"/>
+    <p:sldId id="262" r:id="rId8"/>
+    <p:sldId id="263" r:id="rId9"/>
   </p:sldIdLst>
   <p:notesMasterIdLst>
-    <p:notesMasterId r:id="rId8"/>
+    <p:notesMasterId r:id="rId10"/>
   </p:notesMasterIdLst>
   <p:sldSz cx="12192000" cy="6858000"/>
   <p:notesSz cx="6858000" cy="12192000"/>
@@ -971,6 +973,182 @@
             <a:fld id="{F7021451-1387-4CA6-816F-3879F97B5CBC}" type="slidenum">
               <a:rPr lang="en-US"/>
               <a:t>6</a:t>
+            </a:fld>
+            <a:endParaRPr lang="en-US"/>
+          </a:p>
+        </p:txBody>
+      </p:sp>
+    </p:spTree>
+    <p:extLst>
+      <p:ext uri="{BB962C8B-B14F-4D97-AF65-F5344CB8AC3E}">
+        <p14:creationId xmlns:p14="http://schemas.microsoft.com/office/powerpoint/2010/main" val="1024086991"/>
+      </p:ext>
+    </p:extLst>
+  </p:cSld>
+  <p:clrMapOvr>
+    <a:masterClrMapping/>
+  </p:clrMapOvr>
+</p:notes>
+</file>
+
+<file path=ppt/notesSlides/notesSlide7.xml><?xml version="1.0" encoding="utf-8"?>
+<p:notes xmlns:a="http://schemas.openxmlformats.org/drawingml/2006/main" xmlns:r="http://schemas.openxmlformats.org/officeDocument/2006/relationships" xmlns:p="http://schemas.openxmlformats.org/presentationml/2006/main">
+  <p:cSld>
+    <p:spTree>
+      <p:nvGrpSpPr>
+        <p:cNvPr id="1" name=""/>
+        <p:cNvGrpSpPr/>
+        <p:nvPr/>
+      </p:nvGrpSpPr>
+      <p:grpSpPr>
+        <a:xfrm>
+          <a:off x="0" y="0"/>
+          <a:ext cx="0" cy="0"/>
+          <a:chOff x="0" y="0"/>
+          <a:chExt cx="0" cy="0"/>
+        </a:xfrm>
+      </p:grpSpPr>
+      <p:sp>
+        <p:nvSpPr>
+          <p:cNvPr id="2" name="Slide Image Placeholder 1"/>
+          <p:cNvSpPr>
+            <a:spLocks noGrp="1" noRot="1" noChangeAspect="1"/>
+          </p:cNvSpPr>
+          <p:nvPr>
+            <p:ph type="sldImg"/>
+          </p:nvPr>
+        </p:nvSpPr>
+        <p:spPr/>
+      </p:sp>
+      <p:sp>
+        <p:nvSpPr>
+          <p:cNvPr id="3" name="Notes Placeholder 2"/>
+          <p:cNvSpPr>
+            <a:spLocks noGrp="1"/>
+          </p:cNvSpPr>
+          <p:nvPr>
+            <p:ph type="body" idx="1"/>
+          </p:nvPr>
+        </p:nvSpPr>
+        <p:spPr/>
+        <p:txBody>
+          <a:bodyPr/>
+          <a:lstStyle/>
+          <a:p>
+            <a:r>
+              <a:rPr lang="en-US" dirty="0"/>
+              <a:t/>
+            </a:r>
+            <a:endParaRPr lang="en-US" dirty="0"/>
+          </a:p>
+        </p:txBody>
+      </p:sp>
+      <p:sp>
+        <p:nvSpPr>
+          <p:cNvPr id="4" name="Slide Number Placeholder 3"/>
+          <p:cNvSpPr>
+            <a:spLocks noGrp="1"/>
+          </p:cNvSpPr>
+          <p:nvPr>
+            <p:ph type="sldNum" sz="quarter" idx="10"/>
+          </p:nvPr>
+        </p:nvSpPr>
+        <p:spPr/>
+        <p:txBody>
+          <a:bodyPr/>
+          <a:lstStyle/>
+          <a:p>
+            <a:fld id="{F7021451-1387-4CA6-816F-3879F97B5CBC}" type="slidenum">
+              <a:rPr lang="en-US"/>
+              <a:t>7</a:t>
+            </a:fld>
+            <a:endParaRPr lang="en-US"/>
+          </a:p>
+        </p:txBody>
+      </p:sp>
+    </p:spTree>
+    <p:extLst>
+      <p:ext uri="{BB962C8B-B14F-4D97-AF65-F5344CB8AC3E}">
+        <p14:creationId xmlns:p14="http://schemas.microsoft.com/office/powerpoint/2010/main" val="1024086991"/>
+      </p:ext>
+    </p:extLst>
+  </p:cSld>
+  <p:clrMapOvr>
+    <a:masterClrMapping/>
+  </p:clrMapOvr>
+</p:notes>
+</file>
+
+<file path=ppt/notesSlides/notesSlide8.xml><?xml version="1.0" encoding="utf-8"?>
+<p:notes xmlns:a="http://schemas.openxmlformats.org/drawingml/2006/main" xmlns:r="http://schemas.openxmlformats.org/officeDocument/2006/relationships" xmlns:p="http://schemas.openxmlformats.org/presentationml/2006/main">
+  <p:cSld>
+    <p:spTree>
+      <p:nvGrpSpPr>
+        <p:cNvPr id="1" name=""/>
+        <p:cNvGrpSpPr/>
+        <p:nvPr/>
+      </p:nvGrpSpPr>
+      <p:grpSpPr>
+        <a:xfrm>
+          <a:off x="0" y="0"/>
+          <a:ext cx="0" cy="0"/>
+          <a:chOff x="0" y="0"/>
+          <a:chExt cx="0" cy="0"/>
+        </a:xfrm>
+      </p:grpSpPr>
+      <p:sp>
+        <p:nvSpPr>
+          <p:cNvPr id="2" name="Slide Image Placeholder 1"/>
+          <p:cNvSpPr>
+            <a:spLocks noGrp="1" noRot="1" noChangeAspect="1"/>
+          </p:cNvSpPr>
+          <p:nvPr>
+            <p:ph type="sldImg"/>
+          </p:nvPr>
+        </p:nvSpPr>
+        <p:spPr/>
+      </p:sp>
+      <p:sp>
+        <p:nvSpPr>
+          <p:cNvPr id="3" name="Notes Placeholder 2"/>
+          <p:cNvSpPr>
+            <a:spLocks noGrp="1"/>
+          </p:cNvSpPr>
+          <p:nvPr>
+            <p:ph type="body" idx="1"/>
+          </p:nvPr>
+        </p:nvSpPr>
+        <p:spPr/>
+        <p:txBody>
+          <a:bodyPr/>
+          <a:lstStyle/>
+          <a:p>
+            <a:r>
+              <a:rPr lang="en-US" dirty="0"/>
+              <a:t/>
+            </a:r>
+            <a:endParaRPr lang="en-US" dirty="0"/>
+          </a:p>
+        </p:txBody>
+      </p:sp>
+      <p:sp>
+        <p:nvSpPr>
+          <p:cNvPr id="4" name="Slide Number Placeholder 3"/>
+          <p:cNvSpPr>
+            <a:spLocks noGrp="1"/>
+          </p:cNvSpPr>
+          <p:nvPr>
+            <p:ph type="sldNum" sz="quarter" idx="10"/>
+          </p:nvPr>
+        </p:nvSpPr>
+        <p:spPr/>
+        <p:txBody>
+          <a:bodyPr/>
+          <a:lstStyle/>
+          <a:p>
+            <a:fld id="{F7021451-1387-4CA6-816F-3879F97B5CBC}" type="slidenum">
+              <a:rPr lang="en-US"/>
+              <a:t>8</a:t>
             </a:fld>
             <a:endParaRPr lang="en-US"/>
           </a:p>
@@ -4226,6 +4404,1969 @@
     <p:bg>
       <p:bgPr>
         <a:solidFill>
+          <a:srgbClr val="ECEEF1"/>
+        </a:solidFill>
+      </p:bgPr>
+    </p:bg>
+    <p:spTree>
+      <p:nvGrpSpPr>
+        <p:cNvPr id="1" name=""/>
+        <p:cNvGrpSpPr/>
+        <p:nvPr/>
+      </p:nvGrpSpPr>
+      <p:grpSpPr>
+        <a:xfrm>
+          <a:off x="0" y="0"/>
+          <a:ext cx="0" cy="0"/>
+          <a:chOff x="0" y="0"/>
+          <a:chExt cx="0" cy="0"/>
+        </a:xfrm>
+      </p:grpSpPr>
+      <p:sp>
+        <p:nvSpPr>
+          <p:cNvPr id="2" name="Text 0"/>
+          <p:cNvSpPr txBox="1"/>
+          <p:nvPr/>
+        </p:nvSpPr>
+        <p:spPr>
+          <a:xfrm>
+            <a:off x="640080" y="457200"/>
+            <a:ext cx="8229600" cy="274320"/>
+          </a:xfrm>
+          <a:prstGeom prst="rect">
+            <a:avLst/>
+          </a:prstGeom>
+          <a:noFill/>
+          <a:ln/>
+        </p:spPr>
+        <p:txBody>
+          <a:bodyPr wrap="square" lIns="0" tIns="0" rIns="0" bIns="0" rtlCol="0" anchor="ctr"/>
+          <a:lstStyle/>
+          <a:p>
+            <a:pPr indent="0" marL="0">
+              <a:buNone/>
+            </a:pPr>
+            <a:r>
+              <a:rPr lang="en-US" sz="1100" b="1" spc="200" kern="0" dirty="0">
+                <a:solidFill>
+                  <a:srgbClr val="F14635"/>
+                </a:solidFill>
+                <a:latin typeface="Calibri" pitchFamily="34" charset="0"/>
+                <a:ea typeface="Calibri" pitchFamily="34" charset="-122"/>
+                <a:cs typeface="Calibri" pitchFamily="34" charset="-120"/>
+              </a:rPr>
+              <a:t>ОТДЕЛЬНЫЙ ВОПРОС — НЕ СРОЧНО</a:t>
+            </a:r>
+            <a:endParaRPr lang="en-US" sz="1100" dirty="0"/>
+          </a:p>
+        </p:txBody>
+      </p:sp>
+      <p:sp>
+        <p:nvSpPr>
+          <p:cNvPr id="3" name="Text 1"/>
+          <p:cNvSpPr txBox="1"/>
+          <p:nvPr/>
+        </p:nvSpPr>
+        <p:spPr>
+          <a:xfrm>
+            <a:off x="594360" y="749808"/>
+            <a:ext cx="10881360" cy="548640"/>
+          </a:xfrm>
+          <a:prstGeom prst="rect">
+            <a:avLst/>
+          </a:prstGeom>
+          <a:noFill/>
+          <a:ln/>
+        </p:spPr>
+        <p:txBody>
+          <a:bodyPr wrap="square" lIns="0" tIns="0" rIns="0" bIns="0" rtlCol="0" anchor="ctr"/>
+          <a:lstStyle/>
+          <a:p>
+            <a:pPr indent="0" marL="0">
+              <a:buNone/>
+            </a:pPr>
+            <a:r>
+              <a:rPr lang="en-US" sz="2600" b="1" dirty="0">
+                <a:solidFill>
+                  <a:srgbClr val="1C2333"/>
+                </a:solidFill>
+                <a:latin typeface="Cambria" pitchFamily="34" charset="0"/>
+                <a:ea typeface="Cambria" pitchFamily="34" charset="-122"/>
+                <a:cs typeface="Cambria" pitchFamily="34" charset="-120"/>
+              </a:rPr>
+              <a:t>Label Studio — реальная альтернатива, если понадобится</a:t>
+            </a:r>
+            <a:endParaRPr lang="en-US" sz="2600" dirty="0"/>
+          </a:p>
+        </p:txBody>
+      </p:sp>
+      <p:sp>
+        <p:nvSpPr>
+          <p:cNvPr id="4" name="Shape 2"/>
+          <p:cNvSpPr/>
+          <p:nvPr/>
+        </p:nvSpPr>
+        <p:spPr>
+          <a:xfrm>
+            <a:off x="640080" y="1691640"/>
+            <a:ext cx="3429000" cy="2331720"/>
+          </a:xfrm>
+          <a:prstGeom prst="roundRect">
+            <a:avLst>
+              <a:gd name="adj" fmla="val 3922"/>
+            </a:avLst>
+          </a:prstGeom>
+          <a:solidFill>
+            <a:srgbClr val="FFFFFF"/>
+          </a:solidFill>
+          <a:ln w="12700">
+            <a:solidFill>
+              <a:srgbClr val="DDE1E7"/>
+            </a:solidFill>
+            <a:prstDash val="solid"/>
+          </a:ln>
+          <a:effectLst>
+            <a:outerShdw sx="100000" sy="100000" kx="0" ky="0" algn="bl" rotWithShape="0" blurRad="76200" dist="25400" dir="5400000">
+              <a:srgbClr val="1C2333">
+                <a:alpha val="12000"/>
+              </a:srgbClr>
+            </a:outerShdw>
+          </a:effectLst>
+        </p:spPr>
+      </p:sp>
+      <p:sp>
+        <p:nvSpPr>
+          <p:cNvPr id="5" name="Shape 3"/>
+          <p:cNvSpPr/>
+          <p:nvPr/>
+        </p:nvSpPr>
+        <p:spPr>
+          <a:xfrm>
+            <a:off x="914400" y="1965960"/>
+            <a:ext cx="402336" cy="402336"/>
+          </a:xfrm>
+          <a:prstGeom prst="ellipse">
+            <a:avLst/>
+          </a:prstGeom>
+          <a:solidFill>
+            <a:srgbClr val="22C55E"/>
+          </a:solidFill>
+          <a:ln/>
+        </p:spPr>
+      </p:sp>
+      <p:sp>
+        <p:nvSpPr>
+          <p:cNvPr id="6" name="Text 4"/>
+          <p:cNvSpPr txBox="1"/>
+          <p:nvPr/>
+        </p:nvSpPr>
+        <p:spPr>
+          <a:xfrm>
+            <a:off x="914400" y="1965960"/>
+            <a:ext cx="402336" cy="402336"/>
+          </a:xfrm>
+          <a:prstGeom prst="rect">
+            <a:avLst/>
+          </a:prstGeom>
+          <a:noFill/>
+          <a:ln/>
+        </p:spPr>
+        <p:txBody>
+          <a:bodyPr wrap="square" lIns="0" tIns="0" rIns="0" bIns="0" rtlCol="0" anchor="ctr"/>
+          <a:lstStyle/>
+          <a:p>
+            <a:pPr algn="ctr" indent="0" marL="0">
+              <a:buNone/>
+            </a:pPr>
+            <a:r>
+              <a:rPr lang="en-US" sz="1800" b="1" dirty="0">
+                <a:solidFill>
+                  <a:srgbClr val="FFFFFF"/>
+                </a:solidFill>
+                <a:latin typeface="Cambria" pitchFamily="34" charset="0"/>
+                <a:ea typeface="Cambria" pitchFamily="34" charset="-122"/>
+                <a:cs typeface="Cambria" pitchFamily="34" charset="-120"/>
+              </a:rPr>
+              <a:t>1</a:t>
+            </a:r>
+            <a:endParaRPr lang="en-US" sz="1800" dirty="0"/>
+          </a:p>
+        </p:txBody>
+      </p:sp>
+      <p:sp>
+        <p:nvSpPr>
+          <p:cNvPr id="7" name="Text 5"/>
+          <p:cNvSpPr txBox="1"/>
+          <p:nvPr/>
+        </p:nvSpPr>
+        <p:spPr>
+          <a:xfrm>
+            <a:off x="914400" y="2560320"/>
+            <a:ext cx="2880360" cy="640080"/>
+          </a:xfrm>
+          <a:prstGeom prst="rect">
+            <a:avLst/>
+          </a:prstGeom>
+          <a:noFill/>
+          <a:ln/>
+        </p:spPr>
+        <p:txBody>
+          <a:bodyPr wrap="square" lIns="0" tIns="0" rIns="0" bIns="0" rtlCol="0" anchor="ctr"/>
+          <a:lstStyle/>
+          <a:p>
+            <a:pPr indent="0" marL="0">
+              <a:lnSpc>
+                <a:spcPct val="110000"/>
+              </a:lnSpc>
+              <a:buNone/>
+            </a:pPr>
+            <a:r>
+              <a:rPr lang="en-US" sz="1600" b="1" dirty="0">
+                <a:solidFill>
+                  <a:srgbClr val="1C2333"/>
+                </a:solidFill>
+                <a:latin typeface="Cambria" pitchFamily="34" charset="0"/>
+                <a:ea typeface="Cambria" pitchFamily="34" charset="-122"/>
+                <a:cs typeface="Cambria" pitchFamily="34" charset="-120"/>
+              </a:rPr>
+              <a:t>Аудио — из коробки</a:t>
+            </a:r>
+            <a:endParaRPr lang="en-US" sz="1600" dirty="0"/>
+          </a:p>
+        </p:txBody>
+      </p:sp>
+      <p:sp>
+        <p:nvSpPr>
+          <p:cNvPr id="8" name="Text 6"/>
+          <p:cNvSpPr txBox="1"/>
+          <p:nvPr/>
+        </p:nvSpPr>
+        <p:spPr>
+          <a:xfrm>
+            <a:off x="914400" y="3108960"/>
+            <a:ext cx="2880360" cy="822960"/>
+          </a:xfrm>
+          <a:prstGeom prst="rect">
+            <a:avLst/>
+          </a:prstGeom>
+          <a:noFill/>
+          <a:ln/>
+        </p:spPr>
+        <p:txBody>
+          <a:bodyPr wrap="square" lIns="0" tIns="0" rIns="0" bIns="0" rtlCol="0" anchor="ctr"/>
+          <a:lstStyle/>
+          <a:p>
+            <a:pPr indent="0" marL="0">
+              <a:lnSpc>
+                <a:spcPct val="120000"/>
+              </a:lnSpc>
+              <a:buNone/>
+            </a:pPr>
+            <a:r>
+              <a:rPr lang="en-US" sz="1150" dirty="0">
+                <a:solidFill>
+                  <a:srgbClr val="6B7280"/>
+                </a:solidFill>
+                <a:latin typeface="Calibri" pitchFamily="34" charset="0"/>
+                <a:ea typeface="Calibri" pitchFamily="34" charset="-122"/>
+                <a:cs typeface="Calibri" pitchFamily="34" charset="-120"/>
+              </a:rPr>
+              <a:t>Готовый шаблон Audio Transcription: плеер + поле транскрипции, ничего собирать не нужно.</a:t>
+            </a:r>
+            <a:endParaRPr lang="en-US" sz="1150" dirty="0"/>
+          </a:p>
+        </p:txBody>
+      </p:sp>
+      <p:sp>
+        <p:nvSpPr>
+          <p:cNvPr id="9" name="Shape 7"/>
+          <p:cNvSpPr/>
+          <p:nvPr/>
+        </p:nvSpPr>
+        <p:spPr>
+          <a:xfrm>
+            <a:off x="4389120" y="1691640"/>
+            <a:ext cx="3429000" cy="2331720"/>
+          </a:xfrm>
+          <a:prstGeom prst="roundRect">
+            <a:avLst>
+              <a:gd name="adj" fmla="val 3922"/>
+            </a:avLst>
+          </a:prstGeom>
+          <a:solidFill>
+            <a:srgbClr val="FFFFFF"/>
+          </a:solidFill>
+          <a:ln w="12700">
+            <a:solidFill>
+              <a:srgbClr val="DDE1E7"/>
+            </a:solidFill>
+            <a:prstDash val="solid"/>
+          </a:ln>
+          <a:effectLst>
+            <a:outerShdw sx="100000" sy="100000" kx="0" ky="0" algn="bl" rotWithShape="0" blurRad="76200" dist="25400" dir="5400000">
+              <a:srgbClr val="1C2333">
+                <a:alpha val="12000"/>
+              </a:srgbClr>
+            </a:outerShdw>
+          </a:effectLst>
+        </p:spPr>
+      </p:sp>
+      <p:sp>
+        <p:nvSpPr>
+          <p:cNvPr id="10" name="Shape 8"/>
+          <p:cNvSpPr/>
+          <p:nvPr/>
+        </p:nvSpPr>
+        <p:spPr>
+          <a:xfrm>
+            <a:off x="4663440" y="1965960"/>
+            <a:ext cx="402336" cy="402336"/>
+          </a:xfrm>
+          <a:prstGeom prst="ellipse">
+            <a:avLst/>
+          </a:prstGeom>
+          <a:solidFill>
+            <a:srgbClr val="22C55E"/>
+          </a:solidFill>
+          <a:ln/>
+        </p:spPr>
+      </p:sp>
+      <p:sp>
+        <p:nvSpPr>
+          <p:cNvPr id="11" name="Text 9"/>
+          <p:cNvSpPr txBox="1"/>
+          <p:nvPr/>
+        </p:nvSpPr>
+        <p:spPr>
+          <a:xfrm>
+            <a:off x="4663440" y="1965960"/>
+            <a:ext cx="402336" cy="402336"/>
+          </a:xfrm>
+          <a:prstGeom prst="rect">
+            <a:avLst/>
+          </a:prstGeom>
+          <a:noFill/>
+          <a:ln/>
+        </p:spPr>
+        <p:txBody>
+          <a:bodyPr wrap="square" lIns="0" tIns="0" rIns="0" bIns="0" rtlCol="0" anchor="ctr"/>
+          <a:lstStyle/>
+          <a:p>
+            <a:pPr algn="ctr" indent="0" marL="0">
+              <a:buNone/>
+            </a:pPr>
+            <a:r>
+              <a:rPr lang="en-US" sz="1800" b="1" dirty="0">
+                <a:solidFill>
+                  <a:srgbClr val="FFFFFF"/>
+                </a:solidFill>
+                <a:latin typeface="Cambria" pitchFamily="34" charset="0"/>
+                <a:ea typeface="Cambria" pitchFamily="34" charset="-122"/>
+                <a:cs typeface="Cambria" pitchFamily="34" charset="-120"/>
+              </a:rPr>
+              <a:t>2</a:t>
+            </a:r>
+            <a:endParaRPr lang="en-US" sz="1800" dirty="0"/>
+          </a:p>
+        </p:txBody>
+      </p:sp>
+      <p:sp>
+        <p:nvSpPr>
+          <p:cNvPr id="12" name="Text 10"/>
+          <p:cNvSpPr txBox="1"/>
+          <p:nvPr/>
+        </p:nvSpPr>
+        <p:spPr>
+          <a:xfrm>
+            <a:off x="4663440" y="2560320"/>
+            <a:ext cx="2880360" cy="640080"/>
+          </a:xfrm>
+          <a:prstGeom prst="rect">
+            <a:avLst/>
+          </a:prstGeom>
+          <a:noFill/>
+          <a:ln/>
+        </p:spPr>
+        <p:txBody>
+          <a:bodyPr wrap="square" lIns="0" tIns="0" rIns="0" bIns="0" rtlCol="0" anchor="ctr"/>
+          <a:lstStyle/>
+          <a:p>
+            <a:pPr indent="0" marL="0">
+              <a:lnSpc>
+                <a:spcPct val="110000"/>
+              </a:lnSpc>
+              <a:buNone/>
+            </a:pPr>
+            <a:r>
+              <a:rPr lang="en-US" sz="1600" b="1" dirty="0">
+                <a:solidFill>
+                  <a:srgbClr val="1C2333"/>
+                </a:solidFill>
+                <a:latin typeface="Cambria" pitchFamily="34" charset="0"/>
+                <a:ea typeface="Cambria" pitchFamily="34" charset="-122"/>
+                <a:cs typeface="Cambria" pitchFamily="34" charset="-120"/>
+              </a:rPr>
+              <a:t>Свои данные, свой экспорт</a:t>
+            </a:r>
+            <a:endParaRPr lang="en-US" sz="1600" dirty="0"/>
+          </a:p>
+        </p:txBody>
+      </p:sp>
+      <p:sp>
+        <p:nvSpPr>
+          <p:cNvPr id="13" name="Text 11"/>
+          <p:cNvSpPr txBox="1"/>
+          <p:nvPr/>
+        </p:nvSpPr>
+        <p:spPr>
+          <a:xfrm>
+            <a:off x="4663440" y="3108960"/>
+            <a:ext cx="2880360" cy="822960"/>
+          </a:xfrm>
+          <a:prstGeom prst="rect">
+            <a:avLst/>
+          </a:prstGeom>
+          <a:noFill/>
+          <a:ln/>
+        </p:spPr>
+        <p:txBody>
+          <a:bodyPr wrap="square" lIns="0" tIns="0" rIns="0" bIns="0" rtlCol="0" anchor="ctr"/>
+          <a:lstStyle/>
+          <a:p>
+            <a:pPr indent="0" marL="0">
+              <a:lnSpc>
+                <a:spcPct val="120000"/>
+              </a:lnSpc>
+              <a:buNone/>
+            </a:pPr>
+            <a:r>
+              <a:rPr lang="en-US" sz="1150" dirty="0">
+                <a:solidFill>
+                  <a:srgbClr val="6B7280"/>
+                </a:solidFill>
+                <a:latin typeface="Calibri" pitchFamily="34" charset="0"/>
+                <a:ea typeface="Calibri" pitchFamily="34" charset="-122"/>
+                <a:cs typeface="Calibri" pitchFamily="34" charset="-120"/>
+              </a:rPr>
+              <a:t>Импорт из CSV/JSON/облака, экспорт в JSON/CSV — данные не заперты внутри системы.</a:t>
+            </a:r>
+            <a:endParaRPr lang="en-US" sz="1150" dirty="0"/>
+          </a:p>
+        </p:txBody>
+      </p:sp>
+      <p:sp>
+        <p:nvSpPr>
+          <p:cNvPr id="14" name="Shape 12"/>
+          <p:cNvSpPr/>
+          <p:nvPr/>
+        </p:nvSpPr>
+        <p:spPr>
+          <a:xfrm>
+            <a:off x="8138160" y="1691640"/>
+            <a:ext cx="3429000" cy="2331720"/>
+          </a:xfrm>
+          <a:prstGeom prst="roundRect">
+            <a:avLst>
+              <a:gd name="adj" fmla="val 3922"/>
+            </a:avLst>
+          </a:prstGeom>
+          <a:solidFill>
+            <a:srgbClr val="FFFFFF"/>
+          </a:solidFill>
+          <a:ln w="12700">
+            <a:solidFill>
+              <a:srgbClr val="DDE1E7"/>
+            </a:solidFill>
+            <a:prstDash val="solid"/>
+          </a:ln>
+          <a:effectLst>
+            <a:outerShdw sx="100000" sy="100000" kx="0" ky="0" algn="bl" rotWithShape="0" blurRad="76200" dist="25400" dir="5400000">
+              <a:srgbClr val="1C2333">
+                <a:alpha val="12000"/>
+              </a:srgbClr>
+            </a:outerShdw>
+          </a:effectLst>
+        </p:spPr>
+      </p:sp>
+      <p:sp>
+        <p:nvSpPr>
+          <p:cNvPr id="15" name="Shape 13"/>
+          <p:cNvSpPr/>
+          <p:nvPr/>
+        </p:nvSpPr>
+        <p:spPr>
+          <a:xfrm>
+            <a:off x="8412480" y="1965960"/>
+            <a:ext cx="402336" cy="402336"/>
+          </a:xfrm>
+          <a:prstGeom prst="ellipse">
+            <a:avLst/>
+          </a:prstGeom>
+          <a:solidFill>
+            <a:srgbClr val="22C55E"/>
+          </a:solidFill>
+          <a:ln/>
+        </p:spPr>
+      </p:sp>
+      <p:sp>
+        <p:nvSpPr>
+          <p:cNvPr id="16" name="Text 14"/>
+          <p:cNvSpPr txBox="1"/>
+          <p:nvPr/>
+        </p:nvSpPr>
+        <p:spPr>
+          <a:xfrm>
+            <a:off x="8412480" y="1965960"/>
+            <a:ext cx="402336" cy="402336"/>
+          </a:xfrm>
+          <a:prstGeom prst="rect">
+            <a:avLst/>
+          </a:prstGeom>
+          <a:noFill/>
+          <a:ln/>
+        </p:spPr>
+        <p:txBody>
+          <a:bodyPr wrap="square" lIns="0" tIns="0" rIns="0" bIns="0" rtlCol="0" anchor="ctr"/>
+          <a:lstStyle/>
+          <a:p>
+            <a:pPr algn="ctr" indent="0" marL="0">
+              <a:buNone/>
+            </a:pPr>
+            <a:r>
+              <a:rPr lang="en-US" sz="1800" b="1" dirty="0">
+                <a:solidFill>
+                  <a:srgbClr val="FFFFFF"/>
+                </a:solidFill>
+                <a:latin typeface="Cambria" pitchFamily="34" charset="0"/>
+                <a:ea typeface="Cambria" pitchFamily="34" charset="-122"/>
+                <a:cs typeface="Cambria" pitchFamily="34" charset="-120"/>
+              </a:rPr>
+              <a:t>3</a:t>
+            </a:r>
+            <a:endParaRPr lang="en-US" sz="1800" dirty="0"/>
+          </a:p>
+        </p:txBody>
+      </p:sp>
+      <p:sp>
+        <p:nvSpPr>
+          <p:cNvPr id="17" name="Text 15"/>
+          <p:cNvSpPr txBox="1"/>
+          <p:nvPr/>
+        </p:nvSpPr>
+        <p:spPr>
+          <a:xfrm>
+            <a:off x="8412480" y="2560320"/>
+            <a:ext cx="2880360" cy="640080"/>
+          </a:xfrm>
+          <a:prstGeom prst="rect">
+            <a:avLst/>
+          </a:prstGeom>
+          <a:noFill/>
+          <a:ln/>
+        </p:spPr>
+        <p:txBody>
+          <a:bodyPr wrap="square" lIns="0" tIns="0" rIns="0" bIns="0" rtlCol="0" anchor="ctr"/>
+          <a:lstStyle/>
+          <a:p>
+            <a:pPr indent="0" marL="0">
+              <a:lnSpc>
+                <a:spcPct val="110000"/>
+              </a:lnSpc>
+              <a:buNone/>
+            </a:pPr>
+            <a:r>
+              <a:rPr lang="en-US" sz="1600" b="1" dirty="0">
+                <a:solidFill>
+                  <a:srgbClr val="1C2333"/>
+                </a:solidFill>
+                <a:latin typeface="Cambria" pitchFamily="34" charset="0"/>
+                <a:ea typeface="Cambria" pitchFamily="34" charset="-122"/>
+                <a:cs typeface="Cambria" pitchFamily="34" charset="-120"/>
+              </a:rPr>
+              <a:t>Сравнение аннотаторов встроено</a:t>
+            </a:r>
+            <a:endParaRPr lang="en-US" sz="1600" dirty="0"/>
+          </a:p>
+        </p:txBody>
+      </p:sp>
+      <p:sp>
+        <p:nvSpPr>
+          <p:cNvPr id="18" name="Text 16"/>
+          <p:cNvSpPr txBox="1"/>
+          <p:nvPr/>
+        </p:nvSpPr>
+        <p:spPr>
+          <a:xfrm>
+            <a:off x="8412480" y="3108960"/>
+            <a:ext cx="2880360" cy="822960"/>
+          </a:xfrm>
+          <a:prstGeom prst="rect">
+            <a:avLst/>
+          </a:prstGeom>
+          <a:noFill/>
+          <a:ln/>
+        </p:spPr>
+        <p:txBody>
+          <a:bodyPr wrap="square" lIns="0" tIns="0" rIns="0" bIns="0" rtlCol="0" anchor="ctr"/>
+          <a:lstStyle/>
+          <a:p>
+            <a:pPr indent="0" marL="0">
+              <a:lnSpc>
+                <a:spcPct val="120000"/>
+              </a:lnSpc>
+              <a:buNone/>
+            </a:pPr>
+            <a:r>
+              <a:rPr lang="en-US" sz="1150" dirty="0">
+                <a:solidFill>
+                  <a:srgbClr val="6B7280"/>
+                </a:solidFill>
+                <a:latin typeface="Calibri" pitchFamily="34" charset="0"/>
+                <a:ea typeface="Calibri" pitchFamily="34" charset="-122"/>
+                <a:cs typeface="Calibri" pitchFamily="34" charset="-120"/>
+              </a:rPr>
+              <a:t>Есть готовая метрика согласованности (agreement) между разметчиками — то же самое, что делает ваш ассессор.</a:t>
+            </a:r>
+            <a:endParaRPr lang="en-US" sz="1150" dirty="0"/>
+          </a:p>
+        </p:txBody>
+      </p:sp>
+      <p:sp>
+        <p:nvSpPr>
+          <p:cNvPr id="19" name="Shape 17"/>
+          <p:cNvSpPr/>
+          <p:nvPr/>
+        </p:nvSpPr>
+        <p:spPr>
+          <a:xfrm>
+            <a:off x="640080" y="4343400"/>
+            <a:ext cx="10881360" cy="1234440"/>
+          </a:xfrm>
+          <a:prstGeom prst="roundRect">
+            <a:avLst>
+              <a:gd name="adj" fmla="val 7407"/>
+            </a:avLst>
+          </a:prstGeom>
+          <a:solidFill>
+            <a:srgbClr val="1C2333"/>
+          </a:solidFill>
+          <a:ln/>
+        </p:spPr>
+      </p:sp>
+      <p:sp>
+        <p:nvSpPr>
+          <p:cNvPr id="20" name="Text 18"/>
+          <p:cNvSpPr txBox="1"/>
+          <p:nvPr/>
+        </p:nvSpPr>
+        <p:spPr>
+          <a:xfrm>
+            <a:off x="914400" y="4507992"/>
+            <a:ext cx="10241280" cy="274320"/>
+          </a:xfrm>
+          <a:prstGeom prst="rect">
+            <a:avLst/>
+          </a:prstGeom>
+          <a:noFill/>
+          <a:ln/>
+        </p:spPr>
+        <p:txBody>
+          <a:bodyPr wrap="square" lIns="0" tIns="0" rIns="0" bIns="0" rtlCol="0" anchor="ctr"/>
+          <a:lstStyle/>
+          <a:p>
+            <a:pPr indent="0" marL="0">
+              <a:buNone/>
+            </a:pPr>
+            <a:r>
+              <a:rPr lang="en-US" sz="1050" b="1" spc="100" kern="0" dirty="0">
+                <a:solidFill>
+                  <a:srgbClr val="4ADE80"/>
+                </a:solidFill>
+                <a:latin typeface="Calibri" pitchFamily="34" charset="0"/>
+                <a:ea typeface="Calibri" pitchFamily="34" charset="-122"/>
+                <a:cs typeface="Calibri" pitchFamily="34" charset="-120"/>
+              </a:rPr>
+              <a:t>КАК С ЭТИМ СПРАВЛЯЮТСЯ ЗА ГРАНИЦЕЙ</a:t>
+            </a:r>
+            <a:endParaRPr lang="en-US" sz="1050" dirty="0"/>
+          </a:p>
+        </p:txBody>
+      </p:sp>
+      <p:sp>
+        <p:nvSpPr>
+          <p:cNvPr id="21" name="Text 19"/>
+          <p:cNvSpPr txBox="1"/>
+          <p:nvPr/>
+        </p:nvSpPr>
+        <p:spPr>
+          <a:xfrm>
+            <a:off x="914400" y="4782312"/>
+            <a:ext cx="10241280" cy="731520"/>
+          </a:xfrm>
+          <a:prstGeom prst="rect">
+            <a:avLst/>
+          </a:prstGeom>
+          <a:noFill/>
+          <a:ln/>
+        </p:spPr>
+        <p:txBody>
+          <a:bodyPr wrap="square" lIns="0" tIns="0" rIns="0" bIns="0" rtlCol="0" anchor="ctr"/>
+          <a:lstStyle/>
+          <a:p>
+            <a:pPr indent="0" marL="0">
+              <a:lnSpc>
+                <a:spcPct val="125000"/>
+              </a:lnSpc>
+              <a:buNone/>
+            </a:pPr>
+            <a:r>
+              <a:rPr lang="en-US" sz="1250" dirty="0">
+                <a:solidFill>
+                  <a:srgbClr val="E2E8F0"/>
+                </a:solidFill>
+                <a:latin typeface="Calibri" pitchFamily="34" charset="0"/>
+                <a:ea typeface="Calibri" pitchFamily="34" charset="-122"/>
+                <a:cs typeface="Calibri" pitchFamily="34" charset="-120"/>
+              </a:rPr>
+              <a:t>NVIDIA использует Label Studio именно для разметки речи: модель делает черновую транскрипцию (NeMo ASR) → человек проверяет и правит в Label Studio → экспорт для дообучения модели. Практически один в один наш процесс с STT.</a:t>
+            </a:r>
+            <a:endParaRPr lang="en-US" sz="1250" dirty="0"/>
+          </a:p>
+        </p:txBody>
+      </p:sp>
+      <p:sp>
+        <p:nvSpPr>
+          <p:cNvPr id="22" name="Text 20"/>
+          <p:cNvSpPr txBox="1"/>
+          <p:nvPr/>
+        </p:nvSpPr>
+        <p:spPr>
+          <a:xfrm>
+            <a:off x="502920" y="6446520"/>
+            <a:ext cx="2743200" cy="274320"/>
+          </a:xfrm>
+          <a:prstGeom prst="rect">
+            <a:avLst/>
+          </a:prstGeom>
+          <a:noFill/>
+          <a:ln/>
+        </p:spPr>
+        <p:txBody>
+          <a:bodyPr wrap="square" lIns="0" tIns="0" rIns="0" bIns="0" rtlCol="0" anchor="ctr"/>
+          <a:lstStyle/>
+          <a:p>
+            <a:pPr indent="0" marL="0">
+              <a:buNone/>
+            </a:pPr>
+            <a:r>
+              <a:rPr lang="en-US" sz="1050" b="1" dirty="0">
+                <a:solidFill>
+                  <a:srgbClr val="1C2333"/>
+                </a:solidFill>
+                <a:latin typeface="Cambria" pitchFamily="34" charset="0"/>
+                <a:ea typeface="Cambria" pitchFamily="34" charset="-122"/>
+                <a:cs typeface="Cambria" pitchFamily="34" charset="-120"/>
+              </a:rPr>
+              <a:t>Kaspi </a:t>
+            </a:r>
+            <a:pPr indent="0" marL="0">
+              <a:buNone/>
+            </a:pPr>
+            <a:r>
+              <a:rPr lang="en-US" sz="1050" b="1" dirty="0">
+                <a:solidFill>
+                  <a:srgbClr val="F14635"/>
+                </a:solidFill>
+                <a:latin typeface="Cambria" pitchFamily="34" charset="0"/>
+                <a:ea typeface="Cambria" pitchFamily="34" charset="-122"/>
+                <a:cs typeface="Cambria" pitchFamily="34" charset="-120"/>
+              </a:rPr>
+              <a:t>Markup</a:t>
+            </a:r>
+            <a:endParaRPr lang="en-US" sz="1050" dirty="0"/>
+          </a:p>
+        </p:txBody>
+      </p:sp>
+      <p:sp>
+        <p:nvSpPr>
+          <p:cNvPr id="23" name="Text 21"/>
+          <p:cNvSpPr txBox="1"/>
+          <p:nvPr/>
+        </p:nvSpPr>
+        <p:spPr>
+          <a:xfrm>
+            <a:off x="11551615" y="6446520"/>
+            <a:ext cx="457200" cy="274320"/>
+          </a:xfrm>
+          <a:prstGeom prst="rect">
+            <a:avLst/>
+          </a:prstGeom>
+          <a:noFill/>
+          <a:ln/>
+        </p:spPr>
+        <p:txBody>
+          <a:bodyPr wrap="square" lIns="0" tIns="0" rIns="0" bIns="0" rtlCol="0" anchor="ctr"/>
+          <a:lstStyle/>
+          <a:p>
+            <a:pPr algn="r" indent="0" marL="0">
+              <a:buNone/>
+            </a:pPr>
+            <a:r>
+              <a:rPr lang="en-US" sz="1000" dirty="0">
+                <a:solidFill>
+                  <a:srgbClr val="6B7280"/>
+                </a:solidFill>
+                <a:latin typeface="Calibri" pitchFamily="34" charset="0"/>
+                <a:ea typeface="Calibri" pitchFamily="34" charset="-122"/>
+                <a:cs typeface="Calibri" pitchFamily="34" charset="-120"/>
+              </a:rPr>
+              <a:t>06</a:t>
+            </a:r>
+            <a:endParaRPr lang="en-US" sz="1000" dirty="0"/>
+          </a:p>
+        </p:txBody>
+      </p:sp>
+    </p:spTree>
+  </p:cSld>
+  <p:clrMapOvr>
+    <a:masterClrMapping/>
+  </p:clrMapOvr>
+</p:sld>
+</file>
+
+<file path=ppt/slides/slide7.xml><?xml version="1.0" encoding="utf-8"?>
+<p:sld xmlns:a="http://schemas.openxmlformats.org/drawingml/2006/main" xmlns:r="http://schemas.openxmlformats.org/officeDocument/2006/relationships" xmlns:p="http://schemas.openxmlformats.org/presentationml/2006/main">
+  <p:cSld name="Slide 7">
+    <p:bg>
+      <p:bgPr>
+        <a:solidFill>
+          <a:srgbClr val="ECEEF1"/>
+        </a:solidFill>
+      </p:bgPr>
+    </p:bg>
+    <p:spTree>
+      <p:nvGrpSpPr>
+        <p:cNvPr id="1" name=""/>
+        <p:cNvGrpSpPr/>
+        <p:nvPr/>
+      </p:nvGrpSpPr>
+      <p:grpSpPr>
+        <a:xfrm>
+          <a:off x="0" y="0"/>
+          <a:ext cx="0" cy="0"/>
+          <a:chOff x="0" y="0"/>
+          <a:chExt cx="0" cy="0"/>
+        </a:xfrm>
+      </p:grpSpPr>
+      <p:sp>
+        <p:nvSpPr>
+          <p:cNvPr id="2" name="Text 0"/>
+          <p:cNvSpPr txBox="1"/>
+          <p:nvPr/>
+        </p:nvSpPr>
+        <p:spPr>
+          <a:xfrm>
+            <a:off x="640080" y="457200"/>
+            <a:ext cx="8229600" cy="274320"/>
+          </a:xfrm>
+          <a:prstGeom prst="rect">
+            <a:avLst/>
+          </a:prstGeom>
+          <a:noFill/>
+          <a:ln/>
+        </p:spPr>
+        <p:txBody>
+          <a:bodyPr wrap="square" lIns="0" tIns="0" rIns="0" bIns="0" rtlCol="0" anchor="ctr"/>
+          <a:lstStyle/>
+          <a:p>
+            <a:pPr indent="0" marL="0">
+              <a:buNone/>
+            </a:pPr>
+            <a:r>
+              <a:rPr lang="en-US" sz="1100" b="1" spc="200" kern="0" dirty="0">
+                <a:solidFill>
+                  <a:srgbClr val="F14635"/>
+                </a:solidFill>
+                <a:latin typeface="Calibri" pitchFamily="34" charset="0"/>
+                <a:ea typeface="Calibri" pitchFamily="34" charset="-122"/>
+                <a:cs typeface="Calibri" pitchFamily="34" charset="-120"/>
+              </a:rPr>
+              <a:t>СТЕК И СТОИМОСТЬ</a:t>
+            </a:r>
+            <a:endParaRPr lang="en-US" sz="1100" dirty="0"/>
+          </a:p>
+        </p:txBody>
+      </p:sp>
+      <p:sp>
+        <p:nvSpPr>
+          <p:cNvPr id="3" name="Text 1"/>
+          <p:cNvSpPr txBox="1"/>
+          <p:nvPr/>
+        </p:nvSpPr>
+        <p:spPr>
+          <a:xfrm>
+            <a:off x="594360" y="749808"/>
+            <a:ext cx="10881360" cy="548640"/>
+          </a:xfrm>
+          <a:prstGeom prst="rect">
+            <a:avLst/>
+          </a:prstGeom>
+          <a:noFill/>
+          <a:ln/>
+        </p:spPr>
+        <p:txBody>
+          <a:bodyPr wrap="square" lIns="0" tIns="0" rIns="0" bIns="0" rtlCol="0" anchor="ctr"/>
+          <a:lstStyle/>
+          <a:p>
+            <a:pPr indent="0" marL="0">
+              <a:buNone/>
+            </a:pPr>
+            <a:r>
+              <a:rPr lang="en-US" sz="2800" b="1" dirty="0">
+                <a:solidFill>
+                  <a:srgbClr val="1C2333"/>
+                </a:solidFill>
+                <a:latin typeface="Cambria" pitchFamily="34" charset="0"/>
+                <a:ea typeface="Cambria" pitchFamily="34" charset="-122"/>
+                <a:cs typeface="Cambria" pitchFamily="34" charset="-120"/>
+              </a:rPr>
+              <a:t>Что дешевле — не так однозначно</a:t>
+            </a:r>
+            <a:endParaRPr lang="en-US" sz="2800" dirty="0"/>
+          </a:p>
+        </p:txBody>
+      </p:sp>
+      <p:sp>
+        <p:nvSpPr>
+          <p:cNvPr id="4" name="Shape 2"/>
+          <p:cNvSpPr/>
+          <p:nvPr/>
+        </p:nvSpPr>
+        <p:spPr>
+          <a:xfrm>
+            <a:off x="640080" y="1691640"/>
+            <a:ext cx="10881360" cy="457200"/>
+          </a:xfrm>
+          <a:prstGeom prst="roundRect">
+            <a:avLst>
+              <a:gd name="adj" fmla="val 12000"/>
+            </a:avLst>
+          </a:prstGeom>
+          <a:solidFill>
+            <a:srgbClr val="1C2333"/>
+          </a:solidFill>
+          <a:ln/>
+        </p:spPr>
+      </p:sp>
+      <p:sp>
+        <p:nvSpPr>
+          <p:cNvPr id="5" name="Text 3"/>
+          <p:cNvSpPr txBox="1"/>
+          <p:nvPr/>
+        </p:nvSpPr>
+        <p:spPr>
+          <a:xfrm>
+            <a:off x="640080" y="1691640"/>
+            <a:ext cx="3017520" cy="457200"/>
+          </a:xfrm>
+          <a:prstGeom prst="rect">
+            <a:avLst/>
+          </a:prstGeom>
+          <a:noFill/>
+          <a:ln/>
+        </p:spPr>
+        <p:txBody>
+          <a:bodyPr wrap="square" lIns="0" tIns="0" rIns="0" bIns="0" rtlCol="0" anchor="ctr"/>
+          <a:lstStyle/>
+          <a:p>
+            <a:pPr indent="0" marL="0">
+              <a:buNone/>
+            </a:pPr>
+            <a:endParaRPr lang="en-US" dirty="0"/>
+          </a:p>
+        </p:txBody>
+      </p:sp>
+      <p:sp>
+        <p:nvSpPr>
+          <p:cNvPr id="6" name="Text 4"/>
+          <p:cNvSpPr txBox="1"/>
+          <p:nvPr/>
+        </p:nvSpPr>
+        <p:spPr>
+          <a:xfrm>
+            <a:off x="3657600" y="1691640"/>
+            <a:ext cx="3931920" cy="457200"/>
+          </a:xfrm>
+          <a:prstGeom prst="rect">
+            <a:avLst/>
+          </a:prstGeom>
+          <a:noFill/>
+          <a:ln/>
+        </p:spPr>
+        <p:txBody>
+          <a:bodyPr wrap="square" lIns="0" tIns="0" rIns="0" bIns="0" rtlCol="0" anchor="ctr"/>
+          <a:lstStyle/>
+          <a:p>
+            <a:pPr algn="ctr" indent="0" marL="0">
+              <a:buNone/>
+            </a:pPr>
+            <a:r>
+              <a:rPr lang="en-US" sz="1300" b="1" spc="100" kern="0" dirty="0">
+                <a:solidFill>
+                  <a:srgbClr val="FFFFFF"/>
+                </a:solidFill>
+                <a:latin typeface="Calibri" pitchFamily="34" charset="0"/>
+                <a:ea typeface="Calibri" pitchFamily="34" charset="-122"/>
+                <a:cs typeface="Calibri" pitchFamily="34" charset="-120"/>
+              </a:rPr>
+              <a:t>PRODIGY</a:t>
+            </a:r>
+            <a:endParaRPr lang="en-US" sz="1300" dirty="0"/>
+          </a:p>
+        </p:txBody>
+      </p:sp>
+      <p:sp>
+        <p:nvSpPr>
+          <p:cNvPr id="7" name="Text 5"/>
+          <p:cNvSpPr txBox="1"/>
+          <p:nvPr/>
+        </p:nvSpPr>
+        <p:spPr>
+          <a:xfrm>
+            <a:off x="7589520" y="1691640"/>
+            <a:ext cx="3931920" cy="457200"/>
+          </a:xfrm>
+          <a:prstGeom prst="rect">
+            <a:avLst/>
+          </a:prstGeom>
+          <a:noFill/>
+          <a:ln/>
+        </p:spPr>
+        <p:txBody>
+          <a:bodyPr wrap="square" lIns="0" tIns="0" rIns="0" bIns="0" rtlCol="0" anchor="ctr"/>
+          <a:lstStyle/>
+          <a:p>
+            <a:pPr algn="ctr" indent="0" marL="0">
+              <a:buNone/>
+            </a:pPr>
+            <a:r>
+              <a:rPr lang="en-US" sz="1300" b="1" spc="100" kern="0" dirty="0">
+                <a:solidFill>
+                  <a:srgbClr val="4ADE80"/>
+                </a:solidFill>
+                <a:latin typeface="Calibri" pitchFamily="34" charset="0"/>
+                <a:ea typeface="Calibri" pitchFamily="34" charset="-122"/>
+                <a:cs typeface="Calibri" pitchFamily="34" charset="-120"/>
+              </a:rPr>
+              <a:t>LABEL STUDIO</a:t>
+            </a:r>
+            <a:endParaRPr lang="en-US" sz="1300" dirty="0"/>
+          </a:p>
+        </p:txBody>
+      </p:sp>
+      <p:sp>
+        <p:nvSpPr>
+          <p:cNvPr id="8" name="Shape 6"/>
+          <p:cNvSpPr/>
+          <p:nvPr/>
+        </p:nvSpPr>
+        <p:spPr>
+          <a:xfrm>
+            <a:off x="640080" y="2148840"/>
+            <a:ext cx="10881360" cy="658368"/>
+          </a:xfrm>
+          <a:prstGeom prst="rect">
+            <a:avLst/>
+          </a:prstGeom>
+          <a:solidFill>
+            <a:srgbClr val="FFFFFF"/>
+          </a:solidFill>
+          <a:ln w="9525">
+            <a:solidFill>
+              <a:srgbClr val="DDE1E7"/>
+            </a:solidFill>
+            <a:prstDash val="solid"/>
+          </a:ln>
+        </p:spPr>
+      </p:sp>
+      <p:sp>
+        <p:nvSpPr>
+          <p:cNvPr id="9" name="Text 7"/>
+          <p:cNvSpPr txBox="1"/>
+          <p:nvPr/>
+        </p:nvSpPr>
+        <p:spPr>
+          <a:xfrm>
+            <a:off x="822960" y="2148840"/>
+            <a:ext cx="2743200" cy="658368"/>
+          </a:xfrm>
+          <a:prstGeom prst="rect">
+            <a:avLst/>
+          </a:prstGeom>
+          <a:noFill/>
+          <a:ln/>
+        </p:spPr>
+        <p:txBody>
+          <a:bodyPr wrap="square" lIns="0" tIns="0" rIns="0" bIns="0" rtlCol="0" anchor="ctr"/>
+          <a:lstStyle/>
+          <a:p>
+            <a:pPr indent="0" marL="0">
+              <a:lnSpc>
+                <a:spcPct val="110000"/>
+              </a:lnSpc>
+              <a:buNone/>
+            </a:pPr>
+            <a:r>
+              <a:rPr lang="en-US" sz="1250" b="1" dirty="0">
+                <a:solidFill>
+                  <a:srgbClr val="1C2333"/>
+                </a:solidFill>
+                <a:latin typeface="Cambria" pitchFamily="34" charset="0"/>
+                <a:ea typeface="Cambria" pitchFamily="34" charset="-122"/>
+                <a:cs typeface="Cambria" pitchFamily="34" charset="-120"/>
+              </a:rPr>
+              <a:t>Фронтенд</a:t>
+            </a:r>
+            <a:endParaRPr lang="en-US" sz="1250" dirty="0"/>
+          </a:p>
+        </p:txBody>
+      </p:sp>
+      <p:sp>
+        <p:nvSpPr>
+          <p:cNvPr id="10" name="Text 8"/>
+          <p:cNvSpPr txBox="1"/>
+          <p:nvPr/>
+        </p:nvSpPr>
+        <p:spPr>
+          <a:xfrm>
+            <a:off x="3794760" y="2148840"/>
+            <a:ext cx="3657600" cy="658368"/>
+          </a:xfrm>
+          <a:prstGeom prst="rect">
+            <a:avLst/>
+          </a:prstGeom>
+          <a:noFill/>
+          <a:ln/>
+        </p:spPr>
+        <p:txBody>
+          <a:bodyPr wrap="square" lIns="0" tIns="0" rIns="0" bIns="0" rtlCol="0" anchor="ctr"/>
+          <a:lstStyle/>
+          <a:p>
+            <a:pPr indent="0" marL="0">
+              <a:lnSpc>
+                <a:spcPct val="110000"/>
+              </a:lnSpc>
+              <a:buNone/>
+            </a:pPr>
+            <a:r>
+              <a:rPr lang="en-US" sz="1200" dirty="0">
+                <a:solidFill>
+                  <a:srgbClr val="6B7280"/>
+                </a:solidFill>
+                <a:latin typeface="Calibri" pitchFamily="34" charset="0"/>
+                <a:ea typeface="Calibri" pitchFamily="34" charset="-122"/>
+                <a:cs typeface="Calibri" pitchFamily="34" charset="-120"/>
+              </a:rPr>
+              <a:t>Svelte, закрытый исходный код</a:t>
+            </a:r>
+            <a:endParaRPr lang="en-US" sz="1200" dirty="0"/>
+          </a:p>
+        </p:txBody>
+      </p:sp>
+      <p:sp>
+        <p:nvSpPr>
+          <p:cNvPr id="11" name="Text 9"/>
+          <p:cNvSpPr txBox="1"/>
+          <p:nvPr/>
+        </p:nvSpPr>
+        <p:spPr>
+          <a:xfrm>
+            <a:off x="7726680" y="2148840"/>
+            <a:ext cx="3657600" cy="658368"/>
+          </a:xfrm>
+          <a:prstGeom prst="rect">
+            <a:avLst/>
+          </a:prstGeom>
+          <a:noFill/>
+          <a:ln/>
+        </p:spPr>
+        <p:txBody>
+          <a:bodyPr wrap="square" lIns="0" tIns="0" rIns="0" bIns="0" rtlCol="0" anchor="ctr"/>
+          <a:lstStyle/>
+          <a:p>
+            <a:pPr indent="0" marL="0">
+              <a:lnSpc>
+                <a:spcPct val="110000"/>
+              </a:lnSpc>
+              <a:buNone/>
+            </a:pPr>
+            <a:r>
+              <a:rPr lang="en-US" sz="1200" dirty="0">
+                <a:solidFill>
+                  <a:srgbClr val="1C2333"/>
+                </a:solidFill>
+                <a:latin typeface="Calibri" pitchFamily="34" charset="0"/>
+                <a:ea typeface="Calibri" pitchFamily="34" charset="-122"/>
+                <a:cs typeface="Calibri" pitchFamily="34" charset="-120"/>
+              </a:rPr>
+              <a:t>React, открытый исходный код</a:t>
+            </a:r>
+            <a:endParaRPr lang="en-US" sz="1200" dirty="0"/>
+          </a:p>
+        </p:txBody>
+      </p:sp>
+      <p:sp>
+        <p:nvSpPr>
+          <p:cNvPr id="12" name="Shape 10"/>
+          <p:cNvSpPr/>
+          <p:nvPr/>
+        </p:nvSpPr>
+        <p:spPr>
+          <a:xfrm>
+            <a:off x="640080" y="2807208"/>
+            <a:ext cx="10881360" cy="658368"/>
+          </a:xfrm>
+          <a:prstGeom prst="rect">
+            <a:avLst/>
+          </a:prstGeom>
+          <a:solidFill>
+            <a:srgbClr val="ECEEF1"/>
+          </a:solidFill>
+          <a:ln w="9525">
+            <a:solidFill>
+              <a:srgbClr val="DDE1E7"/>
+            </a:solidFill>
+            <a:prstDash val="solid"/>
+          </a:ln>
+        </p:spPr>
+      </p:sp>
+      <p:sp>
+        <p:nvSpPr>
+          <p:cNvPr id="13" name="Text 11"/>
+          <p:cNvSpPr txBox="1"/>
+          <p:nvPr/>
+        </p:nvSpPr>
+        <p:spPr>
+          <a:xfrm>
+            <a:off x="822960" y="2807208"/>
+            <a:ext cx="2743200" cy="658368"/>
+          </a:xfrm>
+          <a:prstGeom prst="rect">
+            <a:avLst/>
+          </a:prstGeom>
+          <a:noFill/>
+          <a:ln/>
+        </p:spPr>
+        <p:txBody>
+          <a:bodyPr wrap="square" lIns="0" tIns="0" rIns="0" bIns="0" rtlCol="0" anchor="ctr"/>
+          <a:lstStyle/>
+          <a:p>
+            <a:pPr indent="0" marL="0">
+              <a:lnSpc>
+                <a:spcPct val="110000"/>
+              </a:lnSpc>
+              <a:buNone/>
+            </a:pPr>
+            <a:r>
+              <a:rPr lang="en-US" sz="1250" b="1" dirty="0">
+                <a:solidFill>
+                  <a:srgbClr val="1C2333"/>
+                </a:solidFill>
+                <a:latin typeface="Cambria" pitchFamily="34" charset="0"/>
+                <a:ea typeface="Cambria" pitchFamily="34" charset="-122"/>
+                <a:cs typeface="Cambria" pitchFamily="34" charset="-120"/>
+              </a:rPr>
+              <a:t>Кастомизация</a:t>
+            </a:r>
+            <a:endParaRPr lang="en-US" sz="1250" dirty="0"/>
+          </a:p>
+        </p:txBody>
+      </p:sp>
+      <p:sp>
+        <p:nvSpPr>
+          <p:cNvPr id="14" name="Text 12"/>
+          <p:cNvSpPr txBox="1"/>
+          <p:nvPr/>
+        </p:nvSpPr>
+        <p:spPr>
+          <a:xfrm>
+            <a:off x="3794760" y="2807208"/>
+            <a:ext cx="3657600" cy="658368"/>
+          </a:xfrm>
+          <a:prstGeom prst="rect">
+            <a:avLst/>
+          </a:prstGeom>
+          <a:noFill/>
+          <a:ln/>
+        </p:spPr>
+        <p:txBody>
+          <a:bodyPr wrap="square" lIns="0" tIns="0" rIns="0" bIns="0" rtlCol="0" anchor="ctr"/>
+          <a:lstStyle/>
+          <a:p>
+            <a:pPr indent="0" marL="0">
+              <a:lnSpc>
+                <a:spcPct val="110000"/>
+              </a:lnSpc>
+              <a:buNone/>
+            </a:pPr>
+            <a:r>
+              <a:rPr lang="en-US" sz="1200" dirty="0">
+                <a:solidFill>
+                  <a:srgbClr val="6B7280"/>
+                </a:solidFill>
+                <a:latin typeface="Calibri" pitchFamily="34" charset="0"/>
+                <a:ea typeface="Calibri" pitchFamily="34" charset="-122"/>
+                <a:cs typeface="Calibri" pitchFamily="34" charset="-120"/>
+              </a:rPr>
+              <a:t>Только через config-хуки</a:t>
+            </a:r>
+            <a:endParaRPr lang="en-US" sz="1200" dirty="0"/>
+          </a:p>
+        </p:txBody>
+      </p:sp>
+      <p:sp>
+        <p:nvSpPr>
+          <p:cNvPr id="15" name="Text 13"/>
+          <p:cNvSpPr txBox="1"/>
+          <p:nvPr/>
+        </p:nvSpPr>
+        <p:spPr>
+          <a:xfrm>
+            <a:off x="7726680" y="2807208"/>
+            <a:ext cx="3657600" cy="658368"/>
+          </a:xfrm>
+          <a:prstGeom prst="rect">
+            <a:avLst/>
+          </a:prstGeom>
+          <a:noFill/>
+          <a:ln/>
+        </p:spPr>
+        <p:txBody>
+          <a:bodyPr wrap="square" lIns="0" tIns="0" rIns="0" bIns="0" rtlCol="0" anchor="ctr"/>
+          <a:lstStyle/>
+          <a:p>
+            <a:pPr indent="0" marL="0">
+              <a:lnSpc>
+                <a:spcPct val="110000"/>
+              </a:lnSpc>
+              <a:buNone/>
+            </a:pPr>
+            <a:r>
+              <a:rPr lang="en-US" sz="1200" dirty="0">
+                <a:solidFill>
+                  <a:srgbClr val="1C2333"/>
+                </a:solidFill>
+                <a:latin typeface="Calibri" pitchFamily="34" charset="0"/>
+                <a:ea typeface="Calibri" pitchFamily="34" charset="-122"/>
+                <a:cs typeface="Calibri" pitchFamily="34" charset="-120"/>
+              </a:rPr>
+              <a:t>Можно менять исходники напрямую</a:t>
+            </a:r>
+            <a:endParaRPr lang="en-US" sz="1200" dirty="0"/>
+          </a:p>
+        </p:txBody>
+      </p:sp>
+      <p:sp>
+        <p:nvSpPr>
+          <p:cNvPr id="16" name="Shape 14"/>
+          <p:cNvSpPr/>
+          <p:nvPr/>
+        </p:nvSpPr>
+        <p:spPr>
+          <a:xfrm>
+            <a:off x="640080" y="3465576"/>
+            <a:ext cx="10881360" cy="658368"/>
+          </a:xfrm>
+          <a:prstGeom prst="rect">
+            <a:avLst/>
+          </a:prstGeom>
+          <a:solidFill>
+            <a:srgbClr val="FFFFFF"/>
+          </a:solidFill>
+          <a:ln w="9525">
+            <a:solidFill>
+              <a:srgbClr val="DDE1E7"/>
+            </a:solidFill>
+            <a:prstDash val="solid"/>
+          </a:ln>
+        </p:spPr>
+      </p:sp>
+      <p:sp>
+        <p:nvSpPr>
+          <p:cNvPr id="17" name="Text 15"/>
+          <p:cNvSpPr txBox="1"/>
+          <p:nvPr/>
+        </p:nvSpPr>
+        <p:spPr>
+          <a:xfrm>
+            <a:off x="822960" y="3465576"/>
+            <a:ext cx="2743200" cy="658368"/>
+          </a:xfrm>
+          <a:prstGeom prst="rect">
+            <a:avLst/>
+          </a:prstGeom>
+          <a:noFill/>
+          <a:ln/>
+        </p:spPr>
+        <p:txBody>
+          <a:bodyPr wrap="square" lIns="0" tIns="0" rIns="0" bIns="0" rtlCol="0" anchor="ctr"/>
+          <a:lstStyle/>
+          <a:p>
+            <a:pPr indent="0" marL="0">
+              <a:lnSpc>
+                <a:spcPct val="110000"/>
+              </a:lnSpc>
+              <a:buNone/>
+            </a:pPr>
+            <a:r>
+              <a:rPr lang="en-US" sz="1250" b="1" dirty="0">
+                <a:solidFill>
+                  <a:srgbClr val="1C2333"/>
+                </a:solidFill>
+                <a:latin typeface="Cambria" pitchFamily="34" charset="0"/>
+                <a:ea typeface="Cambria" pitchFamily="34" charset="-122"/>
+                <a:cs typeface="Cambria" pitchFamily="34" charset="-120"/>
+              </a:rPr>
+              <a:t>Базовая разметка</a:t>
+            </a:r>
+            <a:endParaRPr lang="en-US" sz="1250" dirty="0"/>
+          </a:p>
+        </p:txBody>
+      </p:sp>
+      <p:sp>
+        <p:nvSpPr>
+          <p:cNvPr id="18" name="Text 16"/>
+          <p:cNvSpPr txBox="1"/>
+          <p:nvPr/>
+        </p:nvSpPr>
+        <p:spPr>
+          <a:xfrm>
+            <a:off x="3794760" y="3465576"/>
+            <a:ext cx="3657600" cy="658368"/>
+          </a:xfrm>
+          <a:prstGeom prst="rect">
+            <a:avLst/>
+          </a:prstGeom>
+          <a:noFill/>
+          <a:ln/>
+        </p:spPr>
+        <p:txBody>
+          <a:bodyPr wrap="square" lIns="0" tIns="0" rIns="0" bIns="0" rtlCol="0" anchor="ctr"/>
+          <a:lstStyle/>
+          <a:p>
+            <a:pPr indent="0" marL="0">
+              <a:lnSpc>
+                <a:spcPct val="110000"/>
+              </a:lnSpc>
+              <a:buNone/>
+            </a:pPr>
+            <a:r>
+              <a:rPr lang="en-US" sz="1200" dirty="0">
+                <a:solidFill>
+                  <a:srgbClr val="6B7280"/>
+                </a:solidFill>
+                <a:latin typeface="Calibri" pitchFamily="34" charset="0"/>
+                <a:ea typeface="Calibri" pitchFamily="34" charset="-122"/>
+                <a:cs typeface="Calibri" pitchFamily="34" charset="-120"/>
+              </a:rPr>
+              <a:t>$490 / место, разовая покупка</a:t>
+            </a:r>
+            <a:endParaRPr lang="en-US" sz="1200" dirty="0"/>
+          </a:p>
+        </p:txBody>
+      </p:sp>
+      <p:sp>
+        <p:nvSpPr>
+          <p:cNvPr id="19" name="Text 17"/>
+          <p:cNvSpPr txBox="1"/>
+          <p:nvPr/>
+        </p:nvSpPr>
+        <p:spPr>
+          <a:xfrm>
+            <a:off x="7726680" y="3465576"/>
+            <a:ext cx="3657600" cy="658368"/>
+          </a:xfrm>
+          <a:prstGeom prst="rect">
+            <a:avLst/>
+          </a:prstGeom>
+          <a:noFill/>
+          <a:ln/>
+        </p:spPr>
+        <p:txBody>
+          <a:bodyPr wrap="square" lIns="0" tIns="0" rIns="0" bIns="0" rtlCol="0" anchor="ctr"/>
+          <a:lstStyle/>
+          <a:p>
+            <a:pPr indent="0" marL="0">
+              <a:lnSpc>
+                <a:spcPct val="110000"/>
+              </a:lnSpc>
+              <a:buNone/>
+            </a:pPr>
+            <a:r>
+              <a:rPr lang="en-US" sz="1200" dirty="0">
+                <a:solidFill>
+                  <a:srgbClr val="1C2333"/>
+                </a:solidFill>
+                <a:latin typeface="Calibri" pitchFamily="34" charset="0"/>
+                <a:ea typeface="Calibri" pitchFamily="34" charset="-122"/>
+                <a:cs typeface="Calibri" pitchFamily="34" charset="-120"/>
+              </a:rPr>
+              <a:t>Бесплатно (Apache 2.0), self-host</a:t>
+            </a:r>
+            <a:endParaRPr lang="en-US" sz="1200" dirty="0"/>
+          </a:p>
+        </p:txBody>
+      </p:sp>
+      <p:sp>
+        <p:nvSpPr>
+          <p:cNvPr id="20" name="Shape 18"/>
+          <p:cNvSpPr/>
+          <p:nvPr/>
+        </p:nvSpPr>
+        <p:spPr>
+          <a:xfrm>
+            <a:off x="640080" y="4123944"/>
+            <a:ext cx="10881360" cy="658368"/>
+          </a:xfrm>
+          <a:prstGeom prst="rect">
+            <a:avLst/>
+          </a:prstGeom>
+          <a:solidFill>
+            <a:srgbClr val="ECEEF1"/>
+          </a:solidFill>
+          <a:ln w="9525">
+            <a:solidFill>
+              <a:srgbClr val="DDE1E7"/>
+            </a:solidFill>
+            <a:prstDash val="solid"/>
+          </a:ln>
+        </p:spPr>
+      </p:sp>
+      <p:sp>
+        <p:nvSpPr>
+          <p:cNvPr id="21" name="Text 19"/>
+          <p:cNvSpPr txBox="1"/>
+          <p:nvPr/>
+        </p:nvSpPr>
+        <p:spPr>
+          <a:xfrm>
+            <a:off x="822960" y="4123944"/>
+            <a:ext cx="2743200" cy="658368"/>
+          </a:xfrm>
+          <a:prstGeom prst="rect">
+            <a:avLst/>
+          </a:prstGeom>
+          <a:noFill/>
+          <a:ln/>
+        </p:spPr>
+        <p:txBody>
+          <a:bodyPr wrap="square" lIns="0" tIns="0" rIns="0" bIns="0" rtlCol="0" anchor="ctr"/>
+          <a:lstStyle/>
+          <a:p>
+            <a:pPr indent="0" marL="0">
+              <a:lnSpc>
+                <a:spcPct val="110000"/>
+              </a:lnSpc>
+              <a:buNone/>
+            </a:pPr>
+            <a:r>
+              <a:rPr lang="en-US" sz="1250" b="1" dirty="0">
+                <a:solidFill>
+                  <a:srgbClr val="1C2333"/>
+                </a:solidFill>
+                <a:latin typeface="Cambria" pitchFamily="34" charset="0"/>
+                <a:ea typeface="Cambria" pitchFamily="34" charset="-122"/>
+                <a:cs typeface="Cambria" pitchFamily="34" charset="-120"/>
+              </a:rPr>
+              <a:t>Роли и ревью (как на вашем скрине)</a:t>
+            </a:r>
+            <a:endParaRPr lang="en-US" sz="1250" dirty="0"/>
+          </a:p>
+        </p:txBody>
+      </p:sp>
+      <p:sp>
+        <p:nvSpPr>
+          <p:cNvPr id="22" name="Text 20"/>
+          <p:cNvSpPr txBox="1"/>
+          <p:nvPr/>
+        </p:nvSpPr>
+        <p:spPr>
+          <a:xfrm>
+            <a:off x="3794760" y="4123944"/>
+            <a:ext cx="3657600" cy="658368"/>
+          </a:xfrm>
+          <a:prstGeom prst="rect">
+            <a:avLst/>
+          </a:prstGeom>
+          <a:noFill/>
+          <a:ln/>
+        </p:spPr>
+        <p:txBody>
+          <a:bodyPr wrap="square" lIns="0" tIns="0" rIns="0" bIns="0" rtlCol="0" anchor="ctr"/>
+          <a:lstStyle/>
+          <a:p>
+            <a:pPr indent="0" marL="0">
+              <a:lnSpc>
+                <a:spcPct val="110000"/>
+              </a:lnSpc>
+              <a:buNone/>
+            </a:pPr>
+            <a:r>
+              <a:rPr lang="en-US" sz="1200" dirty="0">
+                <a:solidFill>
+                  <a:srgbClr val="6B7280"/>
+                </a:solidFill>
+                <a:latin typeface="Calibri" pitchFamily="34" charset="0"/>
+                <a:ea typeface="Calibri" pitchFamily="34" charset="-122"/>
+                <a:cs typeface="Calibri" pitchFamily="34" charset="-120"/>
+              </a:rPr>
+              <a:t>Входит в лицензию</a:t>
+            </a:r>
+            <a:endParaRPr lang="en-US" sz="1200" dirty="0"/>
+          </a:p>
+        </p:txBody>
+      </p:sp>
+      <p:sp>
+        <p:nvSpPr>
+          <p:cNvPr id="23" name="Text 21"/>
+          <p:cNvSpPr txBox="1"/>
+          <p:nvPr/>
+        </p:nvSpPr>
+        <p:spPr>
+          <a:xfrm>
+            <a:off x="7726680" y="4123944"/>
+            <a:ext cx="3657600" cy="658368"/>
+          </a:xfrm>
+          <a:prstGeom prst="rect">
+            <a:avLst/>
+          </a:prstGeom>
+          <a:noFill/>
+          <a:ln/>
+        </p:spPr>
+        <p:txBody>
+          <a:bodyPr wrap="square" lIns="0" tIns="0" rIns="0" bIns="0" rtlCol="0" anchor="ctr"/>
+          <a:lstStyle/>
+          <a:p>
+            <a:pPr indent="0" marL="0">
+              <a:lnSpc>
+                <a:spcPct val="110000"/>
+              </a:lnSpc>
+              <a:buNone/>
+            </a:pPr>
+            <a:r>
+              <a:rPr lang="en-US" sz="1200" dirty="0">
+                <a:solidFill>
+                  <a:srgbClr val="1C2333"/>
+                </a:solidFill>
+                <a:latin typeface="Calibri" pitchFamily="34" charset="0"/>
+                <a:ea typeface="Calibri" pitchFamily="34" charset="-122"/>
+                <a:cs typeface="Calibri" pitchFamily="34" charset="-120"/>
+              </a:rPr>
+              <a:t>Только в Enterprise — цена по запросу</a:t>
+            </a:r>
+            <a:endParaRPr lang="en-US" sz="1200" dirty="0"/>
+          </a:p>
+        </p:txBody>
+      </p:sp>
+      <p:sp>
+        <p:nvSpPr>
+          <p:cNvPr id="24" name="Shape 22"/>
+          <p:cNvSpPr/>
+          <p:nvPr/>
+        </p:nvSpPr>
+        <p:spPr>
+          <a:xfrm>
+            <a:off x="640080" y="4782312"/>
+            <a:ext cx="10881360" cy="658368"/>
+          </a:xfrm>
+          <a:prstGeom prst="rect">
+            <a:avLst/>
+          </a:prstGeom>
+          <a:solidFill>
+            <a:srgbClr val="FFFFFF"/>
+          </a:solidFill>
+          <a:ln w="9525">
+            <a:solidFill>
+              <a:srgbClr val="DDE1E7"/>
+            </a:solidFill>
+            <a:prstDash val="solid"/>
+          </a:ln>
+        </p:spPr>
+      </p:sp>
+      <p:sp>
+        <p:nvSpPr>
+          <p:cNvPr id="25" name="Text 23"/>
+          <p:cNvSpPr txBox="1"/>
+          <p:nvPr/>
+        </p:nvSpPr>
+        <p:spPr>
+          <a:xfrm>
+            <a:off x="822960" y="4782312"/>
+            <a:ext cx="2743200" cy="658368"/>
+          </a:xfrm>
+          <a:prstGeom prst="rect">
+            <a:avLst/>
+          </a:prstGeom>
+          <a:noFill/>
+          <a:ln/>
+        </p:spPr>
+        <p:txBody>
+          <a:bodyPr wrap="square" lIns="0" tIns="0" rIns="0" bIns="0" rtlCol="0" anchor="ctr"/>
+          <a:lstStyle/>
+          <a:p>
+            <a:pPr indent="0" marL="0">
+              <a:lnSpc>
+                <a:spcPct val="110000"/>
+              </a:lnSpc>
+              <a:buNone/>
+            </a:pPr>
+            <a:r>
+              <a:rPr lang="en-US" sz="1250" b="1" dirty="0">
+                <a:solidFill>
+                  <a:srgbClr val="1C2333"/>
+                </a:solidFill>
+                <a:latin typeface="Cambria" pitchFamily="34" charset="0"/>
+                <a:ea typeface="Cambria" pitchFamily="34" charset="-122"/>
+                <a:cs typeface="Cambria" pitchFamily="34" charset="-120"/>
+              </a:rPr>
+              <a:t>Аудио + транскрипция</a:t>
+            </a:r>
+            <a:endParaRPr lang="en-US" sz="1250" dirty="0"/>
+          </a:p>
+        </p:txBody>
+      </p:sp>
+      <p:sp>
+        <p:nvSpPr>
+          <p:cNvPr id="26" name="Text 24"/>
+          <p:cNvSpPr txBox="1"/>
+          <p:nvPr/>
+        </p:nvSpPr>
+        <p:spPr>
+          <a:xfrm>
+            <a:off x="3794760" y="4782312"/>
+            <a:ext cx="3657600" cy="658368"/>
+          </a:xfrm>
+          <a:prstGeom prst="rect">
+            <a:avLst/>
+          </a:prstGeom>
+          <a:noFill/>
+          <a:ln/>
+        </p:spPr>
+        <p:txBody>
+          <a:bodyPr wrap="square" lIns="0" tIns="0" rIns="0" bIns="0" rtlCol="0" anchor="ctr"/>
+          <a:lstStyle/>
+          <a:p>
+            <a:pPr indent="0" marL="0">
+              <a:lnSpc>
+                <a:spcPct val="110000"/>
+              </a:lnSpc>
+              <a:buNone/>
+            </a:pPr>
+            <a:r>
+              <a:rPr lang="en-US" sz="1200" dirty="0">
+                <a:solidFill>
+                  <a:srgbClr val="6B7280"/>
+                </a:solidFill>
+                <a:latin typeface="Calibri" pitchFamily="34" charset="0"/>
+                <a:ea typeface="Calibri" pitchFamily="34" charset="-122"/>
+                <a:cs typeface="Calibri" pitchFamily="34" charset="-120"/>
+              </a:rPr>
+              <a:t>Есть (может требовать плагин)</a:t>
+            </a:r>
+            <a:endParaRPr lang="en-US" sz="1200" dirty="0"/>
+          </a:p>
+        </p:txBody>
+      </p:sp>
+      <p:sp>
+        <p:nvSpPr>
+          <p:cNvPr id="27" name="Text 25"/>
+          <p:cNvSpPr txBox="1"/>
+          <p:nvPr/>
+        </p:nvSpPr>
+        <p:spPr>
+          <a:xfrm>
+            <a:off x="7726680" y="4782312"/>
+            <a:ext cx="3657600" cy="658368"/>
+          </a:xfrm>
+          <a:prstGeom prst="rect">
+            <a:avLst/>
+          </a:prstGeom>
+          <a:noFill/>
+          <a:ln/>
+        </p:spPr>
+        <p:txBody>
+          <a:bodyPr wrap="square" lIns="0" tIns="0" rIns="0" bIns="0" rtlCol="0" anchor="ctr"/>
+          <a:lstStyle/>
+          <a:p>
+            <a:pPr indent="0" marL="0">
+              <a:lnSpc>
+                <a:spcPct val="110000"/>
+              </a:lnSpc>
+              <a:buNone/>
+            </a:pPr>
+            <a:r>
+              <a:rPr lang="en-US" sz="1200" dirty="0">
+                <a:solidFill>
+                  <a:srgbClr val="1C2333"/>
+                </a:solidFill>
+                <a:latin typeface="Calibri" pitchFamily="34" charset="0"/>
+                <a:ea typeface="Calibri" pitchFamily="34" charset="-122"/>
+                <a:cs typeface="Calibri" pitchFamily="34" charset="-120"/>
+              </a:rPr>
+              <a:t>Готовый шаблон из коробки</a:t>
+            </a:r>
+            <a:endParaRPr lang="en-US" sz="1200" dirty="0"/>
+          </a:p>
+        </p:txBody>
+      </p:sp>
+      <p:sp>
+        <p:nvSpPr>
+          <p:cNvPr id="28" name="Text 26"/>
+          <p:cNvSpPr txBox="1"/>
+          <p:nvPr/>
+        </p:nvSpPr>
+        <p:spPr>
+          <a:xfrm>
+            <a:off x="640080" y="5623560"/>
+            <a:ext cx="10881360" cy="640080"/>
+          </a:xfrm>
+          <a:prstGeom prst="rect">
+            <a:avLst/>
+          </a:prstGeom>
+          <a:noFill/>
+          <a:ln/>
+        </p:spPr>
+        <p:txBody>
+          <a:bodyPr wrap="square" lIns="0" tIns="0" rIns="0" bIns="0" rtlCol="0" anchor="ctr"/>
+          <a:lstStyle/>
+          <a:p>
+            <a:pPr indent="0" marL="0">
+              <a:lnSpc>
+                <a:spcPct val="125000"/>
+              </a:lnSpc>
+              <a:buNone/>
+            </a:pPr>
+            <a:r>
+              <a:rPr lang="en-US" sz="1200" i="1" dirty="0">
+                <a:solidFill>
+                  <a:srgbClr val="6B7280"/>
+                </a:solidFill>
+                <a:latin typeface="Calibri" pitchFamily="34" charset="0"/>
+                <a:ea typeface="Calibri" pitchFamily="34" charset="-122"/>
+                <a:cs typeface="Calibri" pitchFamily="34" charset="-120"/>
+              </a:rPr>
+              <a:t>Роли/ревью, которые уже есть у нас сегодня, — платная часть в обеих системах. Честное сравнение: не «Prodigy $490 vs Label Studio бесплатно», а лицензия Prodigy vs цена Enterprise Label Studio по запросу — плюс стоимость миграции данных и переобучения команды.</a:t>
+            </a:r>
+            <a:endParaRPr lang="en-US" sz="1200" dirty="0"/>
+          </a:p>
+        </p:txBody>
+      </p:sp>
+      <p:sp>
+        <p:nvSpPr>
+          <p:cNvPr id="29" name="Text 27"/>
+          <p:cNvSpPr txBox="1"/>
+          <p:nvPr/>
+        </p:nvSpPr>
+        <p:spPr>
+          <a:xfrm>
+            <a:off x="502920" y="6446520"/>
+            <a:ext cx="2743200" cy="274320"/>
+          </a:xfrm>
+          <a:prstGeom prst="rect">
+            <a:avLst/>
+          </a:prstGeom>
+          <a:noFill/>
+          <a:ln/>
+        </p:spPr>
+        <p:txBody>
+          <a:bodyPr wrap="square" lIns="0" tIns="0" rIns="0" bIns="0" rtlCol="0" anchor="ctr"/>
+          <a:lstStyle/>
+          <a:p>
+            <a:pPr indent="0" marL="0">
+              <a:buNone/>
+            </a:pPr>
+            <a:r>
+              <a:rPr lang="en-US" sz="1050" b="1" dirty="0">
+                <a:solidFill>
+                  <a:srgbClr val="1C2333"/>
+                </a:solidFill>
+                <a:latin typeface="Cambria" pitchFamily="34" charset="0"/>
+                <a:ea typeface="Cambria" pitchFamily="34" charset="-122"/>
+                <a:cs typeface="Cambria" pitchFamily="34" charset="-120"/>
+              </a:rPr>
+              <a:t>Kaspi </a:t>
+            </a:r>
+            <a:pPr indent="0" marL="0">
+              <a:buNone/>
+            </a:pPr>
+            <a:r>
+              <a:rPr lang="en-US" sz="1050" b="1" dirty="0">
+                <a:solidFill>
+                  <a:srgbClr val="F14635"/>
+                </a:solidFill>
+                <a:latin typeface="Cambria" pitchFamily="34" charset="0"/>
+                <a:ea typeface="Cambria" pitchFamily="34" charset="-122"/>
+                <a:cs typeface="Cambria" pitchFamily="34" charset="-120"/>
+              </a:rPr>
+              <a:t>Markup</a:t>
+            </a:r>
+            <a:endParaRPr lang="en-US" sz="1050" dirty="0"/>
+          </a:p>
+        </p:txBody>
+      </p:sp>
+      <p:sp>
+        <p:nvSpPr>
+          <p:cNvPr id="30" name="Text 28"/>
+          <p:cNvSpPr txBox="1"/>
+          <p:nvPr/>
+        </p:nvSpPr>
+        <p:spPr>
+          <a:xfrm>
+            <a:off x="11551615" y="6446520"/>
+            <a:ext cx="457200" cy="274320"/>
+          </a:xfrm>
+          <a:prstGeom prst="rect">
+            <a:avLst/>
+          </a:prstGeom>
+          <a:noFill/>
+          <a:ln/>
+        </p:spPr>
+        <p:txBody>
+          <a:bodyPr wrap="square" lIns="0" tIns="0" rIns="0" bIns="0" rtlCol="0" anchor="ctr"/>
+          <a:lstStyle/>
+          <a:p>
+            <a:pPr algn="r" indent="0" marL="0">
+              <a:buNone/>
+            </a:pPr>
+            <a:r>
+              <a:rPr lang="en-US" sz="1000" dirty="0">
+                <a:solidFill>
+                  <a:srgbClr val="6B7280"/>
+                </a:solidFill>
+                <a:latin typeface="Calibri" pitchFamily="34" charset="0"/>
+                <a:ea typeface="Calibri" pitchFamily="34" charset="-122"/>
+                <a:cs typeface="Calibri" pitchFamily="34" charset="-120"/>
+              </a:rPr>
+              <a:t>07</a:t>
+            </a:r>
+            <a:endParaRPr lang="en-US" sz="1000" dirty="0"/>
+          </a:p>
+        </p:txBody>
+      </p:sp>
+    </p:spTree>
+  </p:cSld>
+  <p:clrMapOvr>
+    <a:masterClrMapping/>
+  </p:clrMapOvr>
+</p:sld>
+</file>
+
+<file path=ppt/slides/slide8.xml><?xml version="1.0" encoding="utf-8"?>
+<p:sld xmlns:a="http://schemas.openxmlformats.org/drawingml/2006/main" xmlns:r="http://schemas.openxmlformats.org/officeDocument/2006/relationships" xmlns:p="http://schemas.openxmlformats.org/presentationml/2006/main">
+  <p:cSld name="Slide 8">
+    <p:bg>
+      <p:bgPr>
+        <a:solidFill>
           <a:srgbClr val="1C2333"/>
         </a:solidFill>
       </p:bgPr>
@@ -4312,7 +6453,7 @@
         <p:spPr>
           <a:xfrm>
             <a:off x="777240" y="1371600"/>
-            <a:ext cx="10058400" cy="914400"/>
+            <a:ext cx="10058400" cy="640080"/>
           </a:xfrm>
           <a:prstGeom prst="rect">
             <a:avLst/>
@@ -4336,7 +6477,7 @@
                 <a:ea typeface="Cambria" pitchFamily="34" charset="-122"/>
                 <a:cs typeface="Cambria" pitchFamily="34" charset="-120"/>
               </a:rPr>
-              <a:t>Три пункта, которые хотим обсудить</a:t>
+              <a:t>Четыре пункта к обсуждению</a:t>
             </a:r>
             <a:endParaRPr lang="en-US" sz="3400" dirty="0"/>
           </a:p>
@@ -4350,7 +6491,7 @@
         </p:nvSpPr>
         <p:spPr>
           <a:xfrm>
-            <a:off x="822960" y="2606040"/>
+            <a:off x="822960" y="2697480"/>
             <a:ext cx="402336" cy="402336"/>
           </a:xfrm>
           <a:prstGeom prst="ellipse">
@@ -4370,7 +6511,7 @@
         </p:nvSpPr>
         <p:spPr>
           <a:xfrm>
-            <a:off x="822960" y="2606040"/>
+            <a:off x="822960" y="2697480"/>
             <a:ext cx="402336" cy="402336"/>
           </a:xfrm>
           <a:prstGeom prst="rect">
@@ -4409,7 +6550,7 @@
         </p:nvSpPr>
         <p:spPr>
           <a:xfrm>
-            <a:off x="1417320" y="2560320"/>
+            <a:off x="1417320" y="2651760"/>
             <a:ext cx="8961120" cy="365760"/>
           </a:xfrm>
           <a:prstGeom prst="rect">
@@ -4426,7 +6567,7 @@
               <a:buNone/>
             </a:pPr>
             <a:r>
-              <a:rPr lang="en-US" sz="1800" b="1" dirty="0">
+              <a:rPr lang="en-US" sz="1700" b="1" dirty="0">
                 <a:solidFill>
                   <a:srgbClr val="FFFFFF"/>
                 </a:solidFill>
@@ -4436,7 +6577,7 @@
               </a:rPr>
               <a:t>Буфер слов</a:t>
             </a:r>
-            <a:endParaRPr lang="en-US" sz="1800" dirty="0"/>
+            <a:endParaRPr lang="en-US" sz="1700" dirty="0"/>
           </a:p>
         </p:txBody>
       </p:sp>
@@ -4448,24 +6589,24 @@
         </p:nvSpPr>
         <p:spPr>
           <a:xfrm>
-            <a:off x="1417320" y="2971800"/>
-            <a:ext cx="8961120" cy="457200"/>
-          </a:xfrm>
-          <a:prstGeom prst="rect">
-            <a:avLst/>
-          </a:prstGeom>
-          <a:noFill/>
-          <a:ln/>
-        </p:spPr>
-        <p:txBody>
-          <a:bodyPr wrap="square" lIns="0" tIns="0" rIns="0" bIns="0" rtlCol="0" anchor="ctr"/>
-          <a:lstStyle/>
-          <a:p>
-            <a:pPr indent="0" marL="0">
-              <a:buNone/>
-            </a:pPr>
-            <a:r>
-              <a:rPr lang="en-US" sz="1300" dirty="0">
+            <a:off x="1417320" y="3044952"/>
+            <a:ext cx="8961120" cy="411480"/>
+          </a:xfrm>
+          <a:prstGeom prst="rect">
+            <a:avLst/>
+          </a:prstGeom>
+          <a:noFill/>
+          <a:ln/>
+        </p:spPr>
+        <p:txBody>
+          <a:bodyPr wrap="square" lIns="0" tIns="0" rIns="0" bIns="0" rtlCol="0" anchor="ctr"/>
+          <a:lstStyle/>
+          <a:p>
+            <a:pPr indent="0" marL="0">
+              <a:buNone/>
+            </a:pPr>
+            <a:r>
+              <a:rPr lang="en-US" sz="1250" dirty="0">
                 <a:solidFill>
                   <a:srgbClr val="C7CDD9"/>
                 </a:solidFill>
@@ -4475,7 +6616,7 @@
               </a:rPr>
               <a:t>Жизненно необходим — экономит время на каждой из тысяч задач.</a:t>
             </a:r>
-            <a:endParaRPr lang="en-US" sz="1300" dirty="0"/>
+            <a:endParaRPr lang="en-US" sz="1250" dirty="0"/>
           </a:p>
         </p:txBody>
       </p:sp>
@@ -4487,7 +6628,7 @@
         </p:nvSpPr>
         <p:spPr>
           <a:xfrm>
-            <a:off x="822960" y="3566160"/>
+            <a:off x="822960" y="3474720"/>
             <a:ext cx="402336" cy="402336"/>
           </a:xfrm>
           <a:prstGeom prst="ellipse">
@@ -4507,7 +6648,7 @@
         </p:nvSpPr>
         <p:spPr>
           <a:xfrm>
-            <a:off x="822960" y="3566160"/>
+            <a:off x="822960" y="3474720"/>
             <a:ext cx="402336" cy="402336"/>
           </a:xfrm>
           <a:prstGeom prst="rect">
@@ -4546,7 +6687,7 @@
         </p:nvSpPr>
         <p:spPr>
           <a:xfrm>
-            <a:off x="1417320" y="3520440"/>
+            <a:off x="1417320" y="3429000"/>
             <a:ext cx="8961120" cy="365760"/>
           </a:xfrm>
           <a:prstGeom prst="rect">
@@ -4563,7 +6704,7 @@
               <a:buNone/>
             </a:pPr>
             <a:r>
-              <a:rPr lang="en-US" sz="1800" b="1" dirty="0">
+              <a:rPr lang="en-US" sz="1700" b="1" dirty="0">
                 <a:solidFill>
                   <a:srgbClr val="FFFFFF"/>
                 </a:solidFill>
@@ -4573,7 +6714,7 @@
               </a:rPr>
               <a:t>Точная настройка плеера</a:t>
             </a:r>
-            <a:endParaRPr lang="en-US" sz="1800" dirty="0"/>
+            <a:endParaRPr lang="en-US" sz="1700" dirty="0"/>
           </a:p>
         </p:txBody>
       </p:sp>
@@ -4585,24 +6726,24 @@
         </p:nvSpPr>
         <p:spPr>
           <a:xfrm>
-            <a:off x="1417320" y="3931920"/>
-            <a:ext cx="8961120" cy="457200"/>
-          </a:xfrm>
-          <a:prstGeom prst="rect">
-            <a:avLst/>
-          </a:prstGeom>
-          <a:noFill/>
-          <a:ln/>
-        </p:spPr>
-        <p:txBody>
-          <a:bodyPr wrap="square" lIns="0" tIns="0" rIns="0" bIns="0" rtlCol="0" anchor="ctr"/>
-          <a:lstStyle/>
-          <a:p>
-            <a:pPr indent="0" marL="0">
-              <a:buNone/>
-            </a:pPr>
-            <a:r>
-              <a:rPr lang="en-US" sz="1300" dirty="0">
+            <a:off x="1417320" y="3822192"/>
+            <a:ext cx="8961120" cy="411480"/>
+          </a:xfrm>
+          <a:prstGeom prst="rect">
+            <a:avLst/>
+          </a:prstGeom>
+          <a:noFill/>
+          <a:ln/>
+        </p:spPr>
+        <p:txBody>
+          <a:bodyPr wrap="square" lIns="0" tIns="0" rIns="0" bIns="0" rtlCol="0" anchor="ctr"/>
+          <a:lstStyle/>
+          <a:p>
+            <a:pPr indent="0" marL="0">
+              <a:buNone/>
+            </a:pPr>
+            <a:r>
+              <a:rPr lang="en-US" sz="1250" dirty="0">
                 <a:solidFill>
                   <a:srgbClr val="C7CDD9"/>
                 </a:solidFill>
@@ -4612,7 +6753,7 @@
               </a:rPr>
               <a:t>Скорость и громкость отдельно, шаг 1%, повтор в 3 режимах.</a:t>
             </a:r>
-            <a:endParaRPr lang="en-US" sz="1300" dirty="0"/>
+            <a:endParaRPr lang="en-US" sz="1250" dirty="0"/>
           </a:p>
         </p:txBody>
       </p:sp>
@@ -4624,7 +6765,7 @@
         </p:nvSpPr>
         <p:spPr>
           <a:xfrm>
-            <a:off x="822960" y="4526280"/>
+            <a:off x="822960" y="4251960"/>
             <a:ext cx="402336" cy="402336"/>
           </a:xfrm>
           <a:prstGeom prst="ellipse">
@@ -4644,7 +6785,7 @@
         </p:nvSpPr>
         <p:spPr>
           <a:xfrm>
-            <a:off x="822960" y="4526280"/>
+            <a:off x="822960" y="4251960"/>
             <a:ext cx="402336" cy="402336"/>
           </a:xfrm>
           <a:prstGeom prst="rect">
@@ -4683,7 +6824,7 @@
         </p:nvSpPr>
         <p:spPr>
           <a:xfrm>
-            <a:off x="1417320" y="4480560"/>
+            <a:off x="1417320" y="4206240"/>
             <a:ext cx="8961120" cy="365760"/>
           </a:xfrm>
           <a:prstGeom prst="rect">
@@ -4700,7 +6841,7 @@
               <a:buNone/>
             </a:pPr>
             <a:r>
-              <a:rPr lang="en-US" sz="1800" b="1" dirty="0">
+              <a:rPr lang="en-US" sz="1700" b="1" dirty="0">
                 <a:solidFill>
                   <a:srgbClr val="FFFFFF"/>
                 </a:solidFill>
@@ -4710,7 +6851,7 @@
               </a:rPr>
               <a:t>Аналитика WER/CER</a:t>
             </a:r>
-            <a:endParaRPr lang="en-US" sz="1800" dirty="0"/>
+            <a:endParaRPr lang="en-US" sz="1700" dirty="0"/>
           </a:p>
         </p:txBody>
       </p:sp>
@@ -4722,24 +6863,24 @@
         </p:nvSpPr>
         <p:spPr>
           <a:xfrm>
-            <a:off x="1417320" y="4892040"/>
-            <a:ext cx="8961120" cy="457200"/>
-          </a:xfrm>
-          <a:prstGeom prst="rect">
-            <a:avLst/>
-          </a:prstGeom>
-          <a:noFill/>
-          <a:ln/>
-        </p:spPr>
-        <p:txBody>
-          <a:bodyPr wrap="square" lIns="0" tIns="0" rIns="0" bIns="0" rtlCol="0" anchor="ctr"/>
-          <a:lstStyle/>
-          <a:p>
-            <a:pPr indent="0" marL="0">
-              <a:buNone/>
-            </a:pPr>
-            <a:r>
-              <a:rPr lang="en-US" sz="1300" dirty="0">
+            <a:off x="1417320" y="4599432"/>
+            <a:ext cx="8961120" cy="411480"/>
+          </a:xfrm>
+          <a:prstGeom prst="rect">
+            <a:avLst/>
+          </a:prstGeom>
+          <a:noFill/>
+          <a:ln/>
+        </p:spPr>
+        <p:txBody>
+          <a:bodyPr wrap="square" lIns="0" tIns="0" rIns="0" bIns="0" rtlCol="0" anchor="ctr"/>
+          <a:lstStyle/>
+          <a:p>
+            <a:pPr indent="0" marL="0">
+              <a:buNone/>
+            </a:pPr>
+            <a:r>
+              <a:rPr lang="en-US" sz="1250" dirty="0">
                 <a:solidFill>
                   <a:srgbClr val="C7CDD9"/>
                 </a:solidFill>
@@ -4749,75 +6890,173 @@
               </a:rPr>
               <a:t>Готовый дашборд и среднее по проекту — без ручного подсчёта.</a:t>
             </a:r>
-            <a:endParaRPr lang="en-US" sz="1300" dirty="0"/>
-          </a:p>
-        </p:txBody>
-      </p:sp>
-      <p:sp>
-        <p:nvSpPr>
-          <p:cNvPr id="17" name="Text 15"/>
-          <p:cNvSpPr txBox="1"/>
-          <p:nvPr/>
-        </p:nvSpPr>
-        <p:spPr>
-          <a:xfrm>
-            <a:off x="822960" y="5943600"/>
-            <a:ext cx="7315200" cy="365760"/>
-          </a:xfrm>
-          <a:prstGeom prst="rect">
-            <a:avLst/>
-          </a:prstGeom>
-          <a:noFill/>
-          <a:ln/>
-        </p:spPr>
-        <p:txBody>
-          <a:bodyPr wrap="square" lIns="0" tIns="0" rIns="0" bIns="0" rtlCol="0" anchor="ctr"/>
-          <a:lstStyle/>
-          <a:p>
-            <a:pPr indent="0" marL="0">
-              <a:buNone/>
-            </a:pPr>
-            <a:r>
-              <a:rPr lang="en-US" sz="1300" i="1" dirty="0">
-                <a:solidFill>
-                  <a:srgbClr val="6B7280"/>
+            <a:endParaRPr lang="en-US" sz="1250" dirty="0"/>
+          </a:p>
+        </p:txBody>
+      </p:sp>
+      <p:sp>
+        <p:nvSpPr>
+          <p:cNvPr id="17" name="Shape 15"/>
+          <p:cNvSpPr/>
+          <p:nvPr/>
+        </p:nvSpPr>
+        <p:spPr>
+          <a:xfrm>
+            <a:off x="822960" y="5029200"/>
+            <a:ext cx="402336" cy="402336"/>
+          </a:xfrm>
+          <a:prstGeom prst="ellipse">
+            <a:avLst/>
+          </a:prstGeom>
+          <a:solidFill>
+            <a:srgbClr val="F14635"/>
+          </a:solidFill>
+          <a:ln/>
+        </p:spPr>
+      </p:sp>
+      <p:sp>
+        <p:nvSpPr>
+          <p:cNvPr id="18" name="Text 16"/>
+          <p:cNvSpPr txBox="1"/>
+          <p:nvPr/>
+        </p:nvSpPr>
+        <p:spPr>
+          <a:xfrm>
+            <a:off x="822960" y="5029200"/>
+            <a:ext cx="402336" cy="402336"/>
+          </a:xfrm>
+          <a:prstGeom prst="rect">
+            <a:avLst/>
+          </a:prstGeom>
+          <a:noFill/>
+          <a:ln/>
+        </p:spPr>
+        <p:txBody>
+          <a:bodyPr wrap="square" lIns="0" tIns="0" rIns="0" bIns="0" rtlCol="0" anchor="ctr"/>
+          <a:lstStyle/>
+          <a:p>
+            <a:pPr algn="ctr" indent="0" marL="0">
+              <a:buNone/>
+            </a:pPr>
+            <a:r>
+              <a:rPr lang="en-US" sz="1800" b="1" dirty="0">
+                <a:solidFill>
+                  <a:srgbClr val="FFFFFF"/>
+                </a:solidFill>
+                <a:latin typeface="Cambria" pitchFamily="34" charset="0"/>
+                <a:ea typeface="Cambria" pitchFamily="34" charset="-122"/>
+                <a:cs typeface="Cambria" pitchFamily="34" charset="-120"/>
+              </a:rPr>
+              <a:t>4</a:t>
+            </a:r>
+            <a:endParaRPr lang="en-US" sz="1800" dirty="0"/>
+          </a:p>
+        </p:txBody>
+      </p:sp>
+      <p:sp>
+        <p:nvSpPr>
+          <p:cNvPr id="19" name="Text 17"/>
+          <p:cNvSpPr txBox="1"/>
+          <p:nvPr/>
+        </p:nvSpPr>
+        <p:spPr>
+          <a:xfrm>
+            <a:off x="1417320" y="4983480"/>
+            <a:ext cx="8961120" cy="365760"/>
+          </a:xfrm>
+          <a:prstGeom prst="rect">
+            <a:avLst/>
+          </a:prstGeom>
+          <a:noFill/>
+          <a:ln/>
+        </p:spPr>
+        <p:txBody>
+          <a:bodyPr wrap="square" lIns="0" tIns="0" rIns="0" bIns="0" rtlCol="0" anchor="ctr"/>
+          <a:lstStyle/>
+          <a:p>
+            <a:pPr indent="0" marL="0">
+              <a:buNone/>
+            </a:pPr>
+            <a:r>
+              <a:rPr lang="en-US" sz="1700" b="1" dirty="0">
+                <a:solidFill>
+                  <a:srgbClr val="FFFFFF"/>
+                </a:solidFill>
+                <a:latin typeface="Cambria" pitchFamily="34" charset="0"/>
+                <a:ea typeface="Cambria" pitchFamily="34" charset="-122"/>
+                <a:cs typeface="Cambria" pitchFamily="34" charset="-120"/>
+              </a:rPr>
+              <a:t>Label Studio — параллельная оценка</a:t>
+            </a:r>
+            <a:endParaRPr lang="en-US" sz="1700" dirty="0"/>
+          </a:p>
+        </p:txBody>
+      </p:sp>
+      <p:sp>
+        <p:nvSpPr>
+          <p:cNvPr id="20" name="Text 18"/>
+          <p:cNvSpPr txBox="1"/>
+          <p:nvPr/>
+        </p:nvSpPr>
+        <p:spPr>
+          <a:xfrm>
+            <a:off x="1417320" y="5376672"/>
+            <a:ext cx="8961120" cy="411480"/>
+          </a:xfrm>
+          <a:prstGeom prst="rect">
+            <a:avLst/>
+          </a:prstGeom>
+          <a:noFill/>
+          <a:ln/>
+        </p:spPr>
+        <p:txBody>
+          <a:bodyPr wrap="square" lIns="0" tIns="0" rIns="0" bIns="0" rtlCol="0" anchor="ctr"/>
+          <a:lstStyle/>
+          <a:p>
+            <a:pPr indent="0" marL="0">
+              <a:buNone/>
+            </a:pPr>
+            <a:r>
+              <a:rPr lang="en-US" sz="1250" dirty="0">
+                <a:solidFill>
+                  <a:srgbClr val="C7CDD9"/>
                 </a:solidFill>
                 <a:latin typeface="Calibri" pitchFamily="34" charset="0"/>
                 <a:ea typeface="Calibri" pitchFamily="34" charset="-122"/>
                 <a:cs typeface="Calibri" pitchFamily="34" charset="-120"/>
               </a:rPr>
-              <a:t>Обсудим на встрече</a:t>
-            </a:r>
-            <a:endParaRPr lang="en-US" sz="1300" dirty="0"/>
-          </a:p>
-        </p:txBody>
-      </p:sp>
-      <p:sp>
-        <p:nvSpPr>
-          <p:cNvPr id="18" name="Text 16"/>
-          <p:cNvSpPr txBox="1"/>
-          <p:nvPr/>
-        </p:nvSpPr>
-        <p:spPr>
-          <a:xfrm>
-            <a:off x="11551615" y="6446520"/>
-            <a:ext cx="457200" cy="274320"/>
-          </a:xfrm>
-          <a:prstGeom prst="rect">
-            <a:avLst/>
-          </a:prstGeom>
-          <a:noFill/>
-          <a:ln/>
-        </p:spPr>
-        <p:txBody>
-          <a:bodyPr wrap="square" lIns="0" tIns="0" rIns="0" bIns="0" rtlCol="0" anchor="ctr"/>
-          <a:lstStyle/>
-          <a:p>
-            <a:pPr algn="r" indent="0" marL="0">
-              <a:buNone/>
-            </a:pPr>
-            <a:r>
-              <a:rPr lang="en-US" sz="1000" dirty="0">
+              <a:t>Не блокирует остальное: смотрим цену Enterprise и объём миграции отдельно.</a:t>
+            </a:r>
+            <a:endParaRPr lang="en-US" sz="1250" dirty="0"/>
+          </a:p>
+        </p:txBody>
+      </p:sp>
+      <p:sp>
+        <p:nvSpPr>
+          <p:cNvPr id="21" name="Text 19"/>
+          <p:cNvSpPr txBox="1"/>
+          <p:nvPr/>
+        </p:nvSpPr>
+        <p:spPr>
+          <a:xfrm>
+            <a:off x="822960" y="5943600"/>
+            <a:ext cx="7315200" cy="365760"/>
+          </a:xfrm>
+          <a:prstGeom prst="rect">
+            <a:avLst/>
+          </a:prstGeom>
+          <a:noFill/>
+          <a:ln/>
+        </p:spPr>
+        <p:txBody>
+          <a:bodyPr wrap="square" lIns="0" tIns="0" rIns="0" bIns="0" rtlCol="0" anchor="ctr"/>
+          <a:lstStyle/>
+          <a:p>
+            <a:pPr indent="0" marL="0">
+              <a:buNone/>
+            </a:pPr>
+            <a:r>
+              <a:rPr lang="en-US" sz="1300" i="1" dirty="0">
                 <a:solidFill>
                   <a:srgbClr val="6B7280"/>
                 </a:solidFill>
@@ -4825,7 +7064,46 @@
                 <a:ea typeface="Calibri" pitchFamily="34" charset="-122"/>
                 <a:cs typeface="Calibri" pitchFamily="34" charset="-120"/>
               </a:rPr>
-              <a:t>06</a:t>
+              <a:t>Обсудим на встрече</a:t>
+            </a:r>
+            <a:endParaRPr lang="en-US" sz="1300" dirty="0"/>
+          </a:p>
+        </p:txBody>
+      </p:sp>
+      <p:sp>
+        <p:nvSpPr>
+          <p:cNvPr id="22" name="Text 20"/>
+          <p:cNvSpPr txBox="1"/>
+          <p:nvPr/>
+        </p:nvSpPr>
+        <p:spPr>
+          <a:xfrm>
+            <a:off x="11551615" y="6446520"/>
+            <a:ext cx="457200" cy="274320"/>
+          </a:xfrm>
+          <a:prstGeom prst="rect">
+            <a:avLst/>
+          </a:prstGeom>
+          <a:noFill/>
+          <a:ln/>
+        </p:spPr>
+        <p:txBody>
+          <a:bodyPr wrap="square" lIns="0" tIns="0" rIns="0" bIns="0" rtlCol="0" anchor="ctr"/>
+          <a:lstStyle/>
+          <a:p>
+            <a:pPr algn="r" indent="0" marL="0">
+              <a:buNone/>
+            </a:pPr>
+            <a:r>
+              <a:rPr lang="en-US" sz="1000" dirty="0">
+                <a:solidFill>
+                  <a:srgbClr val="6B7280"/>
+                </a:solidFill>
+                <a:latin typeface="Calibri" pitchFamily="34" charset="0"/>
+                <a:ea typeface="Calibri" pitchFamily="34" charset="-122"/>
+                <a:cs typeface="Calibri" pitchFamily="34" charset="-120"/>
+              </a:rPr>
+              <a:t>08</a:t>
             </a:r>
             <a:endParaRPr lang="en-US" sz="1000" dirty="0"/>
           </a:p>

</xml_diff>

<commit_message>
Add Сводная аналитика slide to presentation (filter, internal/external comparison, start/end timeline)
Co-Authored-By: Claude Sonnet 5 <noreply@anthropic.com>
Claude-Session: https://claude.ai/code/session_01UidobC2wtxq4gpGxwXtsNU
</commit_message>
<xml_diff>
--- a/presentation/Kaspi-Markup-presentation.pptx
+++ b/presentation/Kaspi-Markup-presentation.pptx
@@ -13,9 +13,10 @@
     <p:sldId id="261" r:id="rId7"/>
     <p:sldId id="262" r:id="rId8"/>
     <p:sldId id="263" r:id="rId9"/>
+    <p:sldId id="264" r:id="rId10"/>
   </p:sldIdLst>
   <p:notesMasterIdLst>
-    <p:notesMasterId r:id="rId10"/>
+    <p:notesMasterId r:id="rId11"/>
   </p:notesMasterIdLst>
   <p:sldSz cx="12192000" cy="6858000"/>
   <p:notesSz cx="6858000" cy="12192000"/>
@@ -1149,6 +1150,94 @@
             <a:fld id="{F7021451-1387-4CA6-816F-3879F97B5CBC}" type="slidenum">
               <a:rPr lang="en-US"/>
               <a:t>8</a:t>
+            </a:fld>
+            <a:endParaRPr lang="en-US"/>
+          </a:p>
+        </p:txBody>
+      </p:sp>
+    </p:spTree>
+    <p:extLst>
+      <p:ext uri="{BB962C8B-B14F-4D97-AF65-F5344CB8AC3E}">
+        <p14:creationId xmlns:p14="http://schemas.microsoft.com/office/powerpoint/2010/main" val="1024086991"/>
+      </p:ext>
+    </p:extLst>
+  </p:cSld>
+  <p:clrMapOvr>
+    <a:masterClrMapping/>
+  </p:clrMapOvr>
+</p:notes>
+</file>
+
+<file path=ppt/notesSlides/notesSlide9.xml><?xml version="1.0" encoding="utf-8"?>
+<p:notes xmlns:a="http://schemas.openxmlformats.org/drawingml/2006/main" xmlns:r="http://schemas.openxmlformats.org/officeDocument/2006/relationships" xmlns:p="http://schemas.openxmlformats.org/presentationml/2006/main">
+  <p:cSld>
+    <p:spTree>
+      <p:nvGrpSpPr>
+        <p:cNvPr id="1" name=""/>
+        <p:cNvGrpSpPr/>
+        <p:nvPr/>
+      </p:nvGrpSpPr>
+      <p:grpSpPr>
+        <a:xfrm>
+          <a:off x="0" y="0"/>
+          <a:ext cx="0" cy="0"/>
+          <a:chOff x="0" y="0"/>
+          <a:chExt cx="0" cy="0"/>
+        </a:xfrm>
+      </p:grpSpPr>
+      <p:sp>
+        <p:nvSpPr>
+          <p:cNvPr id="2" name="Slide Image Placeholder 1"/>
+          <p:cNvSpPr>
+            <a:spLocks noGrp="1" noRot="1" noChangeAspect="1"/>
+          </p:cNvSpPr>
+          <p:nvPr>
+            <p:ph type="sldImg"/>
+          </p:nvPr>
+        </p:nvSpPr>
+        <p:spPr/>
+      </p:sp>
+      <p:sp>
+        <p:nvSpPr>
+          <p:cNvPr id="3" name="Notes Placeholder 2"/>
+          <p:cNvSpPr>
+            <a:spLocks noGrp="1"/>
+          </p:cNvSpPr>
+          <p:nvPr>
+            <p:ph type="body" idx="1"/>
+          </p:nvPr>
+        </p:nvSpPr>
+        <p:spPr/>
+        <p:txBody>
+          <a:bodyPr/>
+          <a:lstStyle/>
+          <a:p>
+            <a:r>
+              <a:rPr lang="en-US" dirty="0"/>
+              <a:t/>
+            </a:r>
+            <a:endParaRPr lang="en-US" dirty="0"/>
+          </a:p>
+        </p:txBody>
+      </p:sp>
+      <p:sp>
+        <p:nvSpPr>
+          <p:cNvPr id="4" name="Slide Number Placeholder 3"/>
+          <p:cNvSpPr>
+            <a:spLocks noGrp="1"/>
+          </p:cNvSpPr>
+          <p:nvPr>
+            <p:ph type="sldNum" sz="quarter" idx="10"/>
+          </p:nvPr>
+        </p:nvSpPr>
+        <p:spPr/>
+        <p:txBody>
+          <a:bodyPr/>
+          <a:lstStyle/>
+          <a:p>
+            <a:fld id="{F7021451-1387-4CA6-816F-3879F97B5CBC}" type="slidenum">
+              <a:rPr lang="en-US"/>
+              <a:t>9</a:t>
             </a:fld>
             <a:endParaRPr lang="en-US"/>
           </a:p>
@@ -4455,7 +4544,7 @@
                 <a:ea typeface="Calibri" pitchFamily="34" charset="-122"/>
                 <a:cs typeface="Calibri" pitchFamily="34" charset="-120"/>
               </a:rPr>
-              <a:t>ОТДЕЛЬНЫЙ ВОПРОС — НЕ СРОЧНО</a:t>
+              <a:t>УЖЕ СОБРАНО — ДЛЯ АККАУНТА РУКОВОДИТЕЛЯ</a:t>
             </a:r>
             <a:endParaRPr lang="en-US" sz="1100" dirty="0"/>
           </a:p>
@@ -4486,7 +4575,7 @@
               <a:buNone/>
             </a:pPr>
             <a:r>
-              <a:rPr lang="en-US" sz="2600" b="1" dirty="0">
+              <a:rPr lang="en-US" sz="2700" b="1" dirty="0">
                 <a:solidFill>
                   <a:srgbClr val="1C2333"/>
                 </a:solidFill>
@@ -4494,9 +4583,9 @@
                 <a:ea typeface="Cambria" pitchFamily="34" charset="-122"/>
                 <a:cs typeface="Cambria" pitchFamily="34" charset="-120"/>
               </a:rPr>
-              <a:t>Label Studio — реальная альтернатива, если понадобится</a:t>
-            </a:r>
-            <a:endParaRPr lang="en-US" sz="2600" dirty="0"/>
+              <a:t>Сводная аналитика по всем проектам сразу</a:t>
+            </a:r>
+            <a:endParaRPr lang="en-US" sz="2700" dirty="0"/>
           </a:p>
         </p:txBody>
       </p:sp>
@@ -4508,12 +4597,12 @@
         </p:nvSpPr>
         <p:spPr>
           <a:xfrm>
-            <a:off x="640080" y="1691640"/>
-            <a:ext cx="3429000" cy="2331720"/>
+            <a:off x="1816456" y="1463040"/>
+            <a:ext cx="8558784" cy="3998214"/>
           </a:xfrm>
           <a:prstGeom prst="roundRect">
             <a:avLst>
-              <a:gd name="adj" fmla="val 3922"/>
+              <a:gd name="adj" fmla="val 1830"/>
             </a:avLst>
           </a:prstGeom>
           <a:solidFill>
@@ -4526,83 +4615,107 @@
             <a:prstDash val="solid"/>
           </a:ln>
           <a:effectLst>
-            <a:outerShdw sx="100000" sy="100000" kx="0" ky="0" algn="bl" rotWithShape="0" blurRad="76200" dist="25400" dir="5400000">
+            <a:outerShdw sx="100000" sy="100000" kx="0" ky="0" algn="bl" rotWithShape="0" blurRad="88900" dist="25400" dir="5400000">
               <a:srgbClr val="1C2333">
-                <a:alpha val="12000"/>
+                <a:alpha val="14000"/>
               </a:srgbClr>
             </a:outerShdw>
           </a:effectLst>
         </p:spPr>
       </p:sp>
-      <p:sp>
-        <p:nvSpPr>
-          <p:cNvPr id="5" name="Shape 3"/>
+      <p:pic>
+        <p:nvPicPr>
+          <p:cNvPr id="5" name="Image 0" descr="summary-analytics.png">    </p:cNvPr>
+          <p:cNvPicPr>
+            <a:picLocks noChangeAspect="1"/>
+          </p:cNvPicPr>
+          <p:nvPr/>
+        </p:nvPicPr>
+        <p:blipFill>
+          <a:blip r:embed="rId1"/>
+          <a:stretch>
+            <a:fillRect/>
+          </a:stretch>
+        </p:blipFill>
+        <p:spPr>
+          <a:xfrm>
+            <a:off x="1981048" y="1627632"/>
+            <a:ext cx="8229600" cy="3669030"/>
+          </a:xfrm>
+          <a:prstGeom prst="rect">
+            <a:avLst/>
+          </a:prstGeom>
+        </p:spPr>
+      </p:pic>
+      <p:sp>
+        <p:nvSpPr>
+          <p:cNvPr id="6" name="Shape 3"/>
           <p:cNvSpPr/>
           <p:nvPr/>
         </p:nvSpPr>
         <p:spPr>
           <a:xfrm>
-            <a:off x="914400" y="1965960"/>
-            <a:ext cx="402336" cy="402336"/>
+            <a:off x="640080" y="5662422"/>
+            <a:ext cx="73152" cy="73152"/>
           </a:xfrm>
           <a:prstGeom prst="ellipse">
             <a:avLst/>
           </a:prstGeom>
           <a:solidFill>
-            <a:srgbClr val="22C55E"/>
+            <a:srgbClr val="16A34A"/>
           </a:solidFill>
           <a:ln/>
         </p:spPr>
       </p:sp>
       <p:sp>
         <p:nvSpPr>
-          <p:cNvPr id="6" name="Text 4"/>
-          <p:cNvSpPr txBox="1"/>
-          <p:nvPr/>
-        </p:nvSpPr>
-        <p:spPr>
-          <a:xfrm>
-            <a:off x="914400" y="1965960"/>
-            <a:ext cx="402336" cy="402336"/>
-          </a:xfrm>
-          <a:prstGeom prst="rect">
-            <a:avLst/>
-          </a:prstGeom>
-          <a:noFill/>
-          <a:ln/>
-        </p:spPr>
-        <p:txBody>
-          <a:bodyPr wrap="square" lIns="0" tIns="0" rIns="0" bIns="0" rtlCol="0" anchor="ctr"/>
-          <a:lstStyle/>
-          <a:p>
-            <a:pPr algn="ctr" indent="0" marL="0">
-              <a:buNone/>
-            </a:pPr>
-            <a:r>
-              <a:rPr lang="en-US" sz="1800" b="1" dirty="0">
-                <a:solidFill>
-                  <a:srgbClr val="FFFFFF"/>
+          <p:cNvPr id="7" name="Text 4"/>
+          <p:cNvSpPr txBox="1"/>
+          <p:nvPr/>
+        </p:nvSpPr>
+        <p:spPr>
+          <a:xfrm>
+            <a:off x="841248" y="5525262"/>
+            <a:ext cx="3243072" cy="274320"/>
+          </a:xfrm>
+          <a:prstGeom prst="rect">
+            <a:avLst/>
+          </a:prstGeom>
+          <a:noFill/>
+          <a:ln/>
+        </p:spPr>
+        <p:txBody>
+          <a:bodyPr wrap="square" lIns="0" tIns="0" rIns="0" bIns="0" rtlCol="0" anchor="ctr"/>
+          <a:lstStyle/>
+          <a:p>
+            <a:pPr indent="0" marL="0">
+              <a:buNone/>
+            </a:pPr>
+            <a:r>
+              <a:rPr lang="en-US" sz="1150" b="1" dirty="0">
+                <a:solidFill>
+                  <a:srgbClr val="1C2333"/>
                 </a:solidFill>
                 <a:latin typeface="Cambria" pitchFamily="34" charset="0"/>
                 <a:ea typeface="Cambria" pitchFamily="34" charset="-122"/>
                 <a:cs typeface="Cambria" pitchFamily="34" charset="-120"/>
               </a:rPr>
-              <a:t>1</a:t>
-            </a:r>
-            <a:endParaRPr lang="en-US" sz="1800" dirty="0"/>
-          </a:p>
-        </p:txBody>
-      </p:sp>
-      <p:sp>
-        <p:nvSpPr>
-          <p:cNvPr id="7" name="Text 5"/>
-          <p:cNvSpPr txBox="1"/>
-          <p:nvPr/>
-        </p:nvSpPr>
-        <p:spPr>
-          <a:xfrm>
-            <a:off x="914400" y="2560320"/>
-            <a:ext cx="2880360" cy="640080"/>
+              <a:t>Фильтр Внутренние / Внешние</a:t>
+            </a:r>
+            <a:endParaRPr lang="en-US" sz="1150" dirty="0"/>
+          </a:p>
+        </p:txBody>
+      </p:sp>
+      <p:sp>
+        <p:nvSpPr>
+          <p:cNvPr id="8" name="Text 5"/>
+          <p:cNvSpPr txBox="1"/>
+          <p:nvPr/>
+        </p:nvSpPr>
+        <p:spPr>
+          <a:xfrm>
+            <a:off x="841248" y="5808726"/>
+            <a:ext cx="3243072" cy="502920"/>
           </a:xfrm>
           <a:prstGeom prst="rect">
             <a:avLst/>
@@ -4616,12 +4729,71 @@
           <a:p>
             <a:pPr indent="0" marL="0">
               <a:lnSpc>
-                <a:spcPct val="110000"/>
+                <a:spcPct val="112000"/>
               </a:lnSpc>
               <a:buNone/>
             </a:pPr>
             <a:r>
-              <a:rPr lang="en-US" sz="1600" b="1" dirty="0">
+              <a:rPr lang="en-US" sz="950" dirty="0">
+                <a:solidFill>
+                  <a:srgbClr val="6B7280"/>
+                </a:solidFill>
+                <a:latin typeface="Calibri" pitchFamily="34" charset="0"/>
+                <a:ea typeface="Calibri" pitchFamily="34" charset="-122"/>
+                <a:cs typeface="Calibri" pitchFamily="34" charset="-120"/>
+              </a:rPr>
+              <a:t>переключатель над блоками — WER/CER и все графики пересчитываются под выбранную группу исполнителей.</a:t>
+            </a:r>
+            <a:endParaRPr lang="en-US" sz="950" dirty="0"/>
+          </a:p>
+        </p:txBody>
+      </p:sp>
+      <p:sp>
+        <p:nvSpPr>
+          <p:cNvPr id="9" name="Shape 6"/>
+          <p:cNvSpPr/>
+          <p:nvPr/>
+        </p:nvSpPr>
+        <p:spPr>
+          <a:xfrm>
+            <a:off x="4358640" y="5662422"/>
+            <a:ext cx="73152" cy="73152"/>
+          </a:xfrm>
+          <a:prstGeom prst="ellipse">
+            <a:avLst/>
+          </a:prstGeom>
+          <a:solidFill>
+            <a:srgbClr val="16A34A"/>
+          </a:solidFill>
+          <a:ln/>
+        </p:spPr>
+      </p:sp>
+      <p:sp>
+        <p:nvSpPr>
+          <p:cNvPr id="10" name="Text 7"/>
+          <p:cNvSpPr txBox="1"/>
+          <p:nvPr/>
+        </p:nvSpPr>
+        <p:spPr>
+          <a:xfrm>
+            <a:off x="4559808" y="5525262"/>
+            <a:ext cx="3243072" cy="274320"/>
+          </a:xfrm>
+          <a:prstGeom prst="rect">
+            <a:avLst/>
+          </a:prstGeom>
+          <a:noFill/>
+          <a:ln/>
+        </p:spPr>
+        <p:txBody>
+          <a:bodyPr wrap="square" lIns="0" tIns="0" rIns="0" bIns="0" rtlCol="0" anchor="ctr"/>
+          <a:lstStyle/>
+          <a:p>
+            <a:pPr indent="0" marL="0">
+              <a:buNone/>
+            </a:pPr>
+            <a:r>
+              <a:rPr lang="en-US" sz="1150" b="1" dirty="0">
                 <a:solidFill>
                   <a:srgbClr val="1C2333"/>
                 </a:solidFill>
@@ -4629,22 +4801,22 @@
                 <a:ea typeface="Cambria" pitchFamily="34" charset="-122"/>
                 <a:cs typeface="Cambria" pitchFamily="34" charset="-120"/>
               </a:rPr>
-              <a:t>Аудио — из коробки</a:t>
-            </a:r>
-            <a:endParaRPr lang="en-US" sz="1600" dirty="0"/>
-          </a:p>
-        </p:txBody>
-      </p:sp>
-      <p:sp>
-        <p:nvSpPr>
-          <p:cNvPr id="8" name="Text 6"/>
-          <p:cNvSpPr txBox="1"/>
-          <p:nvPr/>
-        </p:nvSpPr>
-        <p:spPr>
-          <a:xfrm>
-            <a:off x="914400" y="3108960"/>
-            <a:ext cx="2880360" cy="822960"/>
+              <a:t>Сравнение внутренних и внешних</a:t>
+            </a:r>
+            <a:endParaRPr lang="en-US" sz="1150" dirty="0"/>
+          </a:p>
+        </p:txBody>
+      </p:sp>
+      <p:sp>
+        <p:nvSpPr>
+          <p:cNvPr id="11" name="Text 8"/>
+          <p:cNvSpPr txBox="1"/>
+          <p:nvPr/>
+        </p:nvSpPr>
+        <p:spPr>
+          <a:xfrm>
+            <a:off x="4559808" y="5808726"/>
+            <a:ext cx="3243072" cy="502920"/>
           </a:xfrm>
           <a:prstGeom prst="rect">
             <a:avLst/>
@@ -4658,12 +4830,12 @@
           <a:p>
             <a:pPr indent="0" marL="0">
               <a:lnSpc>
-                <a:spcPct val="120000"/>
+                <a:spcPct val="112000"/>
               </a:lnSpc>
               <a:buNone/>
             </a:pPr>
             <a:r>
-              <a:rPr lang="en-US" sz="1150" dirty="0">
+              <a:rPr lang="en-US" sz="950" dirty="0">
                 <a:solidFill>
                   <a:srgbClr val="6B7280"/>
                 </a:solidFill>
@@ -4671,115 +4843,81 @@
                 <a:ea typeface="Calibri" pitchFamily="34" charset="-122"/>
                 <a:cs typeface="Calibri" pitchFamily="34" charset="-120"/>
               </a:rPr>
-              <a:t>Готовый шаблон Audio Transcription: плеер + поле транскрипции, ничего собирать не нужно.</a:t>
-            </a:r>
-            <a:endParaRPr lang="en-US" sz="1150" dirty="0"/>
-          </a:p>
-        </p:txBody>
-      </p:sp>
-      <p:sp>
-        <p:nvSpPr>
-          <p:cNvPr id="9" name="Shape 7"/>
+              <a:t>средний WER/CER рядом по каждой группе — видно, где качество проседает, без сведения цифр вручную.</a:t>
+            </a:r>
+            <a:endParaRPr lang="en-US" sz="950" dirty="0"/>
+          </a:p>
+        </p:txBody>
+      </p:sp>
+      <p:sp>
+        <p:nvSpPr>
+          <p:cNvPr id="12" name="Shape 9"/>
           <p:cNvSpPr/>
           <p:nvPr/>
         </p:nvSpPr>
         <p:spPr>
           <a:xfrm>
-            <a:off x="4389120" y="1691640"/>
-            <a:ext cx="3429000" cy="2331720"/>
-          </a:xfrm>
-          <a:prstGeom prst="roundRect">
-            <a:avLst>
-              <a:gd name="adj" fmla="val 3922"/>
-            </a:avLst>
+            <a:off x="8077200" y="5662422"/>
+            <a:ext cx="73152" cy="73152"/>
+          </a:xfrm>
+          <a:prstGeom prst="ellipse">
+            <a:avLst/>
           </a:prstGeom>
           <a:solidFill>
-            <a:srgbClr val="FFFFFF"/>
+            <a:srgbClr val="16A34A"/>
           </a:solidFill>
-          <a:ln w="12700">
-            <a:solidFill>
-              <a:srgbClr val="DDE1E7"/>
-            </a:solidFill>
-            <a:prstDash val="solid"/>
-          </a:ln>
-          <a:effectLst>
-            <a:outerShdw sx="100000" sy="100000" kx="0" ky="0" algn="bl" rotWithShape="0" blurRad="76200" dist="25400" dir="5400000">
-              <a:srgbClr val="1C2333">
-                <a:alpha val="12000"/>
-              </a:srgbClr>
-            </a:outerShdw>
-          </a:effectLst>
-        </p:spPr>
-      </p:sp>
-      <p:sp>
-        <p:nvSpPr>
-          <p:cNvPr id="10" name="Shape 8"/>
-          <p:cNvSpPr/>
-          <p:nvPr/>
-        </p:nvSpPr>
-        <p:spPr>
-          <a:xfrm>
-            <a:off x="4663440" y="1965960"/>
-            <a:ext cx="402336" cy="402336"/>
-          </a:xfrm>
-          <a:prstGeom prst="ellipse">
-            <a:avLst/>
-          </a:prstGeom>
-          <a:solidFill>
-            <a:srgbClr val="22C55E"/>
-          </a:solidFill>
-          <a:ln/>
-        </p:spPr>
-      </p:sp>
-      <p:sp>
-        <p:nvSpPr>
-          <p:cNvPr id="11" name="Text 9"/>
-          <p:cNvSpPr txBox="1"/>
-          <p:nvPr/>
-        </p:nvSpPr>
-        <p:spPr>
-          <a:xfrm>
-            <a:off x="4663440" y="1965960"/>
-            <a:ext cx="402336" cy="402336"/>
-          </a:xfrm>
-          <a:prstGeom prst="rect">
-            <a:avLst/>
-          </a:prstGeom>
-          <a:noFill/>
-          <a:ln/>
-        </p:spPr>
-        <p:txBody>
-          <a:bodyPr wrap="square" lIns="0" tIns="0" rIns="0" bIns="0" rtlCol="0" anchor="ctr"/>
-          <a:lstStyle/>
-          <a:p>
-            <a:pPr algn="ctr" indent="0" marL="0">
-              <a:buNone/>
-            </a:pPr>
-            <a:r>
-              <a:rPr lang="en-US" sz="1800" b="1" dirty="0">
-                <a:solidFill>
-                  <a:srgbClr val="FFFFFF"/>
+          <a:ln/>
+        </p:spPr>
+      </p:sp>
+      <p:sp>
+        <p:nvSpPr>
+          <p:cNvPr id="13" name="Text 10"/>
+          <p:cNvSpPr txBox="1"/>
+          <p:nvPr/>
+        </p:nvSpPr>
+        <p:spPr>
+          <a:xfrm>
+            <a:off x="8278368" y="5525262"/>
+            <a:ext cx="3243072" cy="274320"/>
+          </a:xfrm>
+          <a:prstGeom prst="rect">
+            <a:avLst/>
+          </a:prstGeom>
+          <a:noFill/>
+          <a:ln/>
+        </p:spPr>
+        <p:txBody>
+          <a:bodyPr wrap="square" lIns="0" tIns="0" rIns="0" bIns="0" rtlCol="0" anchor="ctr"/>
+          <a:lstStyle/>
+          <a:p>
+            <a:pPr indent="0" marL="0">
+              <a:buNone/>
+            </a:pPr>
+            <a:r>
+              <a:rPr lang="en-US" sz="1150" b="1" dirty="0">
+                <a:solidFill>
+                  <a:srgbClr val="1C2333"/>
                 </a:solidFill>
                 <a:latin typeface="Cambria" pitchFamily="34" charset="0"/>
                 <a:ea typeface="Cambria" pitchFamily="34" charset="-122"/>
                 <a:cs typeface="Cambria" pitchFamily="34" charset="-120"/>
               </a:rPr>
-              <a:t>2</a:t>
-            </a:r>
-            <a:endParaRPr lang="en-US" sz="1800" dirty="0"/>
-          </a:p>
-        </p:txBody>
-      </p:sp>
-      <p:sp>
-        <p:nvSpPr>
-          <p:cNvPr id="12" name="Text 10"/>
-          <p:cNvSpPr txBox="1"/>
-          <p:nvPr/>
-        </p:nvSpPr>
-        <p:spPr>
-          <a:xfrm>
-            <a:off x="4663440" y="2560320"/>
-            <a:ext cx="2880360" cy="640080"/>
+              <a:t>Когда работала команда сегодня</a:t>
+            </a:r>
+            <a:endParaRPr lang="en-US" sz="1150" dirty="0"/>
+          </a:p>
+        </p:txBody>
+      </p:sp>
+      <p:sp>
+        <p:nvSpPr>
+          <p:cNvPr id="14" name="Text 11"/>
+          <p:cNvSpPr txBox="1"/>
+          <p:nvPr/>
+        </p:nvSpPr>
+        <p:spPr>
+          <a:xfrm>
+            <a:off x="8278368" y="5808726"/>
+            <a:ext cx="3243072" cy="502920"/>
           </a:xfrm>
           <a:prstGeom prst="rect">
             <a:avLst/>
@@ -4793,12 +4931,51 @@
           <a:p>
             <a:pPr indent="0" marL="0">
               <a:lnSpc>
-                <a:spcPct val="110000"/>
+                <a:spcPct val="112000"/>
               </a:lnSpc>
               <a:buNone/>
             </a:pPr>
             <a:r>
-              <a:rPr lang="en-US" sz="1600" b="1" dirty="0">
+              <a:rPr lang="en-US" sz="950" dirty="0">
+                <a:solidFill>
+                  <a:srgbClr val="6B7280"/>
+                </a:solidFill>
+                <a:latin typeface="Calibri" pitchFamily="34" charset="0"/>
+                <a:ea typeface="Calibri" pitchFamily="34" charset="-122"/>
+                <a:cs typeface="Calibri" pitchFamily="34" charset="-120"/>
+              </a:rPr>
+              <a:t>начало и окончание работы каждого исполнителя на общей шкале дня — видно нагрузку и простои сразу.</a:t>
+            </a:r>
+            <a:endParaRPr lang="en-US" sz="950" dirty="0"/>
+          </a:p>
+        </p:txBody>
+      </p:sp>
+      <p:sp>
+        <p:nvSpPr>
+          <p:cNvPr id="15" name="Text 12"/>
+          <p:cNvSpPr txBox="1"/>
+          <p:nvPr/>
+        </p:nvSpPr>
+        <p:spPr>
+          <a:xfrm>
+            <a:off x="502920" y="6446520"/>
+            <a:ext cx="2743200" cy="274320"/>
+          </a:xfrm>
+          <a:prstGeom prst="rect">
+            <a:avLst/>
+          </a:prstGeom>
+          <a:noFill/>
+          <a:ln/>
+        </p:spPr>
+        <p:txBody>
+          <a:bodyPr wrap="square" lIns="0" tIns="0" rIns="0" bIns="0" rtlCol="0" anchor="ctr"/>
+          <a:lstStyle/>
+          <a:p>
+            <a:pPr indent="0" marL="0">
+              <a:buNone/>
+            </a:pPr>
+            <a:r>
+              <a:rPr lang="en-US" sz="1050" b="1" dirty="0">
                 <a:solidFill>
                   <a:srgbClr val="1C2333"/>
                 </a:solidFill>
@@ -4806,287 +4983,21 @@
                 <a:ea typeface="Cambria" pitchFamily="34" charset="-122"/>
                 <a:cs typeface="Cambria" pitchFamily="34" charset="-120"/>
               </a:rPr>
-              <a:t>Свои данные, свой экспорт</a:t>
-            </a:r>
-            <a:endParaRPr lang="en-US" sz="1600" dirty="0"/>
-          </a:p>
-        </p:txBody>
-      </p:sp>
-      <p:sp>
-        <p:nvSpPr>
-          <p:cNvPr id="13" name="Text 11"/>
-          <p:cNvSpPr txBox="1"/>
-          <p:nvPr/>
-        </p:nvSpPr>
-        <p:spPr>
-          <a:xfrm>
-            <a:off x="4663440" y="3108960"/>
-            <a:ext cx="2880360" cy="822960"/>
-          </a:xfrm>
-          <a:prstGeom prst="rect">
-            <a:avLst/>
-          </a:prstGeom>
-          <a:noFill/>
-          <a:ln/>
-        </p:spPr>
-        <p:txBody>
-          <a:bodyPr wrap="square" lIns="0" tIns="0" rIns="0" bIns="0" rtlCol="0" anchor="ctr"/>
-          <a:lstStyle/>
-          <a:p>
-            <a:pPr indent="0" marL="0">
-              <a:lnSpc>
-                <a:spcPct val="120000"/>
-              </a:lnSpc>
-              <a:buNone/>
-            </a:pPr>
-            <a:r>
-              <a:rPr lang="en-US" sz="1150" dirty="0">
-                <a:solidFill>
-                  <a:srgbClr val="6B7280"/>
-                </a:solidFill>
-                <a:latin typeface="Calibri" pitchFamily="34" charset="0"/>
-                <a:ea typeface="Calibri" pitchFamily="34" charset="-122"/>
-                <a:cs typeface="Calibri" pitchFamily="34" charset="-120"/>
-              </a:rPr>
-              <a:t>Импорт из CSV/JSON/облака, экспорт в JSON/CSV — данные не заперты внутри системы.</a:t>
-            </a:r>
-            <a:endParaRPr lang="en-US" sz="1150" dirty="0"/>
-          </a:p>
-        </p:txBody>
-      </p:sp>
-      <p:sp>
-        <p:nvSpPr>
-          <p:cNvPr id="14" name="Shape 12"/>
-          <p:cNvSpPr/>
-          <p:nvPr/>
-        </p:nvSpPr>
-        <p:spPr>
-          <a:xfrm>
-            <a:off x="8138160" y="1691640"/>
-            <a:ext cx="3429000" cy="2331720"/>
-          </a:xfrm>
-          <a:prstGeom prst="roundRect">
-            <a:avLst>
-              <a:gd name="adj" fmla="val 3922"/>
-            </a:avLst>
-          </a:prstGeom>
-          <a:solidFill>
-            <a:srgbClr val="FFFFFF"/>
-          </a:solidFill>
-          <a:ln w="12700">
-            <a:solidFill>
-              <a:srgbClr val="DDE1E7"/>
-            </a:solidFill>
-            <a:prstDash val="solid"/>
-          </a:ln>
-          <a:effectLst>
-            <a:outerShdw sx="100000" sy="100000" kx="0" ky="0" algn="bl" rotWithShape="0" blurRad="76200" dist="25400" dir="5400000">
-              <a:srgbClr val="1C2333">
-                <a:alpha val="12000"/>
-              </a:srgbClr>
-            </a:outerShdw>
-          </a:effectLst>
-        </p:spPr>
-      </p:sp>
-      <p:sp>
-        <p:nvSpPr>
-          <p:cNvPr id="15" name="Shape 13"/>
-          <p:cNvSpPr/>
-          <p:nvPr/>
-        </p:nvSpPr>
-        <p:spPr>
-          <a:xfrm>
-            <a:off x="8412480" y="1965960"/>
-            <a:ext cx="402336" cy="402336"/>
-          </a:xfrm>
-          <a:prstGeom prst="ellipse">
-            <a:avLst/>
-          </a:prstGeom>
-          <a:solidFill>
-            <a:srgbClr val="22C55E"/>
-          </a:solidFill>
-          <a:ln/>
-        </p:spPr>
-      </p:sp>
-      <p:sp>
-        <p:nvSpPr>
-          <p:cNvPr id="16" name="Text 14"/>
-          <p:cNvSpPr txBox="1"/>
-          <p:nvPr/>
-        </p:nvSpPr>
-        <p:spPr>
-          <a:xfrm>
-            <a:off x="8412480" y="1965960"/>
-            <a:ext cx="402336" cy="402336"/>
-          </a:xfrm>
-          <a:prstGeom prst="rect">
-            <a:avLst/>
-          </a:prstGeom>
-          <a:noFill/>
-          <a:ln/>
-        </p:spPr>
-        <p:txBody>
-          <a:bodyPr wrap="square" lIns="0" tIns="0" rIns="0" bIns="0" rtlCol="0" anchor="ctr"/>
-          <a:lstStyle/>
-          <a:p>
-            <a:pPr algn="ctr" indent="0" marL="0">
-              <a:buNone/>
-            </a:pPr>
-            <a:r>
-              <a:rPr lang="en-US" sz="1800" b="1" dirty="0">
-                <a:solidFill>
-                  <a:srgbClr val="FFFFFF"/>
+              <a:t>Kaspi </a:t>
+            </a:r>
+            <a:pPr indent="0" marL="0">
+              <a:buNone/>
+            </a:pPr>
+            <a:r>
+              <a:rPr lang="en-US" sz="1050" b="1" dirty="0">
+                <a:solidFill>
+                  <a:srgbClr val="F14635"/>
                 </a:solidFill>
                 <a:latin typeface="Cambria" pitchFamily="34" charset="0"/>
                 <a:ea typeface="Cambria" pitchFamily="34" charset="-122"/>
                 <a:cs typeface="Cambria" pitchFamily="34" charset="-120"/>
               </a:rPr>
-              <a:t>3</a:t>
-            </a:r>
-            <a:endParaRPr lang="en-US" sz="1800" dirty="0"/>
-          </a:p>
-        </p:txBody>
-      </p:sp>
-      <p:sp>
-        <p:nvSpPr>
-          <p:cNvPr id="17" name="Text 15"/>
-          <p:cNvSpPr txBox="1"/>
-          <p:nvPr/>
-        </p:nvSpPr>
-        <p:spPr>
-          <a:xfrm>
-            <a:off x="8412480" y="2560320"/>
-            <a:ext cx="2880360" cy="640080"/>
-          </a:xfrm>
-          <a:prstGeom prst="rect">
-            <a:avLst/>
-          </a:prstGeom>
-          <a:noFill/>
-          <a:ln/>
-        </p:spPr>
-        <p:txBody>
-          <a:bodyPr wrap="square" lIns="0" tIns="0" rIns="0" bIns="0" rtlCol="0" anchor="ctr"/>
-          <a:lstStyle/>
-          <a:p>
-            <a:pPr indent="0" marL="0">
-              <a:lnSpc>
-                <a:spcPct val="110000"/>
-              </a:lnSpc>
-              <a:buNone/>
-            </a:pPr>
-            <a:r>
-              <a:rPr lang="en-US" sz="1600" b="1" dirty="0">
-                <a:solidFill>
-                  <a:srgbClr val="1C2333"/>
-                </a:solidFill>
-                <a:latin typeface="Cambria" pitchFamily="34" charset="0"/>
-                <a:ea typeface="Cambria" pitchFamily="34" charset="-122"/>
-                <a:cs typeface="Cambria" pitchFamily="34" charset="-120"/>
-              </a:rPr>
-              <a:t>Сравнение аннотаторов встроено</a:t>
-            </a:r>
-            <a:endParaRPr lang="en-US" sz="1600" dirty="0"/>
-          </a:p>
-        </p:txBody>
-      </p:sp>
-      <p:sp>
-        <p:nvSpPr>
-          <p:cNvPr id="18" name="Text 16"/>
-          <p:cNvSpPr txBox="1"/>
-          <p:nvPr/>
-        </p:nvSpPr>
-        <p:spPr>
-          <a:xfrm>
-            <a:off x="8412480" y="3108960"/>
-            <a:ext cx="2880360" cy="822960"/>
-          </a:xfrm>
-          <a:prstGeom prst="rect">
-            <a:avLst/>
-          </a:prstGeom>
-          <a:noFill/>
-          <a:ln/>
-        </p:spPr>
-        <p:txBody>
-          <a:bodyPr wrap="square" lIns="0" tIns="0" rIns="0" bIns="0" rtlCol="0" anchor="ctr"/>
-          <a:lstStyle/>
-          <a:p>
-            <a:pPr indent="0" marL="0">
-              <a:lnSpc>
-                <a:spcPct val="120000"/>
-              </a:lnSpc>
-              <a:buNone/>
-            </a:pPr>
-            <a:r>
-              <a:rPr lang="en-US" sz="1150" dirty="0">
-                <a:solidFill>
-                  <a:srgbClr val="6B7280"/>
-                </a:solidFill>
-                <a:latin typeface="Calibri" pitchFamily="34" charset="0"/>
-                <a:ea typeface="Calibri" pitchFamily="34" charset="-122"/>
-                <a:cs typeface="Calibri" pitchFamily="34" charset="-120"/>
-              </a:rPr>
-              <a:t>Есть готовая метрика согласованности (agreement) между разметчиками — то же самое, что делает ваш ассессор.</a:t>
-            </a:r>
-            <a:endParaRPr lang="en-US" sz="1150" dirty="0"/>
-          </a:p>
-        </p:txBody>
-      </p:sp>
-      <p:sp>
-        <p:nvSpPr>
-          <p:cNvPr id="19" name="Shape 17"/>
-          <p:cNvSpPr/>
-          <p:nvPr/>
-        </p:nvSpPr>
-        <p:spPr>
-          <a:xfrm>
-            <a:off x="640080" y="4343400"/>
-            <a:ext cx="10881360" cy="1234440"/>
-          </a:xfrm>
-          <a:prstGeom prst="roundRect">
-            <a:avLst>
-              <a:gd name="adj" fmla="val 7407"/>
-            </a:avLst>
-          </a:prstGeom>
-          <a:solidFill>
-            <a:srgbClr val="1C2333"/>
-          </a:solidFill>
-          <a:ln/>
-        </p:spPr>
-      </p:sp>
-      <p:sp>
-        <p:nvSpPr>
-          <p:cNvPr id="20" name="Text 18"/>
-          <p:cNvSpPr txBox="1"/>
-          <p:nvPr/>
-        </p:nvSpPr>
-        <p:spPr>
-          <a:xfrm>
-            <a:off x="914400" y="4507992"/>
-            <a:ext cx="10241280" cy="274320"/>
-          </a:xfrm>
-          <a:prstGeom prst="rect">
-            <a:avLst/>
-          </a:prstGeom>
-          <a:noFill/>
-          <a:ln/>
-        </p:spPr>
-        <p:txBody>
-          <a:bodyPr wrap="square" lIns="0" tIns="0" rIns="0" bIns="0" rtlCol="0" anchor="ctr"/>
-          <a:lstStyle/>
-          <a:p>
-            <a:pPr indent="0" marL="0">
-              <a:buNone/>
-            </a:pPr>
-            <a:r>
-              <a:rPr lang="en-US" sz="1050" b="1" spc="100" kern="0" dirty="0">
-                <a:solidFill>
-                  <a:srgbClr val="4ADE80"/>
-                </a:solidFill>
-                <a:latin typeface="Calibri" pitchFamily="34" charset="0"/>
-                <a:ea typeface="Calibri" pitchFamily="34" charset="-122"/>
-                <a:cs typeface="Calibri" pitchFamily="34" charset="-120"/>
-              </a:rPr>
-              <a:t>КАК С ЭТИМ СПРАВЛЯЮТСЯ ЗА ГРАНИЦЕЙ</a:t>
+              <a:t>Markup</a:t>
             </a:r>
             <a:endParaRPr lang="en-US" sz="1050" dirty="0"/>
           </a:p>
@@ -5094,102 +5005,7 @@
       </p:sp>
       <p:sp>
         <p:nvSpPr>
-          <p:cNvPr id="21" name="Text 19"/>
-          <p:cNvSpPr txBox="1"/>
-          <p:nvPr/>
-        </p:nvSpPr>
-        <p:spPr>
-          <a:xfrm>
-            <a:off x="914400" y="4782312"/>
-            <a:ext cx="10241280" cy="731520"/>
-          </a:xfrm>
-          <a:prstGeom prst="rect">
-            <a:avLst/>
-          </a:prstGeom>
-          <a:noFill/>
-          <a:ln/>
-        </p:spPr>
-        <p:txBody>
-          <a:bodyPr wrap="square" lIns="0" tIns="0" rIns="0" bIns="0" rtlCol="0" anchor="ctr"/>
-          <a:lstStyle/>
-          <a:p>
-            <a:pPr indent="0" marL="0">
-              <a:lnSpc>
-                <a:spcPct val="125000"/>
-              </a:lnSpc>
-              <a:buNone/>
-            </a:pPr>
-            <a:r>
-              <a:rPr lang="en-US" sz="1250" dirty="0">
-                <a:solidFill>
-                  <a:srgbClr val="E2E8F0"/>
-                </a:solidFill>
-                <a:latin typeface="Calibri" pitchFamily="34" charset="0"/>
-                <a:ea typeface="Calibri" pitchFamily="34" charset="-122"/>
-                <a:cs typeface="Calibri" pitchFamily="34" charset="-120"/>
-              </a:rPr>
-              <a:t>NVIDIA использует Label Studio именно для разметки речи: модель делает черновую транскрипцию (NeMo ASR) → человек проверяет и правит в Label Studio → экспорт для дообучения модели. Практически один в один наш процесс с STT.</a:t>
-            </a:r>
-            <a:endParaRPr lang="en-US" sz="1250" dirty="0"/>
-          </a:p>
-        </p:txBody>
-      </p:sp>
-      <p:sp>
-        <p:nvSpPr>
-          <p:cNvPr id="22" name="Text 20"/>
-          <p:cNvSpPr txBox="1"/>
-          <p:nvPr/>
-        </p:nvSpPr>
-        <p:spPr>
-          <a:xfrm>
-            <a:off x="502920" y="6446520"/>
-            <a:ext cx="2743200" cy="274320"/>
-          </a:xfrm>
-          <a:prstGeom prst="rect">
-            <a:avLst/>
-          </a:prstGeom>
-          <a:noFill/>
-          <a:ln/>
-        </p:spPr>
-        <p:txBody>
-          <a:bodyPr wrap="square" lIns="0" tIns="0" rIns="0" bIns="0" rtlCol="0" anchor="ctr"/>
-          <a:lstStyle/>
-          <a:p>
-            <a:pPr indent="0" marL="0">
-              <a:buNone/>
-            </a:pPr>
-            <a:r>
-              <a:rPr lang="en-US" sz="1050" b="1" dirty="0">
-                <a:solidFill>
-                  <a:srgbClr val="1C2333"/>
-                </a:solidFill>
-                <a:latin typeface="Cambria" pitchFamily="34" charset="0"/>
-                <a:ea typeface="Cambria" pitchFamily="34" charset="-122"/>
-                <a:cs typeface="Cambria" pitchFamily="34" charset="-120"/>
-              </a:rPr>
-              <a:t>Kaspi </a:t>
-            </a:r>
-            <a:pPr indent="0" marL="0">
-              <a:buNone/>
-            </a:pPr>
-            <a:r>
-              <a:rPr lang="en-US" sz="1050" b="1" dirty="0">
-                <a:solidFill>
-                  <a:srgbClr val="F14635"/>
-                </a:solidFill>
-                <a:latin typeface="Cambria" pitchFamily="34" charset="0"/>
-                <a:ea typeface="Cambria" pitchFamily="34" charset="-122"/>
-                <a:cs typeface="Cambria" pitchFamily="34" charset="-120"/>
-              </a:rPr>
-              <a:t>Markup</a:t>
-            </a:r>
-            <a:endParaRPr lang="en-US" sz="1050" dirty="0"/>
-          </a:p>
-        </p:txBody>
-      </p:sp>
-      <p:sp>
-        <p:nvSpPr>
-          <p:cNvPr id="23" name="Text 21"/>
+          <p:cNvPr id="16" name="Text 13"/>
           <p:cNvSpPr txBox="1"/>
           <p:nvPr/>
         </p:nvSpPr>
@@ -5291,7 +5107,7 @@
                 <a:ea typeface="Calibri" pitchFamily="34" charset="-122"/>
                 <a:cs typeface="Calibri" pitchFamily="34" charset="-120"/>
               </a:rPr>
-              <a:t>СТЕК И СТОИМОСТЬ</a:t>
+              <a:t>ОТДЕЛЬНЫЙ ВОПРОС — НЕ СРОЧНО</a:t>
             </a:r>
             <a:endParaRPr lang="en-US" sz="1100" dirty="0"/>
           </a:p>
@@ -5322,7 +5138,7 @@
               <a:buNone/>
             </a:pPr>
             <a:r>
-              <a:rPr lang="en-US" sz="2800" b="1" dirty="0">
+              <a:rPr lang="en-US" sz="2600" b="1" dirty="0">
                 <a:solidFill>
                   <a:srgbClr val="1C2333"/>
                 </a:solidFill>
@@ -5330,9 +5146,9 @@
                 <a:ea typeface="Cambria" pitchFamily="34" charset="-122"/>
                 <a:cs typeface="Cambria" pitchFamily="34" charset="-120"/>
               </a:rPr>
-              <a:t>Что дешевле — не так однозначно</a:t>
-            </a:r>
-            <a:endParaRPr lang="en-US" sz="2800" dirty="0"/>
+              <a:t>Label Studio — реальная альтернатива, если понадобится</a:t>
+            </a:r>
+            <a:endParaRPr lang="en-US" sz="2600" dirty="0"/>
           </a:p>
         </p:txBody>
       </p:sp>
@@ -5345,160 +5161,100 @@
         <p:spPr>
           <a:xfrm>
             <a:off x="640080" y="1691640"/>
-            <a:ext cx="10881360" cy="457200"/>
+            <a:ext cx="3429000" cy="2331720"/>
           </a:xfrm>
           <a:prstGeom prst="roundRect">
             <a:avLst>
-              <a:gd name="adj" fmla="val 12000"/>
+              <a:gd name="adj" fmla="val 3922"/>
             </a:avLst>
-          </a:prstGeom>
-          <a:solidFill>
-            <a:srgbClr val="1C2333"/>
-          </a:solidFill>
-          <a:ln/>
-        </p:spPr>
-      </p:sp>
-      <p:sp>
-        <p:nvSpPr>
-          <p:cNvPr id="5" name="Text 3"/>
-          <p:cNvSpPr txBox="1"/>
-          <p:nvPr/>
-        </p:nvSpPr>
-        <p:spPr>
-          <a:xfrm>
-            <a:off x="640080" y="1691640"/>
-            <a:ext cx="3017520" cy="457200"/>
-          </a:xfrm>
-          <a:prstGeom prst="rect">
-            <a:avLst/>
-          </a:prstGeom>
-          <a:noFill/>
-          <a:ln/>
-        </p:spPr>
-        <p:txBody>
-          <a:bodyPr wrap="square" lIns="0" tIns="0" rIns="0" bIns="0" rtlCol="0" anchor="ctr"/>
-          <a:lstStyle/>
-          <a:p>
-            <a:pPr indent="0" marL="0">
-              <a:buNone/>
-            </a:pPr>
-            <a:endParaRPr lang="en-US" dirty="0"/>
-          </a:p>
-        </p:txBody>
-      </p:sp>
-      <p:sp>
-        <p:nvSpPr>
-          <p:cNvPr id="6" name="Text 4"/>
-          <p:cNvSpPr txBox="1"/>
-          <p:nvPr/>
-        </p:nvSpPr>
-        <p:spPr>
-          <a:xfrm>
-            <a:off x="3657600" y="1691640"/>
-            <a:ext cx="3931920" cy="457200"/>
-          </a:xfrm>
-          <a:prstGeom prst="rect">
-            <a:avLst/>
-          </a:prstGeom>
-          <a:noFill/>
-          <a:ln/>
-        </p:spPr>
-        <p:txBody>
-          <a:bodyPr wrap="square" lIns="0" tIns="0" rIns="0" bIns="0" rtlCol="0" anchor="ctr"/>
-          <a:lstStyle/>
-          <a:p>
-            <a:pPr algn="ctr" indent="0" marL="0">
-              <a:buNone/>
-            </a:pPr>
-            <a:r>
-              <a:rPr lang="en-US" sz="1300" b="1" spc="100" kern="0" dirty="0">
-                <a:solidFill>
-                  <a:srgbClr val="FFFFFF"/>
-                </a:solidFill>
-                <a:latin typeface="Calibri" pitchFamily="34" charset="0"/>
-                <a:ea typeface="Calibri" pitchFamily="34" charset="-122"/>
-                <a:cs typeface="Calibri" pitchFamily="34" charset="-120"/>
-              </a:rPr>
-              <a:t>PRODIGY</a:t>
-            </a:r>
-            <a:endParaRPr lang="en-US" sz="1300" dirty="0"/>
-          </a:p>
-        </p:txBody>
-      </p:sp>
-      <p:sp>
-        <p:nvSpPr>
-          <p:cNvPr id="7" name="Text 5"/>
-          <p:cNvSpPr txBox="1"/>
-          <p:nvPr/>
-        </p:nvSpPr>
-        <p:spPr>
-          <a:xfrm>
-            <a:off x="7589520" y="1691640"/>
-            <a:ext cx="3931920" cy="457200"/>
-          </a:xfrm>
-          <a:prstGeom prst="rect">
-            <a:avLst/>
-          </a:prstGeom>
-          <a:noFill/>
-          <a:ln/>
-        </p:spPr>
-        <p:txBody>
-          <a:bodyPr wrap="square" lIns="0" tIns="0" rIns="0" bIns="0" rtlCol="0" anchor="ctr"/>
-          <a:lstStyle/>
-          <a:p>
-            <a:pPr algn="ctr" indent="0" marL="0">
-              <a:buNone/>
-            </a:pPr>
-            <a:r>
-              <a:rPr lang="en-US" sz="1300" b="1" spc="100" kern="0" dirty="0">
-                <a:solidFill>
-                  <a:srgbClr val="4ADE80"/>
-                </a:solidFill>
-                <a:latin typeface="Calibri" pitchFamily="34" charset="0"/>
-                <a:ea typeface="Calibri" pitchFamily="34" charset="-122"/>
-                <a:cs typeface="Calibri" pitchFamily="34" charset="-120"/>
-              </a:rPr>
-              <a:t>LABEL STUDIO</a:t>
-            </a:r>
-            <a:endParaRPr lang="en-US" sz="1300" dirty="0"/>
-          </a:p>
-        </p:txBody>
-      </p:sp>
-      <p:sp>
-        <p:nvSpPr>
-          <p:cNvPr id="8" name="Shape 6"/>
-          <p:cNvSpPr/>
-          <p:nvPr/>
-        </p:nvSpPr>
-        <p:spPr>
-          <a:xfrm>
-            <a:off x="640080" y="2148840"/>
-            <a:ext cx="10881360" cy="658368"/>
-          </a:xfrm>
-          <a:prstGeom prst="rect">
-            <a:avLst/>
           </a:prstGeom>
           <a:solidFill>
             <a:srgbClr val="FFFFFF"/>
           </a:solidFill>
-          <a:ln w="9525">
+          <a:ln w="12700">
             <a:solidFill>
               <a:srgbClr val="DDE1E7"/>
             </a:solidFill>
             <a:prstDash val="solid"/>
           </a:ln>
-        </p:spPr>
-      </p:sp>
-      <p:sp>
-        <p:nvSpPr>
-          <p:cNvPr id="9" name="Text 7"/>
-          <p:cNvSpPr txBox="1"/>
-          <p:nvPr/>
-        </p:nvSpPr>
-        <p:spPr>
-          <a:xfrm>
-            <a:off x="822960" y="2148840"/>
-            <a:ext cx="2743200" cy="658368"/>
+          <a:effectLst>
+            <a:outerShdw sx="100000" sy="100000" kx="0" ky="0" algn="bl" rotWithShape="0" blurRad="76200" dist="25400" dir="5400000">
+              <a:srgbClr val="1C2333">
+                <a:alpha val="12000"/>
+              </a:srgbClr>
+            </a:outerShdw>
+          </a:effectLst>
+        </p:spPr>
+      </p:sp>
+      <p:sp>
+        <p:nvSpPr>
+          <p:cNvPr id="5" name="Shape 3"/>
+          <p:cNvSpPr/>
+          <p:nvPr/>
+        </p:nvSpPr>
+        <p:spPr>
+          <a:xfrm>
+            <a:off x="914400" y="1965960"/>
+            <a:ext cx="402336" cy="402336"/>
+          </a:xfrm>
+          <a:prstGeom prst="ellipse">
+            <a:avLst/>
+          </a:prstGeom>
+          <a:solidFill>
+            <a:srgbClr val="22C55E"/>
+          </a:solidFill>
+          <a:ln/>
+        </p:spPr>
+      </p:sp>
+      <p:sp>
+        <p:nvSpPr>
+          <p:cNvPr id="6" name="Text 4"/>
+          <p:cNvSpPr txBox="1"/>
+          <p:nvPr/>
+        </p:nvSpPr>
+        <p:spPr>
+          <a:xfrm>
+            <a:off x="914400" y="1965960"/>
+            <a:ext cx="402336" cy="402336"/>
+          </a:xfrm>
+          <a:prstGeom prst="rect">
+            <a:avLst/>
+          </a:prstGeom>
+          <a:noFill/>
+          <a:ln/>
+        </p:spPr>
+        <p:txBody>
+          <a:bodyPr wrap="square" lIns="0" tIns="0" rIns="0" bIns="0" rtlCol="0" anchor="ctr"/>
+          <a:lstStyle/>
+          <a:p>
+            <a:pPr algn="ctr" indent="0" marL="0">
+              <a:buNone/>
+            </a:pPr>
+            <a:r>
+              <a:rPr lang="en-US" sz="1800" b="1" dirty="0">
+                <a:solidFill>
+                  <a:srgbClr val="FFFFFF"/>
+                </a:solidFill>
+                <a:latin typeface="Cambria" pitchFamily="34" charset="0"/>
+                <a:ea typeface="Cambria" pitchFamily="34" charset="-122"/>
+                <a:cs typeface="Cambria" pitchFamily="34" charset="-120"/>
+              </a:rPr>
+              <a:t>1</a:t>
+            </a:r>
+            <a:endParaRPr lang="en-US" sz="1800" dirty="0"/>
+          </a:p>
+        </p:txBody>
+      </p:sp>
+      <p:sp>
+        <p:nvSpPr>
+          <p:cNvPr id="7" name="Text 5"/>
+          <p:cNvSpPr txBox="1"/>
+          <p:nvPr/>
+        </p:nvSpPr>
+        <p:spPr>
+          <a:xfrm>
+            <a:off x="914400" y="2560320"/>
+            <a:ext cx="2880360" cy="640080"/>
           </a:xfrm>
           <a:prstGeom prst="rect">
             <a:avLst/>
@@ -5517,7 +5273,7 @@
               <a:buNone/>
             </a:pPr>
             <a:r>
-              <a:rPr lang="en-US" sz="1250" b="1" dirty="0">
+              <a:rPr lang="en-US" sz="1600" b="1" dirty="0">
                 <a:solidFill>
                   <a:srgbClr val="1C2333"/>
                 </a:solidFill>
@@ -5525,22 +5281,22 @@
                 <a:ea typeface="Cambria" pitchFamily="34" charset="-122"/>
                 <a:cs typeface="Cambria" pitchFamily="34" charset="-120"/>
               </a:rPr>
-              <a:t>Фронтенд</a:t>
-            </a:r>
-            <a:endParaRPr lang="en-US" sz="1250" dirty="0"/>
-          </a:p>
-        </p:txBody>
-      </p:sp>
-      <p:sp>
-        <p:nvSpPr>
-          <p:cNvPr id="10" name="Text 8"/>
-          <p:cNvSpPr txBox="1"/>
-          <p:nvPr/>
-        </p:nvSpPr>
-        <p:spPr>
-          <a:xfrm>
-            <a:off x="3794760" y="2148840"/>
-            <a:ext cx="3657600" cy="658368"/>
+              <a:t>Аудио — из коробки</a:t>
+            </a:r>
+            <a:endParaRPr lang="en-US" sz="1600" dirty="0"/>
+          </a:p>
+        </p:txBody>
+      </p:sp>
+      <p:sp>
+        <p:nvSpPr>
+          <p:cNvPr id="8" name="Text 6"/>
+          <p:cNvSpPr txBox="1"/>
+          <p:nvPr/>
+        </p:nvSpPr>
+        <p:spPr>
+          <a:xfrm>
+            <a:off x="914400" y="3108960"/>
+            <a:ext cx="2880360" cy="822960"/>
           </a:xfrm>
           <a:prstGeom prst="rect">
             <a:avLst/>
@@ -5554,12 +5310,12 @@
           <a:p>
             <a:pPr indent="0" marL="0">
               <a:lnSpc>
-                <a:spcPct val="110000"/>
+                <a:spcPct val="120000"/>
               </a:lnSpc>
               <a:buNone/>
             </a:pPr>
             <a:r>
-              <a:rPr lang="en-US" sz="1200" dirty="0">
+              <a:rPr lang="en-US" sz="1150" dirty="0">
                 <a:solidFill>
                   <a:srgbClr val="6B7280"/>
                 </a:solidFill>
@@ -5567,89 +5323,115 @@
                 <a:ea typeface="Calibri" pitchFamily="34" charset="-122"/>
                 <a:cs typeface="Calibri" pitchFamily="34" charset="-120"/>
               </a:rPr>
-              <a:t>Svelte, закрытый исходный код</a:t>
-            </a:r>
-            <a:endParaRPr lang="en-US" sz="1200" dirty="0"/>
-          </a:p>
-        </p:txBody>
-      </p:sp>
-      <p:sp>
-        <p:nvSpPr>
-          <p:cNvPr id="11" name="Text 9"/>
-          <p:cNvSpPr txBox="1"/>
-          <p:nvPr/>
-        </p:nvSpPr>
-        <p:spPr>
-          <a:xfrm>
-            <a:off x="7726680" y="2148840"/>
-            <a:ext cx="3657600" cy="658368"/>
-          </a:xfrm>
-          <a:prstGeom prst="rect">
-            <a:avLst/>
-          </a:prstGeom>
-          <a:noFill/>
-          <a:ln/>
-        </p:spPr>
-        <p:txBody>
-          <a:bodyPr wrap="square" lIns="0" tIns="0" rIns="0" bIns="0" rtlCol="0" anchor="ctr"/>
-          <a:lstStyle/>
-          <a:p>
-            <a:pPr indent="0" marL="0">
-              <a:lnSpc>
-                <a:spcPct val="110000"/>
-              </a:lnSpc>
-              <a:buNone/>
-            </a:pPr>
-            <a:r>
-              <a:rPr lang="en-US" sz="1200" dirty="0">
-                <a:solidFill>
-                  <a:srgbClr val="1C2333"/>
-                </a:solidFill>
-                <a:latin typeface="Calibri" pitchFamily="34" charset="0"/>
-                <a:ea typeface="Calibri" pitchFamily="34" charset="-122"/>
-                <a:cs typeface="Calibri" pitchFamily="34" charset="-120"/>
-              </a:rPr>
-              <a:t>React, открытый исходный код</a:t>
-            </a:r>
-            <a:endParaRPr lang="en-US" sz="1200" dirty="0"/>
-          </a:p>
-        </p:txBody>
-      </p:sp>
-      <p:sp>
-        <p:nvSpPr>
-          <p:cNvPr id="12" name="Shape 10"/>
+              <a:t>Готовый шаблон Audio Transcription: плеер + поле транскрипции, ничего собирать не нужно.</a:t>
+            </a:r>
+            <a:endParaRPr lang="en-US" sz="1150" dirty="0"/>
+          </a:p>
+        </p:txBody>
+      </p:sp>
+      <p:sp>
+        <p:nvSpPr>
+          <p:cNvPr id="9" name="Shape 7"/>
           <p:cNvSpPr/>
           <p:nvPr/>
         </p:nvSpPr>
         <p:spPr>
           <a:xfrm>
-            <a:off x="640080" y="2807208"/>
-            <a:ext cx="10881360" cy="658368"/>
-          </a:xfrm>
-          <a:prstGeom prst="rect">
-            <a:avLst/>
+            <a:off x="4389120" y="1691640"/>
+            <a:ext cx="3429000" cy="2331720"/>
+          </a:xfrm>
+          <a:prstGeom prst="roundRect">
+            <a:avLst>
+              <a:gd name="adj" fmla="val 3922"/>
+            </a:avLst>
           </a:prstGeom>
           <a:solidFill>
-            <a:srgbClr val="ECEEF1"/>
+            <a:srgbClr val="FFFFFF"/>
           </a:solidFill>
-          <a:ln w="9525">
+          <a:ln w="12700">
             <a:solidFill>
               <a:srgbClr val="DDE1E7"/>
             </a:solidFill>
             <a:prstDash val="solid"/>
           </a:ln>
-        </p:spPr>
-      </p:sp>
-      <p:sp>
-        <p:nvSpPr>
-          <p:cNvPr id="13" name="Text 11"/>
-          <p:cNvSpPr txBox="1"/>
-          <p:nvPr/>
-        </p:nvSpPr>
-        <p:spPr>
-          <a:xfrm>
-            <a:off x="822960" y="2807208"/>
-            <a:ext cx="2743200" cy="658368"/>
+          <a:effectLst>
+            <a:outerShdw sx="100000" sy="100000" kx="0" ky="0" algn="bl" rotWithShape="0" blurRad="76200" dist="25400" dir="5400000">
+              <a:srgbClr val="1C2333">
+                <a:alpha val="12000"/>
+              </a:srgbClr>
+            </a:outerShdw>
+          </a:effectLst>
+        </p:spPr>
+      </p:sp>
+      <p:sp>
+        <p:nvSpPr>
+          <p:cNvPr id="10" name="Shape 8"/>
+          <p:cNvSpPr/>
+          <p:nvPr/>
+        </p:nvSpPr>
+        <p:spPr>
+          <a:xfrm>
+            <a:off x="4663440" y="1965960"/>
+            <a:ext cx="402336" cy="402336"/>
+          </a:xfrm>
+          <a:prstGeom prst="ellipse">
+            <a:avLst/>
+          </a:prstGeom>
+          <a:solidFill>
+            <a:srgbClr val="22C55E"/>
+          </a:solidFill>
+          <a:ln/>
+        </p:spPr>
+      </p:sp>
+      <p:sp>
+        <p:nvSpPr>
+          <p:cNvPr id="11" name="Text 9"/>
+          <p:cNvSpPr txBox="1"/>
+          <p:nvPr/>
+        </p:nvSpPr>
+        <p:spPr>
+          <a:xfrm>
+            <a:off x="4663440" y="1965960"/>
+            <a:ext cx="402336" cy="402336"/>
+          </a:xfrm>
+          <a:prstGeom prst="rect">
+            <a:avLst/>
+          </a:prstGeom>
+          <a:noFill/>
+          <a:ln/>
+        </p:spPr>
+        <p:txBody>
+          <a:bodyPr wrap="square" lIns="0" tIns="0" rIns="0" bIns="0" rtlCol="0" anchor="ctr"/>
+          <a:lstStyle/>
+          <a:p>
+            <a:pPr algn="ctr" indent="0" marL="0">
+              <a:buNone/>
+            </a:pPr>
+            <a:r>
+              <a:rPr lang="en-US" sz="1800" b="1" dirty="0">
+                <a:solidFill>
+                  <a:srgbClr val="FFFFFF"/>
+                </a:solidFill>
+                <a:latin typeface="Cambria" pitchFamily="34" charset="0"/>
+                <a:ea typeface="Cambria" pitchFamily="34" charset="-122"/>
+                <a:cs typeface="Cambria" pitchFamily="34" charset="-120"/>
+              </a:rPr>
+              <a:t>2</a:t>
+            </a:r>
+            <a:endParaRPr lang="en-US" sz="1800" dirty="0"/>
+          </a:p>
+        </p:txBody>
+      </p:sp>
+      <p:sp>
+        <p:nvSpPr>
+          <p:cNvPr id="12" name="Text 10"/>
+          <p:cNvSpPr txBox="1"/>
+          <p:nvPr/>
+        </p:nvSpPr>
+        <p:spPr>
+          <a:xfrm>
+            <a:off x="4663440" y="2560320"/>
+            <a:ext cx="2880360" cy="640080"/>
           </a:xfrm>
           <a:prstGeom prst="rect">
             <a:avLst/>
@@ -5668,7 +5450,7 @@
               <a:buNone/>
             </a:pPr>
             <a:r>
-              <a:rPr lang="en-US" sz="1250" b="1" dirty="0">
+              <a:rPr lang="en-US" sz="1600" b="1" dirty="0">
                 <a:solidFill>
                   <a:srgbClr val="1C2333"/>
                 </a:solidFill>
@@ -5676,22 +5458,22 @@
                 <a:ea typeface="Cambria" pitchFamily="34" charset="-122"/>
                 <a:cs typeface="Cambria" pitchFamily="34" charset="-120"/>
               </a:rPr>
-              <a:t>Кастомизация</a:t>
-            </a:r>
-            <a:endParaRPr lang="en-US" sz="1250" dirty="0"/>
-          </a:p>
-        </p:txBody>
-      </p:sp>
-      <p:sp>
-        <p:nvSpPr>
-          <p:cNvPr id="14" name="Text 12"/>
-          <p:cNvSpPr txBox="1"/>
-          <p:nvPr/>
-        </p:nvSpPr>
-        <p:spPr>
-          <a:xfrm>
-            <a:off x="3794760" y="2807208"/>
-            <a:ext cx="3657600" cy="658368"/>
+              <a:t>Свои данные, свой экспорт</a:t>
+            </a:r>
+            <a:endParaRPr lang="en-US" sz="1600" dirty="0"/>
+          </a:p>
+        </p:txBody>
+      </p:sp>
+      <p:sp>
+        <p:nvSpPr>
+          <p:cNvPr id="13" name="Text 11"/>
+          <p:cNvSpPr txBox="1"/>
+          <p:nvPr/>
+        </p:nvSpPr>
+        <p:spPr>
+          <a:xfrm>
+            <a:off x="4663440" y="3108960"/>
+            <a:ext cx="2880360" cy="822960"/>
           </a:xfrm>
           <a:prstGeom prst="rect">
             <a:avLst/>
@@ -5705,12 +5487,12 @@
           <a:p>
             <a:pPr indent="0" marL="0">
               <a:lnSpc>
-                <a:spcPct val="110000"/>
+                <a:spcPct val="120000"/>
               </a:lnSpc>
               <a:buNone/>
             </a:pPr>
             <a:r>
-              <a:rPr lang="en-US" sz="1200" dirty="0">
+              <a:rPr lang="en-US" sz="1150" dirty="0">
                 <a:solidFill>
                   <a:srgbClr val="6B7280"/>
                 </a:solidFill>
@@ -5718,78 +5500,104 @@
                 <a:ea typeface="Calibri" pitchFamily="34" charset="-122"/>
                 <a:cs typeface="Calibri" pitchFamily="34" charset="-120"/>
               </a:rPr>
-              <a:t>Только через config-хуки</a:t>
-            </a:r>
-            <a:endParaRPr lang="en-US" sz="1200" dirty="0"/>
-          </a:p>
-        </p:txBody>
-      </p:sp>
-      <p:sp>
-        <p:nvSpPr>
-          <p:cNvPr id="15" name="Text 13"/>
-          <p:cNvSpPr txBox="1"/>
-          <p:nvPr/>
-        </p:nvSpPr>
-        <p:spPr>
-          <a:xfrm>
-            <a:off x="7726680" y="2807208"/>
-            <a:ext cx="3657600" cy="658368"/>
-          </a:xfrm>
-          <a:prstGeom prst="rect">
-            <a:avLst/>
-          </a:prstGeom>
-          <a:noFill/>
-          <a:ln/>
-        </p:spPr>
-        <p:txBody>
-          <a:bodyPr wrap="square" lIns="0" tIns="0" rIns="0" bIns="0" rtlCol="0" anchor="ctr"/>
-          <a:lstStyle/>
-          <a:p>
-            <a:pPr indent="0" marL="0">
-              <a:lnSpc>
-                <a:spcPct val="110000"/>
-              </a:lnSpc>
-              <a:buNone/>
-            </a:pPr>
-            <a:r>
-              <a:rPr lang="en-US" sz="1200" dirty="0">
-                <a:solidFill>
-                  <a:srgbClr val="1C2333"/>
-                </a:solidFill>
-                <a:latin typeface="Calibri" pitchFamily="34" charset="0"/>
-                <a:ea typeface="Calibri" pitchFamily="34" charset="-122"/>
-                <a:cs typeface="Calibri" pitchFamily="34" charset="-120"/>
-              </a:rPr>
-              <a:t>Можно менять исходники напрямую</a:t>
-            </a:r>
-            <a:endParaRPr lang="en-US" sz="1200" dirty="0"/>
-          </a:p>
-        </p:txBody>
-      </p:sp>
-      <p:sp>
-        <p:nvSpPr>
-          <p:cNvPr id="16" name="Shape 14"/>
+              <a:t>Импорт из CSV/JSON/облака, экспорт в JSON/CSV — данные не заперты внутри системы.</a:t>
+            </a:r>
+            <a:endParaRPr lang="en-US" sz="1150" dirty="0"/>
+          </a:p>
+        </p:txBody>
+      </p:sp>
+      <p:sp>
+        <p:nvSpPr>
+          <p:cNvPr id="14" name="Shape 12"/>
           <p:cNvSpPr/>
           <p:nvPr/>
         </p:nvSpPr>
         <p:spPr>
           <a:xfrm>
-            <a:off x="640080" y="3465576"/>
-            <a:ext cx="10881360" cy="658368"/>
-          </a:xfrm>
-          <a:prstGeom prst="rect">
-            <a:avLst/>
+            <a:off x="8138160" y="1691640"/>
+            <a:ext cx="3429000" cy="2331720"/>
+          </a:xfrm>
+          <a:prstGeom prst="roundRect">
+            <a:avLst>
+              <a:gd name="adj" fmla="val 3922"/>
+            </a:avLst>
           </a:prstGeom>
           <a:solidFill>
             <a:srgbClr val="FFFFFF"/>
           </a:solidFill>
-          <a:ln w="9525">
+          <a:ln w="12700">
             <a:solidFill>
               <a:srgbClr val="DDE1E7"/>
             </a:solidFill>
             <a:prstDash val="solid"/>
           </a:ln>
-        </p:spPr>
+          <a:effectLst>
+            <a:outerShdw sx="100000" sy="100000" kx="0" ky="0" algn="bl" rotWithShape="0" blurRad="76200" dist="25400" dir="5400000">
+              <a:srgbClr val="1C2333">
+                <a:alpha val="12000"/>
+              </a:srgbClr>
+            </a:outerShdw>
+          </a:effectLst>
+        </p:spPr>
+      </p:sp>
+      <p:sp>
+        <p:nvSpPr>
+          <p:cNvPr id="15" name="Shape 13"/>
+          <p:cNvSpPr/>
+          <p:nvPr/>
+        </p:nvSpPr>
+        <p:spPr>
+          <a:xfrm>
+            <a:off x="8412480" y="1965960"/>
+            <a:ext cx="402336" cy="402336"/>
+          </a:xfrm>
+          <a:prstGeom prst="ellipse">
+            <a:avLst/>
+          </a:prstGeom>
+          <a:solidFill>
+            <a:srgbClr val="22C55E"/>
+          </a:solidFill>
+          <a:ln/>
+        </p:spPr>
+      </p:sp>
+      <p:sp>
+        <p:nvSpPr>
+          <p:cNvPr id="16" name="Text 14"/>
+          <p:cNvSpPr txBox="1"/>
+          <p:nvPr/>
+        </p:nvSpPr>
+        <p:spPr>
+          <a:xfrm>
+            <a:off x="8412480" y="1965960"/>
+            <a:ext cx="402336" cy="402336"/>
+          </a:xfrm>
+          <a:prstGeom prst="rect">
+            <a:avLst/>
+          </a:prstGeom>
+          <a:noFill/>
+          <a:ln/>
+        </p:spPr>
+        <p:txBody>
+          <a:bodyPr wrap="square" lIns="0" tIns="0" rIns="0" bIns="0" rtlCol="0" anchor="ctr"/>
+          <a:lstStyle/>
+          <a:p>
+            <a:pPr algn="ctr" indent="0" marL="0">
+              <a:buNone/>
+            </a:pPr>
+            <a:r>
+              <a:rPr lang="en-US" sz="1800" b="1" dirty="0">
+                <a:solidFill>
+                  <a:srgbClr val="FFFFFF"/>
+                </a:solidFill>
+                <a:latin typeface="Cambria" pitchFamily="34" charset="0"/>
+                <a:ea typeface="Cambria" pitchFamily="34" charset="-122"/>
+                <a:cs typeface="Cambria" pitchFamily="34" charset="-120"/>
+              </a:rPr>
+              <a:t>3</a:t>
+            </a:r>
+            <a:endParaRPr lang="en-US" sz="1800" dirty="0"/>
+          </a:p>
+        </p:txBody>
       </p:sp>
       <p:sp>
         <p:nvSpPr>
@@ -5799,8 +5607,8 @@
         </p:nvSpPr>
         <p:spPr>
           <a:xfrm>
-            <a:off x="822960" y="3465576"/>
-            <a:ext cx="2743200" cy="658368"/>
+            <a:off x="8412480" y="2560320"/>
+            <a:ext cx="2880360" cy="640080"/>
           </a:xfrm>
           <a:prstGeom prst="rect">
             <a:avLst/>
@@ -5819,7 +5627,7 @@
               <a:buNone/>
             </a:pPr>
             <a:r>
-              <a:rPr lang="en-US" sz="1250" b="1" dirty="0">
+              <a:rPr lang="en-US" sz="1600" b="1" dirty="0">
                 <a:solidFill>
                   <a:srgbClr val="1C2333"/>
                 </a:solidFill>
@@ -5827,9 +5635,9 @@
                 <a:ea typeface="Cambria" pitchFamily="34" charset="-122"/>
                 <a:cs typeface="Cambria" pitchFamily="34" charset="-120"/>
               </a:rPr>
-              <a:t>Базовая разметка</a:t>
-            </a:r>
-            <a:endParaRPr lang="en-US" sz="1250" dirty="0"/>
+              <a:t>Сравнение аннотаторов встроено</a:t>
+            </a:r>
+            <a:endParaRPr lang="en-US" sz="1600" dirty="0"/>
           </a:p>
         </p:txBody>
       </p:sp>
@@ -5841,8 +5649,8 @@
         </p:nvSpPr>
         <p:spPr>
           <a:xfrm>
-            <a:off x="3794760" y="3465576"/>
-            <a:ext cx="3657600" cy="658368"/>
+            <a:off x="8412480" y="3108960"/>
+            <a:ext cx="2880360" cy="822960"/>
           </a:xfrm>
           <a:prstGeom prst="rect">
             <a:avLst/>
@@ -5856,12 +5664,12 @@
           <a:p>
             <a:pPr indent="0" marL="0">
               <a:lnSpc>
-                <a:spcPct val="110000"/>
+                <a:spcPct val="120000"/>
               </a:lnSpc>
               <a:buNone/>
             </a:pPr>
             <a:r>
-              <a:rPr lang="en-US" sz="1200" dirty="0">
+              <a:rPr lang="en-US" sz="1150" dirty="0">
                 <a:solidFill>
                   <a:srgbClr val="6B7280"/>
                 </a:solidFill>
@@ -5869,78 +5677,72 @@
                 <a:ea typeface="Calibri" pitchFamily="34" charset="-122"/>
                 <a:cs typeface="Calibri" pitchFamily="34" charset="-120"/>
               </a:rPr>
-              <a:t>$490 / место, разовая покупка</a:t>
-            </a:r>
-            <a:endParaRPr lang="en-US" sz="1200" dirty="0"/>
-          </a:p>
-        </p:txBody>
-      </p:sp>
-      <p:sp>
-        <p:nvSpPr>
-          <p:cNvPr id="19" name="Text 17"/>
-          <p:cNvSpPr txBox="1"/>
-          <p:nvPr/>
-        </p:nvSpPr>
-        <p:spPr>
-          <a:xfrm>
-            <a:off x="7726680" y="3465576"/>
-            <a:ext cx="3657600" cy="658368"/>
-          </a:xfrm>
-          <a:prstGeom prst="rect">
-            <a:avLst/>
-          </a:prstGeom>
-          <a:noFill/>
-          <a:ln/>
-        </p:spPr>
-        <p:txBody>
-          <a:bodyPr wrap="square" lIns="0" tIns="0" rIns="0" bIns="0" rtlCol="0" anchor="ctr"/>
-          <a:lstStyle/>
-          <a:p>
-            <a:pPr indent="0" marL="0">
-              <a:lnSpc>
-                <a:spcPct val="110000"/>
-              </a:lnSpc>
-              <a:buNone/>
-            </a:pPr>
-            <a:r>
-              <a:rPr lang="en-US" sz="1200" dirty="0">
-                <a:solidFill>
-                  <a:srgbClr val="1C2333"/>
+              <a:t>Есть готовая метрика согласованности (agreement) между разметчиками — то же самое, что делает ваш ассессор.</a:t>
+            </a:r>
+            <a:endParaRPr lang="en-US" sz="1150" dirty="0"/>
+          </a:p>
+        </p:txBody>
+      </p:sp>
+      <p:sp>
+        <p:nvSpPr>
+          <p:cNvPr id="19" name="Shape 17"/>
+          <p:cNvSpPr/>
+          <p:nvPr/>
+        </p:nvSpPr>
+        <p:spPr>
+          <a:xfrm>
+            <a:off x="640080" y="4343400"/>
+            <a:ext cx="10881360" cy="1234440"/>
+          </a:xfrm>
+          <a:prstGeom prst="roundRect">
+            <a:avLst>
+              <a:gd name="adj" fmla="val 7407"/>
+            </a:avLst>
+          </a:prstGeom>
+          <a:solidFill>
+            <a:srgbClr val="1C2333"/>
+          </a:solidFill>
+          <a:ln/>
+        </p:spPr>
+      </p:sp>
+      <p:sp>
+        <p:nvSpPr>
+          <p:cNvPr id="20" name="Text 18"/>
+          <p:cNvSpPr txBox="1"/>
+          <p:nvPr/>
+        </p:nvSpPr>
+        <p:spPr>
+          <a:xfrm>
+            <a:off x="914400" y="4507992"/>
+            <a:ext cx="10241280" cy="274320"/>
+          </a:xfrm>
+          <a:prstGeom prst="rect">
+            <a:avLst/>
+          </a:prstGeom>
+          <a:noFill/>
+          <a:ln/>
+        </p:spPr>
+        <p:txBody>
+          <a:bodyPr wrap="square" lIns="0" tIns="0" rIns="0" bIns="0" rtlCol="0" anchor="ctr"/>
+          <a:lstStyle/>
+          <a:p>
+            <a:pPr indent="0" marL="0">
+              <a:buNone/>
+            </a:pPr>
+            <a:r>
+              <a:rPr lang="en-US" sz="1050" b="1" spc="100" kern="0" dirty="0">
+                <a:solidFill>
+                  <a:srgbClr val="4ADE80"/>
                 </a:solidFill>
                 <a:latin typeface="Calibri" pitchFamily="34" charset="0"/>
                 <a:ea typeface="Calibri" pitchFamily="34" charset="-122"/>
                 <a:cs typeface="Calibri" pitchFamily="34" charset="-120"/>
               </a:rPr>
-              <a:t>Бесплатно (Apache 2.0), self-host</a:t>
-            </a:r>
-            <a:endParaRPr lang="en-US" sz="1200" dirty="0"/>
-          </a:p>
-        </p:txBody>
-      </p:sp>
-      <p:sp>
-        <p:nvSpPr>
-          <p:cNvPr id="20" name="Shape 18"/>
-          <p:cNvSpPr/>
-          <p:nvPr/>
-        </p:nvSpPr>
-        <p:spPr>
-          <a:xfrm>
-            <a:off x="640080" y="4123944"/>
-            <a:ext cx="10881360" cy="658368"/>
-          </a:xfrm>
-          <a:prstGeom prst="rect">
-            <a:avLst/>
-          </a:prstGeom>
-          <a:solidFill>
-            <a:srgbClr val="ECEEF1"/>
-          </a:solidFill>
-          <a:ln w="9525">
-            <a:solidFill>
-              <a:srgbClr val="DDE1E7"/>
-            </a:solidFill>
-            <a:prstDash val="solid"/>
-          </a:ln>
-        </p:spPr>
+              <a:t>КАК С ЭТИМ СПРАВЛЯЮТСЯ ЗА ГРАНИЦЕЙ</a:t>
+            </a:r>
+            <a:endParaRPr lang="en-US" sz="1050" dirty="0"/>
+          </a:p>
+        </p:txBody>
       </p:sp>
       <p:sp>
         <p:nvSpPr>
@@ -5950,8 +5752,8 @@
         </p:nvSpPr>
         <p:spPr>
           <a:xfrm>
-            <a:off x="822960" y="4123944"/>
-            <a:ext cx="2743200" cy="658368"/>
+            <a:off x="914400" y="4782312"/>
+            <a:ext cx="10241280" cy="731520"/>
           </a:xfrm>
           <a:prstGeom prst="rect">
             <a:avLst/>
@@ -5965,12 +5767,51 @@
           <a:p>
             <a:pPr indent="0" marL="0">
               <a:lnSpc>
-                <a:spcPct val="110000"/>
+                <a:spcPct val="125000"/>
               </a:lnSpc>
               <a:buNone/>
             </a:pPr>
             <a:r>
-              <a:rPr lang="en-US" sz="1250" b="1" dirty="0">
+              <a:rPr lang="en-US" sz="1250" dirty="0">
+                <a:solidFill>
+                  <a:srgbClr val="E2E8F0"/>
+                </a:solidFill>
+                <a:latin typeface="Calibri" pitchFamily="34" charset="0"/>
+                <a:ea typeface="Calibri" pitchFamily="34" charset="-122"/>
+                <a:cs typeface="Calibri" pitchFamily="34" charset="-120"/>
+              </a:rPr>
+              <a:t>NVIDIA использует Label Studio именно для разметки речи: модель делает черновую транскрипцию (NeMo ASR) → человек проверяет и правит в Label Studio → экспорт для дообучения модели. Практически один в один наш процесс с STT.</a:t>
+            </a:r>
+            <a:endParaRPr lang="en-US" sz="1250" dirty="0"/>
+          </a:p>
+        </p:txBody>
+      </p:sp>
+      <p:sp>
+        <p:nvSpPr>
+          <p:cNvPr id="22" name="Text 20"/>
+          <p:cNvSpPr txBox="1"/>
+          <p:nvPr/>
+        </p:nvSpPr>
+        <p:spPr>
+          <a:xfrm>
+            <a:off x="502920" y="6446520"/>
+            <a:ext cx="2743200" cy="274320"/>
+          </a:xfrm>
+          <a:prstGeom prst="rect">
+            <a:avLst/>
+          </a:prstGeom>
+          <a:noFill/>
+          <a:ln/>
+        </p:spPr>
+        <p:txBody>
+          <a:bodyPr wrap="square" lIns="0" tIns="0" rIns="0" bIns="0" rtlCol="0" anchor="ctr"/>
+          <a:lstStyle/>
+          <a:p>
+            <a:pPr indent="0" marL="0">
+              <a:buNone/>
+            </a:pPr>
+            <a:r>
+              <a:rPr lang="en-US" sz="1050" b="1" dirty="0">
                 <a:solidFill>
                   <a:srgbClr val="1C2333"/>
                 </a:solidFill>
@@ -5978,336 +5819,20 @@
                 <a:ea typeface="Cambria" pitchFamily="34" charset="-122"/>
                 <a:cs typeface="Cambria" pitchFamily="34" charset="-120"/>
               </a:rPr>
-              <a:t>Роли и ревью (как на вашем скрине)</a:t>
-            </a:r>
-            <a:endParaRPr lang="en-US" sz="1250" dirty="0"/>
-          </a:p>
-        </p:txBody>
-      </p:sp>
-      <p:sp>
-        <p:nvSpPr>
-          <p:cNvPr id="22" name="Text 20"/>
-          <p:cNvSpPr txBox="1"/>
-          <p:nvPr/>
-        </p:nvSpPr>
-        <p:spPr>
-          <a:xfrm>
-            <a:off x="3794760" y="4123944"/>
-            <a:ext cx="3657600" cy="658368"/>
-          </a:xfrm>
-          <a:prstGeom prst="rect">
-            <a:avLst/>
-          </a:prstGeom>
-          <a:noFill/>
-          <a:ln/>
-        </p:spPr>
-        <p:txBody>
-          <a:bodyPr wrap="square" lIns="0" tIns="0" rIns="0" bIns="0" rtlCol="0" anchor="ctr"/>
-          <a:lstStyle/>
-          <a:p>
-            <a:pPr indent="0" marL="0">
-              <a:lnSpc>
-                <a:spcPct val="110000"/>
-              </a:lnSpc>
-              <a:buNone/>
-            </a:pPr>
-            <a:r>
-              <a:rPr lang="en-US" sz="1200" dirty="0">
-                <a:solidFill>
-                  <a:srgbClr val="6B7280"/>
-                </a:solidFill>
-                <a:latin typeface="Calibri" pitchFamily="34" charset="0"/>
-                <a:ea typeface="Calibri" pitchFamily="34" charset="-122"/>
-                <a:cs typeface="Calibri" pitchFamily="34" charset="-120"/>
-              </a:rPr>
-              <a:t>Входит в лицензию</a:t>
-            </a:r>
-            <a:endParaRPr lang="en-US" sz="1200" dirty="0"/>
-          </a:p>
-        </p:txBody>
-      </p:sp>
-      <p:sp>
-        <p:nvSpPr>
-          <p:cNvPr id="23" name="Text 21"/>
-          <p:cNvSpPr txBox="1"/>
-          <p:nvPr/>
-        </p:nvSpPr>
-        <p:spPr>
-          <a:xfrm>
-            <a:off x="7726680" y="4123944"/>
-            <a:ext cx="3657600" cy="658368"/>
-          </a:xfrm>
-          <a:prstGeom prst="rect">
-            <a:avLst/>
-          </a:prstGeom>
-          <a:noFill/>
-          <a:ln/>
-        </p:spPr>
-        <p:txBody>
-          <a:bodyPr wrap="square" lIns="0" tIns="0" rIns="0" bIns="0" rtlCol="0" anchor="ctr"/>
-          <a:lstStyle/>
-          <a:p>
-            <a:pPr indent="0" marL="0">
-              <a:lnSpc>
-                <a:spcPct val="110000"/>
-              </a:lnSpc>
-              <a:buNone/>
-            </a:pPr>
-            <a:r>
-              <a:rPr lang="en-US" sz="1200" dirty="0">
-                <a:solidFill>
-                  <a:srgbClr val="1C2333"/>
-                </a:solidFill>
-                <a:latin typeface="Calibri" pitchFamily="34" charset="0"/>
-                <a:ea typeface="Calibri" pitchFamily="34" charset="-122"/>
-                <a:cs typeface="Calibri" pitchFamily="34" charset="-120"/>
-              </a:rPr>
-              <a:t>Только в Enterprise — цена по запросу</a:t>
-            </a:r>
-            <a:endParaRPr lang="en-US" sz="1200" dirty="0"/>
-          </a:p>
-        </p:txBody>
-      </p:sp>
-      <p:sp>
-        <p:nvSpPr>
-          <p:cNvPr id="24" name="Shape 22"/>
-          <p:cNvSpPr/>
-          <p:nvPr/>
-        </p:nvSpPr>
-        <p:spPr>
-          <a:xfrm>
-            <a:off x="640080" y="4782312"/>
-            <a:ext cx="10881360" cy="658368"/>
-          </a:xfrm>
-          <a:prstGeom prst="rect">
-            <a:avLst/>
-          </a:prstGeom>
-          <a:solidFill>
-            <a:srgbClr val="FFFFFF"/>
-          </a:solidFill>
-          <a:ln w="9525">
-            <a:solidFill>
-              <a:srgbClr val="DDE1E7"/>
-            </a:solidFill>
-            <a:prstDash val="solid"/>
-          </a:ln>
-        </p:spPr>
-      </p:sp>
-      <p:sp>
-        <p:nvSpPr>
-          <p:cNvPr id="25" name="Text 23"/>
-          <p:cNvSpPr txBox="1"/>
-          <p:nvPr/>
-        </p:nvSpPr>
-        <p:spPr>
-          <a:xfrm>
-            <a:off x="822960" y="4782312"/>
-            <a:ext cx="2743200" cy="658368"/>
-          </a:xfrm>
-          <a:prstGeom prst="rect">
-            <a:avLst/>
-          </a:prstGeom>
-          <a:noFill/>
-          <a:ln/>
-        </p:spPr>
-        <p:txBody>
-          <a:bodyPr wrap="square" lIns="0" tIns="0" rIns="0" bIns="0" rtlCol="0" anchor="ctr"/>
-          <a:lstStyle/>
-          <a:p>
-            <a:pPr indent="0" marL="0">
-              <a:lnSpc>
-                <a:spcPct val="110000"/>
-              </a:lnSpc>
-              <a:buNone/>
-            </a:pPr>
-            <a:r>
-              <a:rPr lang="en-US" sz="1250" b="1" dirty="0">
-                <a:solidFill>
-                  <a:srgbClr val="1C2333"/>
+              <a:t>Kaspi </a:t>
+            </a:r>
+            <a:pPr indent="0" marL="0">
+              <a:buNone/>
+            </a:pPr>
+            <a:r>
+              <a:rPr lang="en-US" sz="1050" b="1" dirty="0">
+                <a:solidFill>
+                  <a:srgbClr val="F14635"/>
                 </a:solidFill>
                 <a:latin typeface="Cambria" pitchFamily="34" charset="0"/>
                 <a:ea typeface="Cambria" pitchFamily="34" charset="-122"/>
                 <a:cs typeface="Cambria" pitchFamily="34" charset="-120"/>
               </a:rPr>
-              <a:t>Аудио + транскрипция</a:t>
-            </a:r>
-            <a:endParaRPr lang="en-US" sz="1250" dirty="0"/>
-          </a:p>
-        </p:txBody>
-      </p:sp>
-      <p:sp>
-        <p:nvSpPr>
-          <p:cNvPr id="26" name="Text 24"/>
-          <p:cNvSpPr txBox="1"/>
-          <p:nvPr/>
-        </p:nvSpPr>
-        <p:spPr>
-          <a:xfrm>
-            <a:off x="3794760" y="4782312"/>
-            <a:ext cx="3657600" cy="658368"/>
-          </a:xfrm>
-          <a:prstGeom prst="rect">
-            <a:avLst/>
-          </a:prstGeom>
-          <a:noFill/>
-          <a:ln/>
-        </p:spPr>
-        <p:txBody>
-          <a:bodyPr wrap="square" lIns="0" tIns="0" rIns="0" bIns="0" rtlCol="0" anchor="ctr"/>
-          <a:lstStyle/>
-          <a:p>
-            <a:pPr indent="0" marL="0">
-              <a:lnSpc>
-                <a:spcPct val="110000"/>
-              </a:lnSpc>
-              <a:buNone/>
-            </a:pPr>
-            <a:r>
-              <a:rPr lang="en-US" sz="1200" dirty="0">
-                <a:solidFill>
-                  <a:srgbClr val="6B7280"/>
-                </a:solidFill>
-                <a:latin typeface="Calibri" pitchFamily="34" charset="0"/>
-                <a:ea typeface="Calibri" pitchFamily="34" charset="-122"/>
-                <a:cs typeface="Calibri" pitchFamily="34" charset="-120"/>
-              </a:rPr>
-              <a:t>Есть (может требовать плагин)</a:t>
-            </a:r>
-            <a:endParaRPr lang="en-US" sz="1200" dirty="0"/>
-          </a:p>
-        </p:txBody>
-      </p:sp>
-      <p:sp>
-        <p:nvSpPr>
-          <p:cNvPr id="27" name="Text 25"/>
-          <p:cNvSpPr txBox="1"/>
-          <p:nvPr/>
-        </p:nvSpPr>
-        <p:spPr>
-          <a:xfrm>
-            <a:off x="7726680" y="4782312"/>
-            <a:ext cx="3657600" cy="658368"/>
-          </a:xfrm>
-          <a:prstGeom prst="rect">
-            <a:avLst/>
-          </a:prstGeom>
-          <a:noFill/>
-          <a:ln/>
-        </p:spPr>
-        <p:txBody>
-          <a:bodyPr wrap="square" lIns="0" tIns="0" rIns="0" bIns="0" rtlCol="0" anchor="ctr"/>
-          <a:lstStyle/>
-          <a:p>
-            <a:pPr indent="0" marL="0">
-              <a:lnSpc>
-                <a:spcPct val="110000"/>
-              </a:lnSpc>
-              <a:buNone/>
-            </a:pPr>
-            <a:r>
-              <a:rPr lang="en-US" sz="1200" dirty="0">
-                <a:solidFill>
-                  <a:srgbClr val="1C2333"/>
-                </a:solidFill>
-                <a:latin typeface="Calibri" pitchFamily="34" charset="0"/>
-                <a:ea typeface="Calibri" pitchFamily="34" charset="-122"/>
-                <a:cs typeface="Calibri" pitchFamily="34" charset="-120"/>
-              </a:rPr>
-              <a:t>Готовый шаблон из коробки</a:t>
-            </a:r>
-            <a:endParaRPr lang="en-US" sz="1200" dirty="0"/>
-          </a:p>
-        </p:txBody>
-      </p:sp>
-      <p:sp>
-        <p:nvSpPr>
-          <p:cNvPr id="28" name="Text 26"/>
-          <p:cNvSpPr txBox="1"/>
-          <p:nvPr/>
-        </p:nvSpPr>
-        <p:spPr>
-          <a:xfrm>
-            <a:off x="640080" y="5623560"/>
-            <a:ext cx="10881360" cy="640080"/>
-          </a:xfrm>
-          <a:prstGeom prst="rect">
-            <a:avLst/>
-          </a:prstGeom>
-          <a:noFill/>
-          <a:ln/>
-        </p:spPr>
-        <p:txBody>
-          <a:bodyPr wrap="square" lIns="0" tIns="0" rIns="0" bIns="0" rtlCol="0" anchor="ctr"/>
-          <a:lstStyle/>
-          <a:p>
-            <a:pPr indent="0" marL="0">
-              <a:lnSpc>
-                <a:spcPct val="125000"/>
-              </a:lnSpc>
-              <a:buNone/>
-            </a:pPr>
-            <a:r>
-              <a:rPr lang="en-US" sz="1200" i="1" dirty="0">
-                <a:solidFill>
-                  <a:srgbClr val="6B7280"/>
-                </a:solidFill>
-                <a:latin typeface="Calibri" pitchFamily="34" charset="0"/>
-                <a:ea typeface="Calibri" pitchFamily="34" charset="-122"/>
-                <a:cs typeface="Calibri" pitchFamily="34" charset="-120"/>
-              </a:rPr>
-              <a:t>Роли/ревью, которые уже есть у нас сегодня, — платная часть в обеих системах. Честное сравнение: не «Prodigy $490 vs Label Studio бесплатно», а лицензия Prodigy vs цена Enterprise Label Studio по запросу — плюс стоимость миграции данных и переобучения команды.</a:t>
-            </a:r>
-            <a:endParaRPr lang="en-US" sz="1200" dirty="0"/>
-          </a:p>
-        </p:txBody>
-      </p:sp>
-      <p:sp>
-        <p:nvSpPr>
-          <p:cNvPr id="29" name="Text 27"/>
-          <p:cNvSpPr txBox="1"/>
-          <p:nvPr/>
-        </p:nvSpPr>
-        <p:spPr>
-          <a:xfrm>
-            <a:off x="502920" y="6446520"/>
-            <a:ext cx="2743200" cy="274320"/>
-          </a:xfrm>
-          <a:prstGeom prst="rect">
-            <a:avLst/>
-          </a:prstGeom>
-          <a:noFill/>
-          <a:ln/>
-        </p:spPr>
-        <p:txBody>
-          <a:bodyPr wrap="square" lIns="0" tIns="0" rIns="0" bIns="0" rtlCol="0" anchor="ctr"/>
-          <a:lstStyle/>
-          <a:p>
-            <a:pPr indent="0" marL="0">
-              <a:buNone/>
-            </a:pPr>
-            <a:r>
-              <a:rPr lang="en-US" sz="1050" b="1" dirty="0">
-                <a:solidFill>
-                  <a:srgbClr val="1C2333"/>
-                </a:solidFill>
-                <a:latin typeface="Cambria" pitchFamily="34" charset="0"/>
-                <a:ea typeface="Cambria" pitchFamily="34" charset="-122"/>
-                <a:cs typeface="Cambria" pitchFamily="34" charset="-120"/>
-              </a:rPr>
-              <a:t>Kaspi </a:t>
-            </a:r>
-            <a:pPr indent="0" marL="0">
-              <a:buNone/>
-            </a:pPr>
-            <a:r>
-              <a:rPr lang="en-US" sz="1050" b="1" dirty="0">
-                <a:solidFill>
-                  <a:srgbClr val="F14635"/>
-                </a:solidFill>
-                <a:latin typeface="Cambria" pitchFamily="34" charset="0"/>
-                <a:ea typeface="Cambria" pitchFamily="34" charset="-122"/>
-                <a:cs typeface="Cambria" pitchFamily="34" charset="-120"/>
-              </a:rPr>
               <a:t>Markup</a:t>
             </a:r>
             <a:endParaRPr lang="en-US" sz="1050" dirty="0"/>
@@ -6316,7 +5841,7 @@
       </p:sp>
       <p:sp>
         <p:nvSpPr>
-          <p:cNvPr id="30" name="Text 28"/>
+          <p:cNvPr id="23" name="Text 21"/>
           <p:cNvSpPr txBox="1"/>
           <p:nvPr/>
         </p:nvSpPr>
@@ -6364,6 +5889,1133 @@
 <file path=ppt/slides/slide8.xml><?xml version="1.0" encoding="utf-8"?>
 <p:sld xmlns:a="http://schemas.openxmlformats.org/drawingml/2006/main" xmlns:r="http://schemas.openxmlformats.org/officeDocument/2006/relationships" xmlns:p="http://schemas.openxmlformats.org/presentationml/2006/main">
   <p:cSld name="Slide 8">
+    <p:bg>
+      <p:bgPr>
+        <a:solidFill>
+          <a:srgbClr val="ECEEF1"/>
+        </a:solidFill>
+      </p:bgPr>
+    </p:bg>
+    <p:spTree>
+      <p:nvGrpSpPr>
+        <p:cNvPr id="1" name=""/>
+        <p:cNvGrpSpPr/>
+        <p:nvPr/>
+      </p:nvGrpSpPr>
+      <p:grpSpPr>
+        <a:xfrm>
+          <a:off x="0" y="0"/>
+          <a:ext cx="0" cy="0"/>
+          <a:chOff x="0" y="0"/>
+          <a:chExt cx="0" cy="0"/>
+        </a:xfrm>
+      </p:grpSpPr>
+      <p:sp>
+        <p:nvSpPr>
+          <p:cNvPr id="2" name="Text 0"/>
+          <p:cNvSpPr txBox="1"/>
+          <p:nvPr/>
+        </p:nvSpPr>
+        <p:spPr>
+          <a:xfrm>
+            <a:off x="640080" y="457200"/>
+            <a:ext cx="8229600" cy="274320"/>
+          </a:xfrm>
+          <a:prstGeom prst="rect">
+            <a:avLst/>
+          </a:prstGeom>
+          <a:noFill/>
+          <a:ln/>
+        </p:spPr>
+        <p:txBody>
+          <a:bodyPr wrap="square" lIns="0" tIns="0" rIns="0" bIns="0" rtlCol="0" anchor="ctr"/>
+          <a:lstStyle/>
+          <a:p>
+            <a:pPr indent="0" marL="0">
+              <a:buNone/>
+            </a:pPr>
+            <a:r>
+              <a:rPr lang="en-US" sz="1100" b="1" spc="200" kern="0" dirty="0">
+                <a:solidFill>
+                  <a:srgbClr val="F14635"/>
+                </a:solidFill>
+                <a:latin typeface="Calibri" pitchFamily="34" charset="0"/>
+                <a:ea typeface="Calibri" pitchFamily="34" charset="-122"/>
+                <a:cs typeface="Calibri" pitchFamily="34" charset="-120"/>
+              </a:rPr>
+              <a:t>СТЕК И СТОИМОСТЬ</a:t>
+            </a:r>
+            <a:endParaRPr lang="en-US" sz="1100" dirty="0"/>
+          </a:p>
+        </p:txBody>
+      </p:sp>
+      <p:sp>
+        <p:nvSpPr>
+          <p:cNvPr id="3" name="Text 1"/>
+          <p:cNvSpPr txBox="1"/>
+          <p:nvPr/>
+        </p:nvSpPr>
+        <p:spPr>
+          <a:xfrm>
+            <a:off x="594360" y="749808"/>
+            <a:ext cx="10881360" cy="548640"/>
+          </a:xfrm>
+          <a:prstGeom prst="rect">
+            <a:avLst/>
+          </a:prstGeom>
+          <a:noFill/>
+          <a:ln/>
+        </p:spPr>
+        <p:txBody>
+          <a:bodyPr wrap="square" lIns="0" tIns="0" rIns="0" bIns="0" rtlCol="0" anchor="ctr"/>
+          <a:lstStyle/>
+          <a:p>
+            <a:pPr indent="0" marL="0">
+              <a:buNone/>
+            </a:pPr>
+            <a:r>
+              <a:rPr lang="en-US" sz="2800" b="1" dirty="0">
+                <a:solidFill>
+                  <a:srgbClr val="1C2333"/>
+                </a:solidFill>
+                <a:latin typeface="Cambria" pitchFamily="34" charset="0"/>
+                <a:ea typeface="Cambria" pitchFamily="34" charset="-122"/>
+                <a:cs typeface="Cambria" pitchFamily="34" charset="-120"/>
+              </a:rPr>
+              <a:t>Что дешевле — не так однозначно</a:t>
+            </a:r>
+            <a:endParaRPr lang="en-US" sz="2800" dirty="0"/>
+          </a:p>
+        </p:txBody>
+      </p:sp>
+      <p:sp>
+        <p:nvSpPr>
+          <p:cNvPr id="4" name="Shape 2"/>
+          <p:cNvSpPr/>
+          <p:nvPr/>
+        </p:nvSpPr>
+        <p:spPr>
+          <a:xfrm>
+            <a:off x="640080" y="1691640"/>
+            <a:ext cx="10881360" cy="457200"/>
+          </a:xfrm>
+          <a:prstGeom prst="roundRect">
+            <a:avLst>
+              <a:gd name="adj" fmla="val 12000"/>
+            </a:avLst>
+          </a:prstGeom>
+          <a:solidFill>
+            <a:srgbClr val="1C2333"/>
+          </a:solidFill>
+          <a:ln/>
+        </p:spPr>
+      </p:sp>
+      <p:sp>
+        <p:nvSpPr>
+          <p:cNvPr id="5" name="Text 3"/>
+          <p:cNvSpPr txBox="1"/>
+          <p:nvPr/>
+        </p:nvSpPr>
+        <p:spPr>
+          <a:xfrm>
+            <a:off x="640080" y="1691640"/>
+            <a:ext cx="3017520" cy="457200"/>
+          </a:xfrm>
+          <a:prstGeom prst="rect">
+            <a:avLst/>
+          </a:prstGeom>
+          <a:noFill/>
+          <a:ln/>
+        </p:spPr>
+        <p:txBody>
+          <a:bodyPr wrap="square" lIns="0" tIns="0" rIns="0" bIns="0" rtlCol="0" anchor="ctr"/>
+          <a:lstStyle/>
+          <a:p>
+            <a:pPr indent="0" marL="0">
+              <a:buNone/>
+            </a:pPr>
+            <a:endParaRPr lang="en-US" dirty="0"/>
+          </a:p>
+        </p:txBody>
+      </p:sp>
+      <p:sp>
+        <p:nvSpPr>
+          <p:cNvPr id="6" name="Text 4"/>
+          <p:cNvSpPr txBox="1"/>
+          <p:nvPr/>
+        </p:nvSpPr>
+        <p:spPr>
+          <a:xfrm>
+            <a:off x="3657600" y="1691640"/>
+            <a:ext cx="3931920" cy="457200"/>
+          </a:xfrm>
+          <a:prstGeom prst="rect">
+            <a:avLst/>
+          </a:prstGeom>
+          <a:noFill/>
+          <a:ln/>
+        </p:spPr>
+        <p:txBody>
+          <a:bodyPr wrap="square" lIns="0" tIns="0" rIns="0" bIns="0" rtlCol="0" anchor="ctr"/>
+          <a:lstStyle/>
+          <a:p>
+            <a:pPr algn="ctr" indent="0" marL="0">
+              <a:buNone/>
+            </a:pPr>
+            <a:r>
+              <a:rPr lang="en-US" sz="1300" b="1" spc="100" kern="0" dirty="0">
+                <a:solidFill>
+                  <a:srgbClr val="FFFFFF"/>
+                </a:solidFill>
+                <a:latin typeface="Calibri" pitchFamily="34" charset="0"/>
+                <a:ea typeface="Calibri" pitchFamily="34" charset="-122"/>
+                <a:cs typeface="Calibri" pitchFamily="34" charset="-120"/>
+              </a:rPr>
+              <a:t>PRODIGY</a:t>
+            </a:r>
+            <a:endParaRPr lang="en-US" sz="1300" dirty="0"/>
+          </a:p>
+        </p:txBody>
+      </p:sp>
+      <p:sp>
+        <p:nvSpPr>
+          <p:cNvPr id="7" name="Text 5"/>
+          <p:cNvSpPr txBox="1"/>
+          <p:nvPr/>
+        </p:nvSpPr>
+        <p:spPr>
+          <a:xfrm>
+            <a:off x="7589520" y="1691640"/>
+            <a:ext cx="3931920" cy="457200"/>
+          </a:xfrm>
+          <a:prstGeom prst="rect">
+            <a:avLst/>
+          </a:prstGeom>
+          <a:noFill/>
+          <a:ln/>
+        </p:spPr>
+        <p:txBody>
+          <a:bodyPr wrap="square" lIns="0" tIns="0" rIns="0" bIns="0" rtlCol="0" anchor="ctr"/>
+          <a:lstStyle/>
+          <a:p>
+            <a:pPr algn="ctr" indent="0" marL="0">
+              <a:buNone/>
+            </a:pPr>
+            <a:r>
+              <a:rPr lang="en-US" sz="1300" b="1" spc="100" kern="0" dirty="0">
+                <a:solidFill>
+                  <a:srgbClr val="4ADE80"/>
+                </a:solidFill>
+                <a:latin typeface="Calibri" pitchFamily="34" charset="0"/>
+                <a:ea typeface="Calibri" pitchFamily="34" charset="-122"/>
+                <a:cs typeface="Calibri" pitchFamily="34" charset="-120"/>
+              </a:rPr>
+              <a:t>LABEL STUDIO</a:t>
+            </a:r>
+            <a:endParaRPr lang="en-US" sz="1300" dirty="0"/>
+          </a:p>
+        </p:txBody>
+      </p:sp>
+      <p:sp>
+        <p:nvSpPr>
+          <p:cNvPr id="8" name="Shape 6"/>
+          <p:cNvSpPr/>
+          <p:nvPr/>
+        </p:nvSpPr>
+        <p:spPr>
+          <a:xfrm>
+            <a:off x="640080" y="2148840"/>
+            <a:ext cx="10881360" cy="658368"/>
+          </a:xfrm>
+          <a:prstGeom prst="rect">
+            <a:avLst/>
+          </a:prstGeom>
+          <a:solidFill>
+            <a:srgbClr val="FFFFFF"/>
+          </a:solidFill>
+          <a:ln w="9525">
+            <a:solidFill>
+              <a:srgbClr val="DDE1E7"/>
+            </a:solidFill>
+            <a:prstDash val="solid"/>
+          </a:ln>
+        </p:spPr>
+      </p:sp>
+      <p:sp>
+        <p:nvSpPr>
+          <p:cNvPr id="9" name="Text 7"/>
+          <p:cNvSpPr txBox="1"/>
+          <p:nvPr/>
+        </p:nvSpPr>
+        <p:spPr>
+          <a:xfrm>
+            <a:off x="822960" y="2148840"/>
+            <a:ext cx="2743200" cy="658368"/>
+          </a:xfrm>
+          <a:prstGeom prst="rect">
+            <a:avLst/>
+          </a:prstGeom>
+          <a:noFill/>
+          <a:ln/>
+        </p:spPr>
+        <p:txBody>
+          <a:bodyPr wrap="square" lIns="0" tIns="0" rIns="0" bIns="0" rtlCol="0" anchor="ctr"/>
+          <a:lstStyle/>
+          <a:p>
+            <a:pPr indent="0" marL="0">
+              <a:lnSpc>
+                <a:spcPct val="110000"/>
+              </a:lnSpc>
+              <a:buNone/>
+            </a:pPr>
+            <a:r>
+              <a:rPr lang="en-US" sz="1250" b="1" dirty="0">
+                <a:solidFill>
+                  <a:srgbClr val="1C2333"/>
+                </a:solidFill>
+                <a:latin typeface="Cambria" pitchFamily="34" charset="0"/>
+                <a:ea typeface="Cambria" pitchFamily="34" charset="-122"/>
+                <a:cs typeface="Cambria" pitchFamily="34" charset="-120"/>
+              </a:rPr>
+              <a:t>Фронтенд</a:t>
+            </a:r>
+            <a:endParaRPr lang="en-US" sz="1250" dirty="0"/>
+          </a:p>
+        </p:txBody>
+      </p:sp>
+      <p:sp>
+        <p:nvSpPr>
+          <p:cNvPr id="10" name="Text 8"/>
+          <p:cNvSpPr txBox="1"/>
+          <p:nvPr/>
+        </p:nvSpPr>
+        <p:spPr>
+          <a:xfrm>
+            <a:off x="3794760" y="2148840"/>
+            <a:ext cx="3657600" cy="658368"/>
+          </a:xfrm>
+          <a:prstGeom prst="rect">
+            <a:avLst/>
+          </a:prstGeom>
+          <a:noFill/>
+          <a:ln/>
+        </p:spPr>
+        <p:txBody>
+          <a:bodyPr wrap="square" lIns="0" tIns="0" rIns="0" bIns="0" rtlCol="0" anchor="ctr"/>
+          <a:lstStyle/>
+          <a:p>
+            <a:pPr indent="0" marL="0">
+              <a:lnSpc>
+                <a:spcPct val="110000"/>
+              </a:lnSpc>
+              <a:buNone/>
+            </a:pPr>
+            <a:r>
+              <a:rPr lang="en-US" sz="1200" dirty="0">
+                <a:solidFill>
+                  <a:srgbClr val="6B7280"/>
+                </a:solidFill>
+                <a:latin typeface="Calibri" pitchFamily="34" charset="0"/>
+                <a:ea typeface="Calibri" pitchFamily="34" charset="-122"/>
+                <a:cs typeface="Calibri" pitchFamily="34" charset="-120"/>
+              </a:rPr>
+              <a:t>Svelte, закрытый исходный код</a:t>
+            </a:r>
+            <a:endParaRPr lang="en-US" sz="1200" dirty="0"/>
+          </a:p>
+        </p:txBody>
+      </p:sp>
+      <p:sp>
+        <p:nvSpPr>
+          <p:cNvPr id="11" name="Text 9"/>
+          <p:cNvSpPr txBox="1"/>
+          <p:nvPr/>
+        </p:nvSpPr>
+        <p:spPr>
+          <a:xfrm>
+            <a:off x="7726680" y="2148840"/>
+            <a:ext cx="3657600" cy="658368"/>
+          </a:xfrm>
+          <a:prstGeom prst="rect">
+            <a:avLst/>
+          </a:prstGeom>
+          <a:noFill/>
+          <a:ln/>
+        </p:spPr>
+        <p:txBody>
+          <a:bodyPr wrap="square" lIns="0" tIns="0" rIns="0" bIns="0" rtlCol="0" anchor="ctr"/>
+          <a:lstStyle/>
+          <a:p>
+            <a:pPr indent="0" marL="0">
+              <a:lnSpc>
+                <a:spcPct val="110000"/>
+              </a:lnSpc>
+              <a:buNone/>
+            </a:pPr>
+            <a:r>
+              <a:rPr lang="en-US" sz="1200" dirty="0">
+                <a:solidFill>
+                  <a:srgbClr val="1C2333"/>
+                </a:solidFill>
+                <a:latin typeface="Calibri" pitchFamily="34" charset="0"/>
+                <a:ea typeface="Calibri" pitchFamily="34" charset="-122"/>
+                <a:cs typeface="Calibri" pitchFamily="34" charset="-120"/>
+              </a:rPr>
+              <a:t>React, открытый исходный код</a:t>
+            </a:r>
+            <a:endParaRPr lang="en-US" sz="1200" dirty="0"/>
+          </a:p>
+        </p:txBody>
+      </p:sp>
+      <p:sp>
+        <p:nvSpPr>
+          <p:cNvPr id="12" name="Shape 10"/>
+          <p:cNvSpPr/>
+          <p:nvPr/>
+        </p:nvSpPr>
+        <p:spPr>
+          <a:xfrm>
+            <a:off x="640080" y="2807208"/>
+            <a:ext cx="10881360" cy="658368"/>
+          </a:xfrm>
+          <a:prstGeom prst="rect">
+            <a:avLst/>
+          </a:prstGeom>
+          <a:solidFill>
+            <a:srgbClr val="ECEEF1"/>
+          </a:solidFill>
+          <a:ln w="9525">
+            <a:solidFill>
+              <a:srgbClr val="DDE1E7"/>
+            </a:solidFill>
+            <a:prstDash val="solid"/>
+          </a:ln>
+        </p:spPr>
+      </p:sp>
+      <p:sp>
+        <p:nvSpPr>
+          <p:cNvPr id="13" name="Text 11"/>
+          <p:cNvSpPr txBox="1"/>
+          <p:nvPr/>
+        </p:nvSpPr>
+        <p:spPr>
+          <a:xfrm>
+            <a:off x="822960" y="2807208"/>
+            <a:ext cx="2743200" cy="658368"/>
+          </a:xfrm>
+          <a:prstGeom prst="rect">
+            <a:avLst/>
+          </a:prstGeom>
+          <a:noFill/>
+          <a:ln/>
+        </p:spPr>
+        <p:txBody>
+          <a:bodyPr wrap="square" lIns="0" tIns="0" rIns="0" bIns="0" rtlCol="0" anchor="ctr"/>
+          <a:lstStyle/>
+          <a:p>
+            <a:pPr indent="0" marL="0">
+              <a:lnSpc>
+                <a:spcPct val="110000"/>
+              </a:lnSpc>
+              <a:buNone/>
+            </a:pPr>
+            <a:r>
+              <a:rPr lang="en-US" sz="1250" b="1" dirty="0">
+                <a:solidFill>
+                  <a:srgbClr val="1C2333"/>
+                </a:solidFill>
+                <a:latin typeface="Cambria" pitchFamily="34" charset="0"/>
+                <a:ea typeface="Cambria" pitchFamily="34" charset="-122"/>
+                <a:cs typeface="Cambria" pitchFamily="34" charset="-120"/>
+              </a:rPr>
+              <a:t>Кастомизация</a:t>
+            </a:r>
+            <a:endParaRPr lang="en-US" sz="1250" dirty="0"/>
+          </a:p>
+        </p:txBody>
+      </p:sp>
+      <p:sp>
+        <p:nvSpPr>
+          <p:cNvPr id="14" name="Text 12"/>
+          <p:cNvSpPr txBox="1"/>
+          <p:nvPr/>
+        </p:nvSpPr>
+        <p:spPr>
+          <a:xfrm>
+            <a:off x="3794760" y="2807208"/>
+            <a:ext cx="3657600" cy="658368"/>
+          </a:xfrm>
+          <a:prstGeom prst="rect">
+            <a:avLst/>
+          </a:prstGeom>
+          <a:noFill/>
+          <a:ln/>
+        </p:spPr>
+        <p:txBody>
+          <a:bodyPr wrap="square" lIns="0" tIns="0" rIns="0" bIns="0" rtlCol="0" anchor="ctr"/>
+          <a:lstStyle/>
+          <a:p>
+            <a:pPr indent="0" marL="0">
+              <a:lnSpc>
+                <a:spcPct val="110000"/>
+              </a:lnSpc>
+              <a:buNone/>
+            </a:pPr>
+            <a:r>
+              <a:rPr lang="en-US" sz="1200" dirty="0">
+                <a:solidFill>
+                  <a:srgbClr val="6B7280"/>
+                </a:solidFill>
+                <a:latin typeface="Calibri" pitchFamily="34" charset="0"/>
+                <a:ea typeface="Calibri" pitchFamily="34" charset="-122"/>
+                <a:cs typeface="Calibri" pitchFamily="34" charset="-120"/>
+              </a:rPr>
+              <a:t>Только через config-хуки</a:t>
+            </a:r>
+            <a:endParaRPr lang="en-US" sz="1200" dirty="0"/>
+          </a:p>
+        </p:txBody>
+      </p:sp>
+      <p:sp>
+        <p:nvSpPr>
+          <p:cNvPr id="15" name="Text 13"/>
+          <p:cNvSpPr txBox="1"/>
+          <p:nvPr/>
+        </p:nvSpPr>
+        <p:spPr>
+          <a:xfrm>
+            <a:off x="7726680" y="2807208"/>
+            <a:ext cx="3657600" cy="658368"/>
+          </a:xfrm>
+          <a:prstGeom prst="rect">
+            <a:avLst/>
+          </a:prstGeom>
+          <a:noFill/>
+          <a:ln/>
+        </p:spPr>
+        <p:txBody>
+          <a:bodyPr wrap="square" lIns="0" tIns="0" rIns="0" bIns="0" rtlCol="0" anchor="ctr"/>
+          <a:lstStyle/>
+          <a:p>
+            <a:pPr indent="0" marL="0">
+              <a:lnSpc>
+                <a:spcPct val="110000"/>
+              </a:lnSpc>
+              <a:buNone/>
+            </a:pPr>
+            <a:r>
+              <a:rPr lang="en-US" sz="1200" dirty="0">
+                <a:solidFill>
+                  <a:srgbClr val="1C2333"/>
+                </a:solidFill>
+                <a:latin typeface="Calibri" pitchFamily="34" charset="0"/>
+                <a:ea typeface="Calibri" pitchFamily="34" charset="-122"/>
+                <a:cs typeface="Calibri" pitchFamily="34" charset="-120"/>
+              </a:rPr>
+              <a:t>Можно менять исходники напрямую</a:t>
+            </a:r>
+            <a:endParaRPr lang="en-US" sz="1200" dirty="0"/>
+          </a:p>
+        </p:txBody>
+      </p:sp>
+      <p:sp>
+        <p:nvSpPr>
+          <p:cNvPr id="16" name="Shape 14"/>
+          <p:cNvSpPr/>
+          <p:nvPr/>
+        </p:nvSpPr>
+        <p:spPr>
+          <a:xfrm>
+            <a:off x="640080" y="3465576"/>
+            <a:ext cx="10881360" cy="658368"/>
+          </a:xfrm>
+          <a:prstGeom prst="rect">
+            <a:avLst/>
+          </a:prstGeom>
+          <a:solidFill>
+            <a:srgbClr val="FFFFFF"/>
+          </a:solidFill>
+          <a:ln w="9525">
+            <a:solidFill>
+              <a:srgbClr val="DDE1E7"/>
+            </a:solidFill>
+            <a:prstDash val="solid"/>
+          </a:ln>
+        </p:spPr>
+      </p:sp>
+      <p:sp>
+        <p:nvSpPr>
+          <p:cNvPr id="17" name="Text 15"/>
+          <p:cNvSpPr txBox="1"/>
+          <p:nvPr/>
+        </p:nvSpPr>
+        <p:spPr>
+          <a:xfrm>
+            <a:off x="822960" y="3465576"/>
+            <a:ext cx="2743200" cy="658368"/>
+          </a:xfrm>
+          <a:prstGeom prst="rect">
+            <a:avLst/>
+          </a:prstGeom>
+          <a:noFill/>
+          <a:ln/>
+        </p:spPr>
+        <p:txBody>
+          <a:bodyPr wrap="square" lIns="0" tIns="0" rIns="0" bIns="0" rtlCol="0" anchor="ctr"/>
+          <a:lstStyle/>
+          <a:p>
+            <a:pPr indent="0" marL="0">
+              <a:lnSpc>
+                <a:spcPct val="110000"/>
+              </a:lnSpc>
+              <a:buNone/>
+            </a:pPr>
+            <a:r>
+              <a:rPr lang="en-US" sz="1250" b="1" dirty="0">
+                <a:solidFill>
+                  <a:srgbClr val="1C2333"/>
+                </a:solidFill>
+                <a:latin typeface="Cambria" pitchFamily="34" charset="0"/>
+                <a:ea typeface="Cambria" pitchFamily="34" charset="-122"/>
+                <a:cs typeface="Cambria" pitchFamily="34" charset="-120"/>
+              </a:rPr>
+              <a:t>Базовая разметка</a:t>
+            </a:r>
+            <a:endParaRPr lang="en-US" sz="1250" dirty="0"/>
+          </a:p>
+        </p:txBody>
+      </p:sp>
+      <p:sp>
+        <p:nvSpPr>
+          <p:cNvPr id="18" name="Text 16"/>
+          <p:cNvSpPr txBox="1"/>
+          <p:nvPr/>
+        </p:nvSpPr>
+        <p:spPr>
+          <a:xfrm>
+            <a:off x="3794760" y="3465576"/>
+            <a:ext cx="3657600" cy="658368"/>
+          </a:xfrm>
+          <a:prstGeom prst="rect">
+            <a:avLst/>
+          </a:prstGeom>
+          <a:noFill/>
+          <a:ln/>
+        </p:spPr>
+        <p:txBody>
+          <a:bodyPr wrap="square" lIns="0" tIns="0" rIns="0" bIns="0" rtlCol="0" anchor="ctr"/>
+          <a:lstStyle/>
+          <a:p>
+            <a:pPr indent="0" marL="0">
+              <a:lnSpc>
+                <a:spcPct val="110000"/>
+              </a:lnSpc>
+              <a:buNone/>
+            </a:pPr>
+            <a:r>
+              <a:rPr lang="en-US" sz="1200" dirty="0">
+                <a:solidFill>
+                  <a:srgbClr val="6B7280"/>
+                </a:solidFill>
+                <a:latin typeface="Calibri" pitchFamily="34" charset="0"/>
+                <a:ea typeface="Calibri" pitchFamily="34" charset="-122"/>
+                <a:cs typeface="Calibri" pitchFamily="34" charset="-120"/>
+              </a:rPr>
+              <a:t>$490 / место, разовая покупка</a:t>
+            </a:r>
+            <a:endParaRPr lang="en-US" sz="1200" dirty="0"/>
+          </a:p>
+        </p:txBody>
+      </p:sp>
+      <p:sp>
+        <p:nvSpPr>
+          <p:cNvPr id="19" name="Text 17"/>
+          <p:cNvSpPr txBox="1"/>
+          <p:nvPr/>
+        </p:nvSpPr>
+        <p:spPr>
+          <a:xfrm>
+            <a:off x="7726680" y="3465576"/>
+            <a:ext cx="3657600" cy="658368"/>
+          </a:xfrm>
+          <a:prstGeom prst="rect">
+            <a:avLst/>
+          </a:prstGeom>
+          <a:noFill/>
+          <a:ln/>
+        </p:spPr>
+        <p:txBody>
+          <a:bodyPr wrap="square" lIns="0" tIns="0" rIns="0" bIns="0" rtlCol="0" anchor="ctr"/>
+          <a:lstStyle/>
+          <a:p>
+            <a:pPr indent="0" marL="0">
+              <a:lnSpc>
+                <a:spcPct val="110000"/>
+              </a:lnSpc>
+              <a:buNone/>
+            </a:pPr>
+            <a:r>
+              <a:rPr lang="en-US" sz="1200" dirty="0">
+                <a:solidFill>
+                  <a:srgbClr val="1C2333"/>
+                </a:solidFill>
+                <a:latin typeface="Calibri" pitchFamily="34" charset="0"/>
+                <a:ea typeface="Calibri" pitchFamily="34" charset="-122"/>
+                <a:cs typeface="Calibri" pitchFamily="34" charset="-120"/>
+              </a:rPr>
+              <a:t>Бесплатно (Apache 2.0), self-host</a:t>
+            </a:r>
+            <a:endParaRPr lang="en-US" sz="1200" dirty="0"/>
+          </a:p>
+        </p:txBody>
+      </p:sp>
+      <p:sp>
+        <p:nvSpPr>
+          <p:cNvPr id="20" name="Shape 18"/>
+          <p:cNvSpPr/>
+          <p:nvPr/>
+        </p:nvSpPr>
+        <p:spPr>
+          <a:xfrm>
+            <a:off x="640080" y="4123944"/>
+            <a:ext cx="10881360" cy="658368"/>
+          </a:xfrm>
+          <a:prstGeom prst="rect">
+            <a:avLst/>
+          </a:prstGeom>
+          <a:solidFill>
+            <a:srgbClr val="ECEEF1"/>
+          </a:solidFill>
+          <a:ln w="9525">
+            <a:solidFill>
+              <a:srgbClr val="DDE1E7"/>
+            </a:solidFill>
+            <a:prstDash val="solid"/>
+          </a:ln>
+        </p:spPr>
+      </p:sp>
+      <p:sp>
+        <p:nvSpPr>
+          <p:cNvPr id="21" name="Text 19"/>
+          <p:cNvSpPr txBox="1"/>
+          <p:nvPr/>
+        </p:nvSpPr>
+        <p:spPr>
+          <a:xfrm>
+            <a:off x="822960" y="4123944"/>
+            <a:ext cx="2743200" cy="658368"/>
+          </a:xfrm>
+          <a:prstGeom prst="rect">
+            <a:avLst/>
+          </a:prstGeom>
+          <a:noFill/>
+          <a:ln/>
+        </p:spPr>
+        <p:txBody>
+          <a:bodyPr wrap="square" lIns="0" tIns="0" rIns="0" bIns="0" rtlCol="0" anchor="ctr"/>
+          <a:lstStyle/>
+          <a:p>
+            <a:pPr indent="0" marL="0">
+              <a:lnSpc>
+                <a:spcPct val="110000"/>
+              </a:lnSpc>
+              <a:buNone/>
+            </a:pPr>
+            <a:r>
+              <a:rPr lang="en-US" sz="1250" b="1" dirty="0">
+                <a:solidFill>
+                  <a:srgbClr val="1C2333"/>
+                </a:solidFill>
+                <a:latin typeface="Cambria" pitchFamily="34" charset="0"/>
+                <a:ea typeface="Cambria" pitchFamily="34" charset="-122"/>
+                <a:cs typeface="Cambria" pitchFamily="34" charset="-120"/>
+              </a:rPr>
+              <a:t>Роли и ревью (как на вашем скрине)</a:t>
+            </a:r>
+            <a:endParaRPr lang="en-US" sz="1250" dirty="0"/>
+          </a:p>
+        </p:txBody>
+      </p:sp>
+      <p:sp>
+        <p:nvSpPr>
+          <p:cNvPr id="22" name="Text 20"/>
+          <p:cNvSpPr txBox="1"/>
+          <p:nvPr/>
+        </p:nvSpPr>
+        <p:spPr>
+          <a:xfrm>
+            <a:off x="3794760" y="4123944"/>
+            <a:ext cx="3657600" cy="658368"/>
+          </a:xfrm>
+          <a:prstGeom prst="rect">
+            <a:avLst/>
+          </a:prstGeom>
+          <a:noFill/>
+          <a:ln/>
+        </p:spPr>
+        <p:txBody>
+          <a:bodyPr wrap="square" lIns="0" tIns="0" rIns="0" bIns="0" rtlCol="0" anchor="ctr"/>
+          <a:lstStyle/>
+          <a:p>
+            <a:pPr indent="0" marL="0">
+              <a:lnSpc>
+                <a:spcPct val="110000"/>
+              </a:lnSpc>
+              <a:buNone/>
+            </a:pPr>
+            <a:r>
+              <a:rPr lang="en-US" sz="1200" dirty="0">
+                <a:solidFill>
+                  <a:srgbClr val="6B7280"/>
+                </a:solidFill>
+                <a:latin typeface="Calibri" pitchFamily="34" charset="0"/>
+                <a:ea typeface="Calibri" pitchFamily="34" charset="-122"/>
+                <a:cs typeface="Calibri" pitchFamily="34" charset="-120"/>
+              </a:rPr>
+              <a:t>Входит в лицензию</a:t>
+            </a:r>
+            <a:endParaRPr lang="en-US" sz="1200" dirty="0"/>
+          </a:p>
+        </p:txBody>
+      </p:sp>
+      <p:sp>
+        <p:nvSpPr>
+          <p:cNvPr id="23" name="Text 21"/>
+          <p:cNvSpPr txBox="1"/>
+          <p:nvPr/>
+        </p:nvSpPr>
+        <p:spPr>
+          <a:xfrm>
+            <a:off x="7726680" y="4123944"/>
+            <a:ext cx="3657600" cy="658368"/>
+          </a:xfrm>
+          <a:prstGeom prst="rect">
+            <a:avLst/>
+          </a:prstGeom>
+          <a:noFill/>
+          <a:ln/>
+        </p:spPr>
+        <p:txBody>
+          <a:bodyPr wrap="square" lIns="0" tIns="0" rIns="0" bIns="0" rtlCol="0" anchor="ctr"/>
+          <a:lstStyle/>
+          <a:p>
+            <a:pPr indent="0" marL="0">
+              <a:lnSpc>
+                <a:spcPct val="110000"/>
+              </a:lnSpc>
+              <a:buNone/>
+            </a:pPr>
+            <a:r>
+              <a:rPr lang="en-US" sz="1200" dirty="0">
+                <a:solidFill>
+                  <a:srgbClr val="1C2333"/>
+                </a:solidFill>
+                <a:latin typeface="Calibri" pitchFamily="34" charset="0"/>
+                <a:ea typeface="Calibri" pitchFamily="34" charset="-122"/>
+                <a:cs typeface="Calibri" pitchFamily="34" charset="-120"/>
+              </a:rPr>
+              <a:t>Только в Enterprise — цена по запросу</a:t>
+            </a:r>
+            <a:endParaRPr lang="en-US" sz="1200" dirty="0"/>
+          </a:p>
+        </p:txBody>
+      </p:sp>
+      <p:sp>
+        <p:nvSpPr>
+          <p:cNvPr id="24" name="Shape 22"/>
+          <p:cNvSpPr/>
+          <p:nvPr/>
+        </p:nvSpPr>
+        <p:spPr>
+          <a:xfrm>
+            <a:off x="640080" y="4782312"/>
+            <a:ext cx="10881360" cy="658368"/>
+          </a:xfrm>
+          <a:prstGeom prst="rect">
+            <a:avLst/>
+          </a:prstGeom>
+          <a:solidFill>
+            <a:srgbClr val="FFFFFF"/>
+          </a:solidFill>
+          <a:ln w="9525">
+            <a:solidFill>
+              <a:srgbClr val="DDE1E7"/>
+            </a:solidFill>
+            <a:prstDash val="solid"/>
+          </a:ln>
+        </p:spPr>
+      </p:sp>
+      <p:sp>
+        <p:nvSpPr>
+          <p:cNvPr id="25" name="Text 23"/>
+          <p:cNvSpPr txBox="1"/>
+          <p:nvPr/>
+        </p:nvSpPr>
+        <p:spPr>
+          <a:xfrm>
+            <a:off x="822960" y="4782312"/>
+            <a:ext cx="2743200" cy="658368"/>
+          </a:xfrm>
+          <a:prstGeom prst="rect">
+            <a:avLst/>
+          </a:prstGeom>
+          <a:noFill/>
+          <a:ln/>
+        </p:spPr>
+        <p:txBody>
+          <a:bodyPr wrap="square" lIns="0" tIns="0" rIns="0" bIns="0" rtlCol="0" anchor="ctr"/>
+          <a:lstStyle/>
+          <a:p>
+            <a:pPr indent="0" marL="0">
+              <a:lnSpc>
+                <a:spcPct val="110000"/>
+              </a:lnSpc>
+              <a:buNone/>
+            </a:pPr>
+            <a:r>
+              <a:rPr lang="en-US" sz="1250" b="1" dirty="0">
+                <a:solidFill>
+                  <a:srgbClr val="1C2333"/>
+                </a:solidFill>
+                <a:latin typeface="Cambria" pitchFamily="34" charset="0"/>
+                <a:ea typeface="Cambria" pitchFamily="34" charset="-122"/>
+                <a:cs typeface="Cambria" pitchFamily="34" charset="-120"/>
+              </a:rPr>
+              <a:t>Аудио + транскрипция</a:t>
+            </a:r>
+            <a:endParaRPr lang="en-US" sz="1250" dirty="0"/>
+          </a:p>
+        </p:txBody>
+      </p:sp>
+      <p:sp>
+        <p:nvSpPr>
+          <p:cNvPr id="26" name="Text 24"/>
+          <p:cNvSpPr txBox="1"/>
+          <p:nvPr/>
+        </p:nvSpPr>
+        <p:spPr>
+          <a:xfrm>
+            <a:off x="3794760" y="4782312"/>
+            <a:ext cx="3657600" cy="658368"/>
+          </a:xfrm>
+          <a:prstGeom prst="rect">
+            <a:avLst/>
+          </a:prstGeom>
+          <a:noFill/>
+          <a:ln/>
+        </p:spPr>
+        <p:txBody>
+          <a:bodyPr wrap="square" lIns="0" tIns="0" rIns="0" bIns="0" rtlCol="0" anchor="ctr"/>
+          <a:lstStyle/>
+          <a:p>
+            <a:pPr indent="0" marL="0">
+              <a:lnSpc>
+                <a:spcPct val="110000"/>
+              </a:lnSpc>
+              <a:buNone/>
+            </a:pPr>
+            <a:r>
+              <a:rPr lang="en-US" sz="1200" dirty="0">
+                <a:solidFill>
+                  <a:srgbClr val="6B7280"/>
+                </a:solidFill>
+                <a:latin typeface="Calibri" pitchFamily="34" charset="0"/>
+                <a:ea typeface="Calibri" pitchFamily="34" charset="-122"/>
+                <a:cs typeface="Calibri" pitchFamily="34" charset="-120"/>
+              </a:rPr>
+              <a:t>Есть (может требовать плагин)</a:t>
+            </a:r>
+            <a:endParaRPr lang="en-US" sz="1200" dirty="0"/>
+          </a:p>
+        </p:txBody>
+      </p:sp>
+      <p:sp>
+        <p:nvSpPr>
+          <p:cNvPr id="27" name="Text 25"/>
+          <p:cNvSpPr txBox="1"/>
+          <p:nvPr/>
+        </p:nvSpPr>
+        <p:spPr>
+          <a:xfrm>
+            <a:off x="7726680" y="4782312"/>
+            <a:ext cx="3657600" cy="658368"/>
+          </a:xfrm>
+          <a:prstGeom prst="rect">
+            <a:avLst/>
+          </a:prstGeom>
+          <a:noFill/>
+          <a:ln/>
+        </p:spPr>
+        <p:txBody>
+          <a:bodyPr wrap="square" lIns="0" tIns="0" rIns="0" bIns="0" rtlCol="0" anchor="ctr"/>
+          <a:lstStyle/>
+          <a:p>
+            <a:pPr indent="0" marL="0">
+              <a:lnSpc>
+                <a:spcPct val="110000"/>
+              </a:lnSpc>
+              <a:buNone/>
+            </a:pPr>
+            <a:r>
+              <a:rPr lang="en-US" sz="1200" dirty="0">
+                <a:solidFill>
+                  <a:srgbClr val="1C2333"/>
+                </a:solidFill>
+                <a:latin typeface="Calibri" pitchFamily="34" charset="0"/>
+                <a:ea typeface="Calibri" pitchFamily="34" charset="-122"/>
+                <a:cs typeface="Calibri" pitchFamily="34" charset="-120"/>
+              </a:rPr>
+              <a:t>Готовый шаблон из коробки</a:t>
+            </a:r>
+            <a:endParaRPr lang="en-US" sz="1200" dirty="0"/>
+          </a:p>
+        </p:txBody>
+      </p:sp>
+      <p:sp>
+        <p:nvSpPr>
+          <p:cNvPr id="28" name="Text 26"/>
+          <p:cNvSpPr txBox="1"/>
+          <p:nvPr/>
+        </p:nvSpPr>
+        <p:spPr>
+          <a:xfrm>
+            <a:off x="640080" y="5623560"/>
+            <a:ext cx="10881360" cy="640080"/>
+          </a:xfrm>
+          <a:prstGeom prst="rect">
+            <a:avLst/>
+          </a:prstGeom>
+          <a:noFill/>
+          <a:ln/>
+        </p:spPr>
+        <p:txBody>
+          <a:bodyPr wrap="square" lIns="0" tIns="0" rIns="0" bIns="0" rtlCol="0" anchor="ctr"/>
+          <a:lstStyle/>
+          <a:p>
+            <a:pPr indent="0" marL="0">
+              <a:lnSpc>
+                <a:spcPct val="125000"/>
+              </a:lnSpc>
+              <a:buNone/>
+            </a:pPr>
+            <a:r>
+              <a:rPr lang="en-US" sz="1200" i="1" dirty="0">
+                <a:solidFill>
+                  <a:srgbClr val="6B7280"/>
+                </a:solidFill>
+                <a:latin typeface="Calibri" pitchFamily="34" charset="0"/>
+                <a:ea typeface="Calibri" pitchFamily="34" charset="-122"/>
+                <a:cs typeface="Calibri" pitchFamily="34" charset="-120"/>
+              </a:rPr>
+              <a:t>Роли/ревью, которые уже есть у нас сегодня, — платная часть в обеих системах. Честное сравнение: не «Prodigy $490 vs Label Studio бесплатно», а лицензия Prodigy vs цена Enterprise Label Studio по запросу — плюс стоимость миграции данных и переобучения команды.</a:t>
+            </a:r>
+            <a:endParaRPr lang="en-US" sz="1200" dirty="0"/>
+          </a:p>
+        </p:txBody>
+      </p:sp>
+      <p:sp>
+        <p:nvSpPr>
+          <p:cNvPr id="29" name="Text 27"/>
+          <p:cNvSpPr txBox="1"/>
+          <p:nvPr/>
+        </p:nvSpPr>
+        <p:spPr>
+          <a:xfrm>
+            <a:off x="502920" y="6446520"/>
+            <a:ext cx="2743200" cy="274320"/>
+          </a:xfrm>
+          <a:prstGeom prst="rect">
+            <a:avLst/>
+          </a:prstGeom>
+          <a:noFill/>
+          <a:ln/>
+        </p:spPr>
+        <p:txBody>
+          <a:bodyPr wrap="square" lIns="0" tIns="0" rIns="0" bIns="0" rtlCol="0" anchor="ctr"/>
+          <a:lstStyle/>
+          <a:p>
+            <a:pPr indent="0" marL="0">
+              <a:buNone/>
+            </a:pPr>
+            <a:r>
+              <a:rPr lang="en-US" sz="1050" b="1" dirty="0">
+                <a:solidFill>
+                  <a:srgbClr val="1C2333"/>
+                </a:solidFill>
+                <a:latin typeface="Cambria" pitchFamily="34" charset="0"/>
+                <a:ea typeface="Cambria" pitchFamily="34" charset="-122"/>
+                <a:cs typeface="Cambria" pitchFamily="34" charset="-120"/>
+              </a:rPr>
+              <a:t>Kaspi </a:t>
+            </a:r>
+            <a:pPr indent="0" marL="0">
+              <a:buNone/>
+            </a:pPr>
+            <a:r>
+              <a:rPr lang="en-US" sz="1050" b="1" dirty="0">
+                <a:solidFill>
+                  <a:srgbClr val="F14635"/>
+                </a:solidFill>
+                <a:latin typeface="Cambria" pitchFamily="34" charset="0"/>
+                <a:ea typeface="Cambria" pitchFamily="34" charset="-122"/>
+                <a:cs typeface="Cambria" pitchFamily="34" charset="-120"/>
+              </a:rPr>
+              <a:t>Markup</a:t>
+            </a:r>
+            <a:endParaRPr lang="en-US" sz="1050" dirty="0"/>
+          </a:p>
+        </p:txBody>
+      </p:sp>
+      <p:sp>
+        <p:nvSpPr>
+          <p:cNvPr id="30" name="Text 28"/>
+          <p:cNvSpPr txBox="1"/>
+          <p:nvPr/>
+        </p:nvSpPr>
+        <p:spPr>
+          <a:xfrm>
+            <a:off x="11551615" y="6446520"/>
+            <a:ext cx="457200" cy="274320"/>
+          </a:xfrm>
+          <a:prstGeom prst="rect">
+            <a:avLst/>
+          </a:prstGeom>
+          <a:noFill/>
+          <a:ln/>
+        </p:spPr>
+        <p:txBody>
+          <a:bodyPr wrap="square" lIns="0" tIns="0" rIns="0" bIns="0" rtlCol="0" anchor="ctr"/>
+          <a:lstStyle/>
+          <a:p>
+            <a:pPr algn="r" indent="0" marL="0">
+              <a:buNone/>
+            </a:pPr>
+            <a:r>
+              <a:rPr lang="en-US" sz="1000" dirty="0">
+                <a:solidFill>
+                  <a:srgbClr val="6B7280"/>
+                </a:solidFill>
+                <a:latin typeface="Calibri" pitchFamily="34" charset="0"/>
+                <a:ea typeface="Calibri" pitchFamily="34" charset="-122"/>
+                <a:cs typeface="Calibri" pitchFamily="34" charset="-120"/>
+              </a:rPr>
+              <a:t>08</a:t>
+            </a:r>
+            <a:endParaRPr lang="en-US" sz="1000" dirty="0"/>
+          </a:p>
+        </p:txBody>
+      </p:sp>
+    </p:spTree>
+  </p:cSld>
+  <p:clrMapOvr>
+    <a:masterClrMapping/>
+  </p:clrMapOvr>
+</p:sld>
+</file>
+
+<file path=ppt/slides/slide9.xml><?xml version="1.0" encoding="utf-8"?>
+<p:sld xmlns:a="http://schemas.openxmlformats.org/drawingml/2006/main" xmlns:r="http://schemas.openxmlformats.org/officeDocument/2006/relationships" xmlns:p="http://schemas.openxmlformats.org/presentationml/2006/main">
+  <p:cSld name="Slide 9">
     <p:bg>
       <p:bgPr>
         <a:solidFill>
@@ -6477,7 +7129,7 @@
                 <a:ea typeface="Cambria" pitchFamily="34" charset="-122"/>
                 <a:cs typeface="Cambria" pitchFamily="34" charset="-120"/>
               </a:rPr>
-              <a:t>Четыре пункта к обсуждению</a:t>
+              <a:t>Пять пунктов к обсуждению</a:t>
             </a:r>
             <a:endParaRPr lang="en-US" sz="3400" dirty="0"/>
           </a:p>
@@ -6491,8 +7143,8 @@
         </p:nvSpPr>
         <p:spPr>
           <a:xfrm>
-            <a:off x="822960" y="2697480"/>
-            <a:ext cx="402336" cy="402336"/>
+            <a:off x="822960" y="2423160"/>
+            <a:ext cx="384048" cy="384048"/>
           </a:xfrm>
           <a:prstGeom prst="ellipse">
             <a:avLst/>
@@ -6511,8 +7163,8 @@
         </p:nvSpPr>
         <p:spPr>
           <a:xfrm>
-            <a:off x="822960" y="2697480"/>
-            <a:ext cx="402336" cy="402336"/>
+            <a:off x="822960" y="2423160"/>
+            <a:ext cx="384048" cy="384048"/>
           </a:xfrm>
           <a:prstGeom prst="rect">
             <a:avLst/>
@@ -6550,24 +7202,24 @@
         </p:nvSpPr>
         <p:spPr>
           <a:xfrm>
-            <a:off x="1417320" y="2651760"/>
-            <a:ext cx="8961120" cy="365760"/>
-          </a:xfrm>
-          <a:prstGeom prst="rect">
-            <a:avLst/>
-          </a:prstGeom>
-          <a:noFill/>
-          <a:ln/>
-        </p:spPr>
-        <p:txBody>
-          <a:bodyPr wrap="square" lIns="0" tIns="0" rIns="0" bIns="0" rtlCol="0" anchor="ctr"/>
-          <a:lstStyle/>
-          <a:p>
-            <a:pPr indent="0" marL="0">
-              <a:buNone/>
-            </a:pPr>
-            <a:r>
-              <a:rPr lang="en-US" sz="1700" b="1" dirty="0">
+            <a:off x="1371600" y="2377440"/>
+            <a:ext cx="9052560" cy="347472"/>
+          </a:xfrm>
+          <a:prstGeom prst="rect">
+            <a:avLst/>
+          </a:prstGeom>
+          <a:noFill/>
+          <a:ln/>
+        </p:spPr>
+        <p:txBody>
+          <a:bodyPr wrap="square" lIns="0" tIns="0" rIns="0" bIns="0" rtlCol="0" anchor="ctr"/>
+          <a:lstStyle/>
+          <a:p>
+            <a:pPr indent="0" marL="0">
+              <a:buNone/>
+            </a:pPr>
+            <a:r>
+              <a:rPr lang="en-US" sz="1600" b="1" dirty="0">
                 <a:solidFill>
                   <a:srgbClr val="FFFFFF"/>
                 </a:solidFill>
@@ -6577,7 +7229,7 @@
               </a:rPr>
               <a:t>Буфер слов</a:t>
             </a:r>
-            <a:endParaRPr lang="en-US" sz="1700" dirty="0"/>
+            <a:endParaRPr lang="en-US" sz="1600" dirty="0"/>
           </a:p>
         </p:txBody>
       </p:sp>
@@ -6589,24 +7241,24 @@
         </p:nvSpPr>
         <p:spPr>
           <a:xfrm>
-            <a:off x="1417320" y="3044952"/>
-            <a:ext cx="8961120" cy="411480"/>
-          </a:xfrm>
-          <a:prstGeom prst="rect">
-            <a:avLst/>
-          </a:prstGeom>
-          <a:noFill/>
-          <a:ln/>
-        </p:spPr>
-        <p:txBody>
-          <a:bodyPr wrap="square" lIns="0" tIns="0" rIns="0" bIns="0" rtlCol="0" anchor="ctr"/>
-          <a:lstStyle/>
-          <a:p>
-            <a:pPr indent="0" marL="0">
-              <a:buNone/>
-            </a:pPr>
-            <a:r>
-              <a:rPr lang="en-US" sz="1250" dirty="0">
+            <a:off x="1371600" y="2734056"/>
+            <a:ext cx="9052560" cy="365760"/>
+          </a:xfrm>
+          <a:prstGeom prst="rect">
+            <a:avLst/>
+          </a:prstGeom>
+          <a:noFill/>
+          <a:ln/>
+        </p:spPr>
+        <p:txBody>
+          <a:bodyPr wrap="square" lIns="0" tIns="0" rIns="0" bIns="0" rtlCol="0" anchor="ctr"/>
+          <a:lstStyle/>
+          <a:p>
+            <a:pPr indent="0" marL="0">
+              <a:buNone/>
+            </a:pPr>
+            <a:r>
+              <a:rPr lang="en-US" sz="1200" dirty="0">
                 <a:solidFill>
                   <a:srgbClr val="C7CDD9"/>
                 </a:solidFill>
@@ -6616,7 +7268,7 @@
               </a:rPr>
               <a:t>Жизненно необходим — экономит время на каждой из тысяч задач.</a:t>
             </a:r>
-            <a:endParaRPr lang="en-US" sz="1250" dirty="0"/>
+            <a:endParaRPr lang="en-US" sz="1200" dirty="0"/>
           </a:p>
         </p:txBody>
       </p:sp>
@@ -6628,8 +7280,8 @@
         </p:nvSpPr>
         <p:spPr>
           <a:xfrm>
-            <a:off x="822960" y="3474720"/>
-            <a:ext cx="402336" cy="402336"/>
+            <a:off x="822960" y="3118104"/>
+            <a:ext cx="384048" cy="384048"/>
           </a:xfrm>
           <a:prstGeom prst="ellipse">
             <a:avLst/>
@@ -6648,8 +7300,8 @@
         </p:nvSpPr>
         <p:spPr>
           <a:xfrm>
-            <a:off x="822960" y="3474720"/>
-            <a:ext cx="402336" cy="402336"/>
+            <a:off x="822960" y="3118104"/>
+            <a:ext cx="384048" cy="384048"/>
           </a:xfrm>
           <a:prstGeom prst="rect">
             <a:avLst/>
@@ -6687,24 +7339,24 @@
         </p:nvSpPr>
         <p:spPr>
           <a:xfrm>
-            <a:off x="1417320" y="3429000"/>
-            <a:ext cx="8961120" cy="365760"/>
-          </a:xfrm>
-          <a:prstGeom prst="rect">
-            <a:avLst/>
-          </a:prstGeom>
-          <a:noFill/>
-          <a:ln/>
-        </p:spPr>
-        <p:txBody>
-          <a:bodyPr wrap="square" lIns="0" tIns="0" rIns="0" bIns="0" rtlCol="0" anchor="ctr"/>
-          <a:lstStyle/>
-          <a:p>
-            <a:pPr indent="0" marL="0">
-              <a:buNone/>
-            </a:pPr>
-            <a:r>
-              <a:rPr lang="en-US" sz="1700" b="1" dirty="0">
+            <a:off x="1371600" y="3072384"/>
+            <a:ext cx="9052560" cy="347472"/>
+          </a:xfrm>
+          <a:prstGeom prst="rect">
+            <a:avLst/>
+          </a:prstGeom>
+          <a:noFill/>
+          <a:ln/>
+        </p:spPr>
+        <p:txBody>
+          <a:bodyPr wrap="square" lIns="0" tIns="0" rIns="0" bIns="0" rtlCol="0" anchor="ctr"/>
+          <a:lstStyle/>
+          <a:p>
+            <a:pPr indent="0" marL="0">
+              <a:buNone/>
+            </a:pPr>
+            <a:r>
+              <a:rPr lang="en-US" sz="1600" b="1" dirty="0">
                 <a:solidFill>
                   <a:srgbClr val="FFFFFF"/>
                 </a:solidFill>
@@ -6714,7 +7366,7 @@
               </a:rPr>
               <a:t>Точная настройка плеера</a:t>
             </a:r>
-            <a:endParaRPr lang="en-US" sz="1700" dirty="0"/>
+            <a:endParaRPr lang="en-US" sz="1600" dirty="0"/>
           </a:p>
         </p:txBody>
       </p:sp>
@@ -6726,24 +7378,24 @@
         </p:nvSpPr>
         <p:spPr>
           <a:xfrm>
-            <a:off x="1417320" y="3822192"/>
-            <a:ext cx="8961120" cy="411480"/>
-          </a:xfrm>
-          <a:prstGeom prst="rect">
-            <a:avLst/>
-          </a:prstGeom>
-          <a:noFill/>
-          <a:ln/>
-        </p:spPr>
-        <p:txBody>
-          <a:bodyPr wrap="square" lIns="0" tIns="0" rIns="0" bIns="0" rtlCol="0" anchor="ctr"/>
-          <a:lstStyle/>
-          <a:p>
-            <a:pPr indent="0" marL="0">
-              <a:buNone/>
-            </a:pPr>
-            <a:r>
-              <a:rPr lang="en-US" sz="1250" dirty="0">
+            <a:off x="1371600" y="3429000"/>
+            <a:ext cx="9052560" cy="365760"/>
+          </a:xfrm>
+          <a:prstGeom prst="rect">
+            <a:avLst/>
+          </a:prstGeom>
+          <a:noFill/>
+          <a:ln/>
+        </p:spPr>
+        <p:txBody>
+          <a:bodyPr wrap="square" lIns="0" tIns="0" rIns="0" bIns="0" rtlCol="0" anchor="ctr"/>
+          <a:lstStyle/>
+          <a:p>
+            <a:pPr indent="0" marL="0">
+              <a:buNone/>
+            </a:pPr>
+            <a:r>
+              <a:rPr lang="en-US" sz="1200" dirty="0">
                 <a:solidFill>
                   <a:srgbClr val="C7CDD9"/>
                 </a:solidFill>
@@ -6753,7 +7405,7 @@
               </a:rPr>
               <a:t>Скорость и громкость отдельно, шаг 1%, повтор в 3 режимах.</a:t>
             </a:r>
-            <a:endParaRPr lang="en-US" sz="1250" dirty="0"/>
+            <a:endParaRPr lang="en-US" sz="1200" dirty="0"/>
           </a:p>
         </p:txBody>
       </p:sp>
@@ -6765,8 +7417,8 @@
         </p:nvSpPr>
         <p:spPr>
           <a:xfrm>
-            <a:off x="822960" y="4251960"/>
-            <a:ext cx="402336" cy="402336"/>
+            <a:off x="822960" y="3813048"/>
+            <a:ext cx="384048" cy="384048"/>
           </a:xfrm>
           <a:prstGeom prst="ellipse">
             <a:avLst/>
@@ -6785,8 +7437,8 @@
         </p:nvSpPr>
         <p:spPr>
           <a:xfrm>
-            <a:off x="822960" y="4251960"/>
-            <a:ext cx="402336" cy="402336"/>
+            <a:off x="822960" y="3813048"/>
+            <a:ext cx="384048" cy="384048"/>
           </a:xfrm>
           <a:prstGeom prst="rect">
             <a:avLst/>
@@ -6824,24 +7476,24 @@
         </p:nvSpPr>
         <p:spPr>
           <a:xfrm>
-            <a:off x="1417320" y="4206240"/>
-            <a:ext cx="8961120" cy="365760"/>
-          </a:xfrm>
-          <a:prstGeom prst="rect">
-            <a:avLst/>
-          </a:prstGeom>
-          <a:noFill/>
-          <a:ln/>
-        </p:spPr>
-        <p:txBody>
-          <a:bodyPr wrap="square" lIns="0" tIns="0" rIns="0" bIns="0" rtlCol="0" anchor="ctr"/>
-          <a:lstStyle/>
-          <a:p>
-            <a:pPr indent="0" marL="0">
-              <a:buNone/>
-            </a:pPr>
-            <a:r>
-              <a:rPr lang="en-US" sz="1700" b="1" dirty="0">
+            <a:off x="1371600" y="3767328"/>
+            <a:ext cx="9052560" cy="347472"/>
+          </a:xfrm>
+          <a:prstGeom prst="rect">
+            <a:avLst/>
+          </a:prstGeom>
+          <a:noFill/>
+          <a:ln/>
+        </p:spPr>
+        <p:txBody>
+          <a:bodyPr wrap="square" lIns="0" tIns="0" rIns="0" bIns="0" rtlCol="0" anchor="ctr"/>
+          <a:lstStyle/>
+          <a:p>
+            <a:pPr indent="0" marL="0">
+              <a:buNone/>
+            </a:pPr>
+            <a:r>
+              <a:rPr lang="en-US" sz="1600" b="1" dirty="0">
                 <a:solidFill>
                   <a:srgbClr val="FFFFFF"/>
                 </a:solidFill>
@@ -6851,7 +7503,7 @@
               </a:rPr>
               <a:t>Аналитика WER/CER</a:t>
             </a:r>
-            <a:endParaRPr lang="en-US" sz="1700" dirty="0"/>
+            <a:endParaRPr lang="en-US" sz="1600" dirty="0"/>
           </a:p>
         </p:txBody>
       </p:sp>
@@ -6863,24 +7515,24 @@
         </p:nvSpPr>
         <p:spPr>
           <a:xfrm>
-            <a:off x="1417320" y="4599432"/>
-            <a:ext cx="8961120" cy="411480"/>
-          </a:xfrm>
-          <a:prstGeom prst="rect">
-            <a:avLst/>
-          </a:prstGeom>
-          <a:noFill/>
-          <a:ln/>
-        </p:spPr>
-        <p:txBody>
-          <a:bodyPr wrap="square" lIns="0" tIns="0" rIns="0" bIns="0" rtlCol="0" anchor="ctr"/>
-          <a:lstStyle/>
-          <a:p>
-            <a:pPr indent="0" marL="0">
-              <a:buNone/>
-            </a:pPr>
-            <a:r>
-              <a:rPr lang="en-US" sz="1250" dirty="0">
+            <a:off x="1371600" y="4123944"/>
+            <a:ext cx="9052560" cy="365760"/>
+          </a:xfrm>
+          <a:prstGeom prst="rect">
+            <a:avLst/>
+          </a:prstGeom>
+          <a:noFill/>
+          <a:ln/>
+        </p:spPr>
+        <p:txBody>
+          <a:bodyPr wrap="square" lIns="0" tIns="0" rIns="0" bIns="0" rtlCol="0" anchor="ctr"/>
+          <a:lstStyle/>
+          <a:p>
+            <a:pPr indent="0" marL="0">
+              <a:buNone/>
+            </a:pPr>
+            <a:r>
+              <a:rPr lang="en-US" sz="1200" dirty="0">
                 <a:solidFill>
                   <a:srgbClr val="C7CDD9"/>
                 </a:solidFill>
@@ -6890,7 +7542,7 @@
               </a:rPr>
               <a:t>Готовый дашборд и среднее по проекту — без ручного подсчёта.</a:t>
             </a:r>
-            <a:endParaRPr lang="en-US" sz="1250" dirty="0"/>
+            <a:endParaRPr lang="en-US" sz="1200" dirty="0"/>
           </a:p>
         </p:txBody>
       </p:sp>
@@ -6902,8 +7554,8 @@
         </p:nvSpPr>
         <p:spPr>
           <a:xfrm>
-            <a:off x="822960" y="5029200"/>
-            <a:ext cx="402336" cy="402336"/>
+            <a:off x="822960" y="4507992"/>
+            <a:ext cx="384048" cy="384048"/>
           </a:xfrm>
           <a:prstGeom prst="ellipse">
             <a:avLst/>
@@ -6922,8 +7574,8 @@
         </p:nvSpPr>
         <p:spPr>
           <a:xfrm>
-            <a:off x="822960" y="5029200"/>
-            <a:ext cx="402336" cy="402336"/>
+            <a:off x="822960" y="4507992"/>
+            <a:ext cx="384048" cy="384048"/>
           </a:xfrm>
           <a:prstGeom prst="rect">
             <a:avLst/>
@@ -6961,24 +7613,24 @@
         </p:nvSpPr>
         <p:spPr>
           <a:xfrm>
-            <a:off x="1417320" y="4983480"/>
-            <a:ext cx="8961120" cy="365760"/>
-          </a:xfrm>
-          <a:prstGeom prst="rect">
-            <a:avLst/>
-          </a:prstGeom>
-          <a:noFill/>
-          <a:ln/>
-        </p:spPr>
-        <p:txBody>
-          <a:bodyPr wrap="square" lIns="0" tIns="0" rIns="0" bIns="0" rtlCol="0" anchor="ctr"/>
-          <a:lstStyle/>
-          <a:p>
-            <a:pPr indent="0" marL="0">
-              <a:buNone/>
-            </a:pPr>
-            <a:r>
-              <a:rPr lang="en-US" sz="1700" b="1" dirty="0">
+            <a:off x="1371600" y="4462272"/>
+            <a:ext cx="9052560" cy="347472"/>
+          </a:xfrm>
+          <a:prstGeom prst="rect">
+            <a:avLst/>
+          </a:prstGeom>
+          <a:noFill/>
+          <a:ln/>
+        </p:spPr>
+        <p:txBody>
+          <a:bodyPr wrap="square" lIns="0" tIns="0" rIns="0" bIns="0" rtlCol="0" anchor="ctr"/>
+          <a:lstStyle/>
+          <a:p>
+            <a:pPr indent="0" marL="0">
+              <a:buNone/>
+            </a:pPr>
+            <a:r>
+              <a:rPr lang="en-US" sz="1600" b="1" dirty="0">
                 <a:solidFill>
                   <a:srgbClr val="FFFFFF"/>
                 </a:solidFill>
@@ -6986,9 +7638,9 @@
                 <a:ea typeface="Cambria" pitchFamily="34" charset="-122"/>
                 <a:cs typeface="Cambria" pitchFamily="34" charset="-120"/>
               </a:rPr>
-              <a:t>Label Studio — параллельная оценка</a:t>
-            </a:r>
-            <a:endParaRPr lang="en-US" sz="1700" dirty="0"/>
+              <a:t>Сводная аналитика и начало/окончание</a:t>
+            </a:r>
+            <a:endParaRPr lang="en-US" sz="1600" dirty="0"/>
           </a:p>
         </p:txBody>
       </p:sp>
@@ -7000,24 +7652,24 @@
         </p:nvSpPr>
         <p:spPr>
           <a:xfrm>
-            <a:off x="1417320" y="5376672"/>
-            <a:ext cx="8961120" cy="411480"/>
-          </a:xfrm>
-          <a:prstGeom prst="rect">
-            <a:avLst/>
-          </a:prstGeom>
-          <a:noFill/>
-          <a:ln/>
-        </p:spPr>
-        <p:txBody>
-          <a:bodyPr wrap="square" lIns="0" tIns="0" rIns="0" bIns="0" rtlCol="0" anchor="ctr"/>
-          <a:lstStyle/>
-          <a:p>
-            <a:pPr indent="0" marL="0">
-              <a:buNone/>
-            </a:pPr>
-            <a:r>
-              <a:rPr lang="en-US" sz="1250" dirty="0">
+            <a:off x="1371600" y="4818888"/>
+            <a:ext cx="9052560" cy="365760"/>
+          </a:xfrm>
+          <a:prstGeom prst="rect">
+            <a:avLst/>
+          </a:prstGeom>
+          <a:noFill/>
+          <a:ln/>
+        </p:spPr>
+        <p:txBody>
+          <a:bodyPr wrap="square" lIns="0" tIns="0" rIns="0" bIns="0" rtlCol="0" anchor="ctr"/>
+          <a:lstStyle/>
+          <a:p>
+            <a:pPr indent="0" marL="0">
+              <a:buNone/>
+            </a:pPr>
+            <a:r>
+              <a:rPr lang="en-US" sz="1200" dirty="0">
                 <a:solidFill>
                   <a:srgbClr val="C7CDD9"/>
                 </a:solidFill>
@@ -7025,77 +7677,175 @@
                 <a:ea typeface="Calibri" pitchFamily="34" charset="-122"/>
                 <a:cs typeface="Calibri" pitchFamily="34" charset="-120"/>
               </a:rPr>
-              <a:t>Не блокирует остальное: смотрим цену Enterprise и объём миграции отдельно.</a:t>
-            </a:r>
-            <a:endParaRPr lang="en-US" sz="1250" dirty="0"/>
-          </a:p>
-        </p:txBody>
-      </p:sp>
-      <p:sp>
-        <p:nvSpPr>
-          <p:cNvPr id="21" name="Text 19"/>
-          <p:cNvSpPr txBox="1"/>
-          <p:nvPr/>
-        </p:nvSpPr>
-        <p:spPr>
-          <a:xfrm>
-            <a:off x="822960" y="5943600"/>
-            <a:ext cx="7315200" cy="365760"/>
-          </a:xfrm>
-          <a:prstGeom prst="rect">
-            <a:avLst/>
-          </a:prstGeom>
-          <a:noFill/>
-          <a:ln/>
-        </p:spPr>
-        <p:txBody>
-          <a:bodyPr wrap="square" lIns="0" tIns="0" rIns="0" bIns="0" rtlCol="0" anchor="ctr"/>
-          <a:lstStyle/>
-          <a:p>
-            <a:pPr indent="0" marL="0">
-              <a:buNone/>
-            </a:pPr>
-            <a:r>
-              <a:rPr lang="en-US" sz="1300" i="1" dirty="0">
-                <a:solidFill>
-                  <a:srgbClr val="6B7280"/>
+              <a:t>Внутренние vs внешние, шкала работы команды за день — уже собрано.</a:t>
+            </a:r>
+            <a:endParaRPr lang="en-US" sz="1200" dirty="0"/>
+          </a:p>
+        </p:txBody>
+      </p:sp>
+      <p:sp>
+        <p:nvSpPr>
+          <p:cNvPr id="21" name="Shape 19"/>
+          <p:cNvSpPr/>
+          <p:nvPr/>
+        </p:nvSpPr>
+        <p:spPr>
+          <a:xfrm>
+            <a:off x="822960" y="5202936"/>
+            <a:ext cx="384048" cy="384048"/>
+          </a:xfrm>
+          <a:prstGeom prst="ellipse">
+            <a:avLst/>
+          </a:prstGeom>
+          <a:solidFill>
+            <a:srgbClr val="F14635"/>
+          </a:solidFill>
+          <a:ln/>
+        </p:spPr>
+      </p:sp>
+      <p:sp>
+        <p:nvSpPr>
+          <p:cNvPr id="22" name="Text 20"/>
+          <p:cNvSpPr txBox="1"/>
+          <p:nvPr/>
+        </p:nvSpPr>
+        <p:spPr>
+          <a:xfrm>
+            <a:off x="822960" y="5202936"/>
+            <a:ext cx="384048" cy="384048"/>
+          </a:xfrm>
+          <a:prstGeom prst="rect">
+            <a:avLst/>
+          </a:prstGeom>
+          <a:noFill/>
+          <a:ln/>
+        </p:spPr>
+        <p:txBody>
+          <a:bodyPr wrap="square" lIns="0" tIns="0" rIns="0" bIns="0" rtlCol="0" anchor="ctr"/>
+          <a:lstStyle/>
+          <a:p>
+            <a:pPr algn="ctr" indent="0" marL="0">
+              <a:buNone/>
+            </a:pPr>
+            <a:r>
+              <a:rPr lang="en-US" sz="1800" b="1" dirty="0">
+                <a:solidFill>
+                  <a:srgbClr val="FFFFFF"/>
+                </a:solidFill>
+                <a:latin typeface="Cambria" pitchFamily="34" charset="0"/>
+                <a:ea typeface="Cambria" pitchFamily="34" charset="-122"/>
+                <a:cs typeface="Cambria" pitchFamily="34" charset="-120"/>
+              </a:rPr>
+              <a:t>5</a:t>
+            </a:r>
+            <a:endParaRPr lang="en-US" sz="1800" dirty="0"/>
+          </a:p>
+        </p:txBody>
+      </p:sp>
+      <p:sp>
+        <p:nvSpPr>
+          <p:cNvPr id="23" name="Text 21"/>
+          <p:cNvSpPr txBox="1"/>
+          <p:nvPr/>
+        </p:nvSpPr>
+        <p:spPr>
+          <a:xfrm>
+            <a:off x="1371600" y="5157216"/>
+            <a:ext cx="9052560" cy="347472"/>
+          </a:xfrm>
+          <a:prstGeom prst="rect">
+            <a:avLst/>
+          </a:prstGeom>
+          <a:noFill/>
+          <a:ln/>
+        </p:spPr>
+        <p:txBody>
+          <a:bodyPr wrap="square" lIns="0" tIns="0" rIns="0" bIns="0" rtlCol="0" anchor="ctr"/>
+          <a:lstStyle/>
+          <a:p>
+            <a:pPr indent="0" marL="0">
+              <a:buNone/>
+            </a:pPr>
+            <a:r>
+              <a:rPr lang="en-US" sz="1600" b="1" dirty="0">
+                <a:solidFill>
+                  <a:srgbClr val="FFFFFF"/>
+                </a:solidFill>
+                <a:latin typeface="Cambria" pitchFamily="34" charset="0"/>
+                <a:ea typeface="Cambria" pitchFamily="34" charset="-122"/>
+                <a:cs typeface="Cambria" pitchFamily="34" charset="-120"/>
+              </a:rPr>
+              <a:t>Label Studio — параллельная оценка</a:t>
+            </a:r>
+            <a:endParaRPr lang="en-US" sz="1600" dirty="0"/>
+          </a:p>
+        </p:txBody>
+      </p:sp>
+      <p:sp>
+        <p:nvSpPr>
+          <p:cNvPr id="24" name="Text 22"/>
+          <p:cNvSpPr txBox="1"/>
+          <p:nvPr/>
+        </p:nvSpPr>
+        <p:spPr>
+          <a:xfrm>
+            <a:off x="1371600" y="5513832"/>
+            <a:ext cx="9052560" cy="365760"/>
+          </a:xfrm>
+          <a:prstGeom prst="rect">
+            <a:avLst/>
+          </a:prstGeom>
+          <a:noFill/>
+          <a:ln/>
+        </p:spPr>
+        <p:txBody>
+          <a:bodyPr wrap="square" lIns="0" tIns="0" rIns="0" bIns="0" rtlCol="0" anchor="ctr"/>
+          <a:lstStyle/>
+          <a:p>
+            <a:pPr indent="0" marL="0">
+              <a:buNone/>
+            </a:pPr>
+            <a:r>
+              <a:rPr lang="en-US" sz="1200" dirty="0">
+                <a:solidFill>
+                  <a:srgbClr val="C7CDD9"/>
                 </a:solidFill>
                 <a:latin typeface="Calibri" pitchFamily="34" charset="0"/>
                 <a:ea typeface="Calibri" pitchFamily="34" charset="-122"/>
                 <a:cs typeface="Calibri" pitchFamily="34" charset="-120"/>
               </a:rPr>
-              <a:t>Обсудим на встрече</a:t>
-            </a:r>
-            <a:endParaRPr lang="en-US" sz="1300" dirty="0"/>
-          </a:p>
-        </p:txBody>
-      </p:sp>
-      <p:sp>
-        <p:nvSpPr>
-          <p:cNvPr id="22" name="Text 20"/>
-          <p:cNvSpPr txBox="1"/>
-          <p:nvPr/>
-        </p:nvSpPr>
-        <p:spPr>
-          <a:xfrm>
-            <a:off x="11551615" y="6446520"/>
-            <a:ext cx="457200" cy="274320"/>
-          </a:xfrm>
-          <a:prstGeom prst="rect">
-            <a:avLst/>
-          </a:prstGeom>
-          <a:noFill/>
-          <a:ln/>
-        </p:spPr>
-        <p:txBody>
-          <a:bodyPr wrap="square" lIns="0" tIns="0" rIns="0" bIns="0" rtlCol="0" anchor="ctr"/>
-          <a:lstStyle/>
-          <a:p>
-            <a:pPr algn="r" indent="0" marL="0">
-              <a:buNone/>
-            </a:pPr>
-            <a:r>
-              <a:rPr lang="en-US" sz="1000" dirty="0">
+              <a:t>Не блокирует остальное: смотрим цену Enterprise и объём миграции отдельно.</a:t>
+            </a:r>
+            <a:endParaRPr lang="en-US" sz="1200" dirty="0"/>
+          </a:p>
+        </p:txBody>
+      </p:sp>
+      <p:sp>
+        <p:nvSpPr>
+          <p:cNvPr id="25" name="Text 23"/>
+          <p:cNvSpPr txBox="1"/>
+          <p:nvPr/>
+        </p:nvSpPr>
+        <p:spPr>
+          <a:xfrm>
+            <a:off x="822960" y="6080760"/>
+            <a:ext cx="7315200" cy="365760"/>
+          </a:xfrm>
+          <a:prstGeom prst="rect">
+            <a:avLst/>
+          </a:prstGeom>
+          <a:noFill/>
+          <a:ln/>
+        </p:spPr>
+        <p:txBody>
+          <a:bodyPr wrap="square" lIns="0" tIns="0" rIns="0" bIns="0" rtlCol="0" anchor="ctr"/>
+          <a:lstStyle/>
+          <a:p>
+            <a:pPr indent="0" marL="0">
+              <a:buNone/>
+            </a:pPr>
+            <a:r>
+              <a:rPr lang="en-US" sz="1300" i="1" dirty="0">
                 <a:solidFill>
                   <a:srgbClr val="6B7280"/>
                 </a:solidFill>
@@ -7103,7 +7853,46 @@
                 <a:ea typeface="Calibri" pitchFamily="34" charset="-122"/>
                 <a:cs typeface="Calibri" pitchFamily="34" charset="-120"/>
               </a:rPr>
-              <a:t>08</a:t>
+              <a:t>Обсудим на встрече</a:t>
+            </a:r>
+            <a:endParaRPr lang="en-US" sz="1300" dirty="0"/>
+          </a:p>
+        </p:txBody>
+      </p:sp>
+      <p:sp>
+        <p:nvSpPr>
+          <p:cNvPr id="26" name="Text 24"/>
+          <p:cNvSpPr txBox="1"/>
+          <p:nvPr/>
+        </p:nvSpPr>
+        <p:spPr>
+          <a:xfrm>
+            <a:off x="11551615" y="6446520"/>
+            <a:ext cx="457200" cy="274320"/>
+          </a:xfrm>
+          <a:prstGeom prst="rect">
+            <a:avLst/>
+          </a:prstGeom>
+          <a:noFill/>
+          <a:ln/>
+        </p:spPr>
+        <p:txBody>
+          <a:bodyPr wrap="square" lIns="0" tIns="0" rIns="0" bIns="0" rtlCol="0" anchor="ctr"/>
+          <a:lstStyle/>
+          <a:p>
+            <a:pPr algn="r" indent="0" marL="0">
+              <a:buNone/>
+            </a:pPr>
+            <a:r>
+              <a:rPr lang="en-US" sz="1000" dirty="0">
+                <a:solidFill>
+                  <a:srgbClr val="6B7280"/>
+                </a:solidFill>
+                <a:latin typeface="Calibri" pitchFamily="34" charset="0"/>
+                <a:ea typeface="Calibri" pitchFamily="34" charset="-122"/>
+                <a:cs typeface="Calibri" pitchFamily="34" charset="-120"/>
+              </a:rPr>
+              <a:t>09</a:t>
             </a:r>
             <a:endParaRPr lang="en-US" sz="1000" dirty="0"/>
           </a:p>

</xml_diff>